<commit_message>
Docs v1.1: add admin portal and changes since v1.0
- Functional Specification: new Chapter 13 (admin portal, statement, bulk ops, run-accrual, partition fix, sandbox URLs)
- Technical Design Document: new Chapter 15 (lending-admin-service design, API, security, deployment, V9, scripts, URLs)
- Architecture deck: 3 new slides (admin portal, screens/login, sandbox URLs and changes)
- Root README.md and CHANGELOG.md; CLOUD_DEPLOYMENT.md section 13 (Render sandbox)

Co-Authored-By: Claude Sonnet 5.5 <noreply@anthropic.com>
Claude-Session: https://claude.ai/code/session_011Ly3TH5YUMArmTYksVUGUE
</commit_message>
<xml_diff>
--- a/docs/Lending-Platform-Architecture.pptx
+++ b/docs/Lending-Platform-Architecture.pptx
@@ -19,9 +19,12 @@
     <p:sldId id="267" r:id="rId13"/>
     <p:sldId id="268" r:id="rId14"/>
     <p:sldId id="269" r:id="rId15"/>
+    <p:sldId id="270" r:id="rId16"/>
+    <p:sldId id="271" r:id="rId17"/>
+    <p:sldId id="272" r:id="rId18"/>
   </p:sldIdLst>
   <p:notesMasterIdLst>
-    <p:notesMasterId r:id="rId16"/>
+    <p:notesMasterId r:id="rId19"/>
   </p:notesMasterIdLst>
   <p:sldSz cx="12192000" cy="6858000"/>
   <p:notesSz cx="6858000" cy="12192000"/>
@@ -120,25 +123,25 @@
   <p:extLst>
     <p:ext uri="{521415D9-36F7-43E2-AB2F-B90AF26B5E84}">
       <p14:sectionLst xmlns:p14="http://schemas.microsoft.com/office/powerpoint/2010/main">
-        <p14:section name="Overview" id="{62572a4c-ab72-592f-23e9-0d5392e04b40}">
+        <p14:section name="Overview" id="{01dbbad1-870d-0c9d-1075-751aacd08455}">
           <p14:sldIdLst>
             <p14:sldId id="256"/>
             <p14:sldId id="257"/>
           </p14:sldIdLst>
         </p14:section>
-        <p14:section name="Architecture" id="{cf56abd9-5e8c-f070-5b9b-95780898c674}">
+        <p14:section name="Architecture" id="{22bd3dad-cacc-4422-c56b-6a2efb2c63d7}">
           <p14:sldIdLst>
             <p14:sldId id="258"/>
             <p14:sldId id="259"/>
           </p14:sldIdLst>
         </p14:section>
-        <p14:section name="Data model" id="{aed94b65-eb80-0801-316c-c7bb7432e718}">
+        <p14:section name="Data model" id="{2ce81484-b38b-a088-1de2-9a3707ebccdf}">
           <p14:sldIdLst>
             <p14:sldId id="260"/>
             <p14:sldId id="261"/>
           </p14:sldIdLst>
         </p14:section>
-        <p14:section name="Flows" id="{636642e2-8131-4d3c-9fc5-63ccccb49412}">
+        <p14:section name="Flows" id="{67806dcc-00bd-36e8-67fb-dbf6ad549151}">
           <p14:sldIdLst>
             <p14:sldId id="262"/>
             <p14:sldId id="263"/>
@@ -146,16 +149,23 @@
             <p14:sldId id="265"/>
           </p14:sldIdLst>
         </p14:section>
-        <p14:section name="Lifecycle" id="{9707137d-4485-7117-d653-23a76ff75712}">
+        <p14:section name="Lifecycle" id="{4e938ae8-0ef7-10ff-abff-a8b42297007b}">
           <p14:sldIdLst>
             <p14:sldId id="266"/>
             <p14:sldId id="267"/>
           </p14:sldIdLst>
         </p14:section>
-        <p14:section name="Reference" id="{6119cc9e-3cba-bd8b-bfb1-3d18793eea5f}">
+        <p14:section name="Admin portal" id="{06c620dd-cf29-46b3-a4a9-6260e0a3cd9a}">
           <p14:sldIdLst>
             <p14:sldId id="268"/>
             <p14:sldId id="269"/>
+            <p14:sldId id="270"/>
+          </p14:sldIdLst>
+        </p14:section>
+        <p14:section name="Reference" id="{43441d28-e7b4-6c4e-1203-4e7bcd536994}">
+          <p14:sldIdLst>
+            <p14:sldId id="271"/>
+            <p14:sldId id="272"/>
           </p14:sldIdLst>
         </p14:section>
       </p14:sectionLst>
@@ -914,7 +924,7 @@
           <a:p>
             <a:r>
               <a:rPr lang="en-US" dirty="0"/>
-              <a:t>Reference table. Paths are relative to /api/v1.</a:t>
+              <a:t>New microservice. Spring Boot API plus React UI in one container. It connects to the same PostgreSQL database with a read-only session, because the Lending REST API has no list, search or portfolio endpoints.</a:t>
             </a:r>
             <a:endParaRPr lang="en-US" dirty="0"/>
           </a:p>
@@ -1002,7 +1012,7 @@
           <a:p>
             <a:r>
               <a:rPr lang="en-US" dirty="0"/>
-              <a:t>Be candid: the REST lifecycle is real; the batch job bodies, ledger integration, Kafka and authentication are still to do.</a:t>
+              <a:t>Screens map to the requirements: account inquiry, amortization, accrual and payment details, upcoming payments, plus overdue, ledger outbox and batch monitoring.</a:t>
             </a:r>
             <a:endParaRPr lang="en-US" dirty="0"/>
           </a:p>
@@ -1026,6 +1036,270 @@
             <a:fld id="{F7021451-1387-4CA6-816F-3879F97B5CBC}" type="slidenum">
               <a:rPr lang="en-US"/>
               <a:t>14</a:t>
+            </a:fld>
+            <a:endParaRPr lang="en-US"/>
+          </a:p>
+        </p:txBody>
+      </p:sp>
+    </p:spTree>
+    <p:extLst>
+      <p:ext uri="{BB962C8B-B14F-4D97-AF65-F5344CB8AC3E}">
+        <p14:creationId xmlns:p14="http://schemas.microsoft.com/office/powerpoint/2010/main" val="1024086991"/>
+      </p:ext>
+    </p:extLst>
+  </p:cSld>
+  <p:clrMapOvr>
+    <a:masterClrMapping/>
+  </p:clrMapOvr>
+</p:notes>
+</file>
+
+<file path=ppt/notesSlides/notesSlide15.xml><?xml version="1.0" encoding="utf-8"?>
+<p:notes xmlns:a="http://schemas.openxmlformats.org/drawingml/2006/main" xmlns:r="http://schemas.openxmlformats.org/officeDocument/2006/relationships" xmlns:p="http://schemas.openxmlformats.org/presentationml/2006/main">
+  <p:cSld>
+    <p:spTree>
+      <p:nvGrpSpPr>
+        <p:cNvPr id="1" name=""/>
+        <p:cNvGrpSpPr/>
+        <p:nvPr/>
+      </p:nvGrpSpPr>
+      <p:grpSpPr>
+        <a:xfrm>
+          <a:off x="0" y="0"/>
+          <a:ext cx="0" cy="0"/>
+          <a:chOff x="0" y="0"/>
+          <a:chExt cx="0" cy="0"/>
+        </a:xfrm>
+      </p:grpSpPr>
+      <p:sp>
+        <p:nvSpPr>
+          <p:cNvPr id="2" name="Slide Image Placeholder 1"/>
+          <p:cNvSpPr>
+            <a:spLocks noGrp="1" noRot="1" noChangeAspect="1"/>
+          </p:cNvSpPr>
+          <p:nvPr>
+            <p:ph type="sldImg"/>
+          </p:nvPr>
+        </p:nvSpPr>
+        <p:spPr/>
+      </p:sp>
+      <p:sp>
+        <p:nvSpPr>
+          <p:cNvPr id="3" name="Notes Placeholder 2"/>
+          <p:cNvSpPr>
+            <a:spLocks noGrp="1"/>
+          </p:cNvSpPr>
+          <p:nvPr>
+            <p:ph type="body" idx="1"/>
+          </p:nvPr>
+        </p:nvSpPr>
+        <p:spPr/>
+        <p:txBody>
+          <a:bodyPr/>
+          <a:lstStyle/>
+          <a:p>
+            <a:r>
+              <a:rPr lang="en-US" dirty="0"/>
+              <a:t>The admin portal URL suffix is assigned by Render when the service is first created; copy it from the dashboard.</a:t>
+            </a:r>
+            <a:endParaRPr lang="en-US" dirty="0"/>
+          </a:p>
+        </p:txBody>
+      </p:sp>
+      <p:sp>
+        <p:nvSpPr>
+          <p:cNvPr id="4" name="Slide Number Placeholder 3"/>
+          <p:cNvSpPr>
+            <a:spLocks noGrp="1"/>
+          </p:cNvSpPr>
+          <p:nvPr>
+            <p:ph type="sldNum" sz="quarter" idx="10"/>
+          </p:nvPr>
+        </p:nvSpPr>
+        <p:spPr/>
+        <p:txBody>
+          <a:bodyPr/>
+          <a:lstStyle/>
+          <a:p>
+            <a:fld id="{F7021451-1387-4CA6-816F-3879F97B5CBC}" type="slidenum">
+              <a:rPr lang="en-US"/>
+              <a:t>15</a:t>
+            </a:fld>
+            <a:endParaRPr lang="en-US"/>
+          </a:p>
+        </p:txBody>
+      </p:sp>
+    </p:spTree>
+    <p:extLst>
+      <p:ext uri="{BB962C8B-B14F-4D97-AF65-F5344CB8AC3E}">
+        <p14:creationId xmlns:p14="http://schemas.microsoft.com/office/powerpoint/2010/main" val="1024086991"/>
+      </p:ext>
+    </p:extLst>
+  </p:cSld>
+  <p:clrMapOvr>
+    <a:masterClrMapping/>
+  </p:clrMapOvr>
+</p:notes>
+</file>
+
+<file path=ppt/notesSlides/notesSlide16.xml><?xml version="1.0" encoding="utf-8"?>
+<p:notes xmlns:a="http://schemas.openxmlformats.org/drawingml/2006/main" xmlns:r="http://schemas.openxmlformats.org/officeDocument/2006/relationships" xmlns:p="http://schemas.openxmlformats.org/presentationml/2006/main">
+  <p:cSld>
+    <p:spTree>
+      <p:nvGrpSpPr>
+        <p:cNvPr id="1" name=""/>
+        <p:cNvGrpSpPr/>
+        <p:nvPr/>
+      </p:nvGrpSpPr>
+      <p:grpSpPr>
+        <a:xfrm>
+          <a:off x="0" y="0"/>
+          <a:ext cx="0" cy="0"/>
+          <a:chOff x="0" y="0"/>
+          <a:chExt cx="0" cy="0"/>
+        </a:xfrm>
+      </p:grpSpPr>
+      <p:sp>
+        <p:nvSpPr>
+          <p:cNvPr id="2" name="Slide Image Placeholder 1"/>
+          <p:cNvSpPr>
+            <a:spLocks noGrp="1" noRot="1" noChangeAspect="1"/>
+          </p:cNvSpPr>
+          <p:nvPr>
+            <p:ph type="sldImg"/>
+          </p:nvPr>
+        </p:nvSpPr>
+        <p:spPr/>
+      </p:sp>
+      <p:sp>
+        <p:nvSpPr>
+          <p:cNvPr id="3" name="Notes Placeholder 2"/>
+          <p:cNvSpPr>
+            <a:spLocks noGrp="1"/>
+          </p:cNvSpPr>
+          <p:nvPr>
+            <p:ph type="body" idx="1"/>
+          </p:nvPr>
+        </p:nvSpPr>
+        <p:spPr/>
+        <p:txBody>
+          <a:bodyPr/>
+          <a:lstStyle/>
+          <a:p>
+            <a:r>
+              <a:rPr lang="en-US" dirty="0"/>
+              <a:t>Reference table. Paths are relative to /api/v1.</a:t>
+            </a:r>
+            <a:endParaRPr lang="en-US" dirty="0"/>
+          </a:p>
+        </p:txBody>
+      </p:sp>
+      <p:sp>
+        <p:nvSpPr>
+          <p:cNvPr id="4" name="Slide Number Placeholder 3"/>
+          <p:cNvSpPr>
+            <a:spLocks noGrp="1"/>
+          </p:cNvSpPr>
+          <p:nvPr>
+            <p:ph type="sldNum" sz="quarter" idx="10"/>
+          </p:nvPr>
+        </p:nvSpPr>
+        <p:spPr/>
+        <p:txBody>
+          <a:bodyPr/>
+          <a:lstStyle/>
+          <a:p>
+            <a:fld id="{F7021451-1387-4CA6-816F-3879F97B5CBC}" type="slidenum">
+              <a:rPr lang="en-US"/>
+              <a:t>16</a:t>
+            </a:fld>
+            <a:endParaRPr lang="en-US"/>
+          </a:p>
+        </p:txBody>
+      </p:sp>
+    </p:spTree>
+    <p:extLst>
+      <p:ext uri="{BB962C8B-B14F-4D97-AF65-F5344CB8AC3E}">
+        <p14:creationId xmlns:p14="http://schemas.microsoft.com/office/powerpoint/2010/main" val="1024086991"/>
+      </p:ext>
+    </p:extLst>
+  </p:cSld>
+  <p:clrMapOvr>
+    <a:masterClrMapping/>
+  </p:clrMapOvr>
+</p:notes>
+</file>
+
+<file path=ppt/notesSlides/notesSlide17.xml><?xml version="1.0" encoding="utf-8"?>
+<p:notes xmlns:a="http://schemas.openxmlformats.org/drawingml/2006/main" xmlns:r="http://schemas.openxmlformats.org/officeDocument/2006/relationships" xmlns:p="http://schemas.openxmlformats.org/presentationml/2006/main">
+  <p:cSld>
+    <p:spTree>
+      <p:nvGrpSpPr>
+        <p:cNvPr id="1" name=""/>
+        <p:cNvGrpSpPr/>
+        <p:nvPr/>
+      </p:nvGrpSpPr>
+      <p:grpSpPr>
+        <a:xfrm>
+          <a:off x="0" y="0"/>
+          <a:ext cx="0" cy="0"/>
+          <a:chOff x="0" y="0"/>
+          <a:chExt cx="0" cy="0"/>
+        </a:xfrm>
+      </p:grpSpPr>
+      <p:sp>
+        <p:nvSpPr>
+          <p:cNvPr id="2" name="Slide Image Placeholder 1"/>
+          <p:cNvSpPr>
+            <a:spLocks noGrp="1" noRot="1" noChangeAspect="1"/>
+          </p:cNvSpPr>
+          <p:nvPr>
+            <p:ph type="sldImg"/>
+          </p:nvPr>
+        </p:nvSpPr>
+        <p:spPr/>
+      </p:sp>
+      <p:sp>
+        <p:nvSpPr>
+          <p:cNvPr id="3" name="Notes Placeholder 2"/>
+          <p:cNvSpPr>
+            <a:spLocks noGrp="1"/>
+          </p:cNvSpPr>
+          <p:nvPr>
+            <p:ph type="body" idx="1"/>
+          </p:nvPr>
+        </p:nvSpPr>
+        <p:spPr/>
+        <p:txBody>
+          <a:bodyPr/>
+          <a:lstStyle/>
+          <a:p>
+            <a:r>
+              <a:rPr lang="en-US" dirty="0"/>
+              <a:t>Be candid: the REST lifecycle is real; the batch job bodies, ledger integration, Kafka and authentication are still to do.</a:t>
+            </a:r>
+            <a:endParaRPr lang="en-US" dirty="0"/>
+          </a:p>
+        </p:txBody>
+      </p:sp>
+      <p:sp>
+        <p:nvSpPr>
+          <p:cNvPr id="4" name="Slide Number Placeholder 3"/>
+          <p:cNvSpPr>
+            <a:spLocks noGrp="1"/>
+          </p:cNvSpPr>
+          <p:nvPr>
+            <p:ph type="sldNum" sz="quarter" idx="10"/>
+          </p:nvPr>
+        </p:nvSpPr>
+        <p:spPr/>
+        <p:txBody>
+          <a:bodyPr/>
+          <a:lstStyle/>
+          <a:p>
+            <a:fld id="{F7021451-1387-4CA6-816F-3879F97B5CBC}" type="slidenum">
+              <a:rPr lang="en-US"/>
+              <a:t>17</a:t>
             </a:fld>
             <a:endParaRPr lang="en-US"/>
           </a:p>
@@ -2597,7 +2871,7 @@
                   <a:schemeClr val="accent2"/>
                 </a:solidFill>
               </a:rPr>
-              <a:t>lending-service  |  lending-batch-service  |  PostgreSQL  |  Render sandbox</a:t>
+              <a:t>lending-service  |  lending-batch-service  |  lending-admin-service  |  PostgreSQL  |  Render sandbox</a:t>
             </a:r>
             <a:endParaRPr lang="en-US" sz="1400" dirty="0"/>
           </a:p>
@@ -8000,7 +8274,7 @@
                   <a:schemeClr val="tx2"/>
                 </a:solidFill>
               </a:rPr>
-              <a:t>API catalogue</a:t>
+              <a:t>Admin portal: a separate, read-only service</a:t>
             </a:r>
             <a:endParaRPr lang="en-US" sz="3400" dirty="0"/>
           </a:p>
@@ -8038,7 +8312,831 @@
                   <a:schemeClr val="accent4"/>
                 </a:solidFill>
               </a:rPr>
-              <a:t>Base path /api/v1; lending-service on port 8080, batch admin on lending-batch-service</a:t>
+              <a:t>lending-admin-service reads the Lending database; it never writes and never changes the other services</a:t>
+            </a:r>
+            <a:endParaRPr lang="en-US" sz="1400" dirty="0"/>
+          </a:p>
+        </p:txBody>
+      </p:sp>
+      <p:sp>
+        <p:nvSpPr>
+          <p:cNvPr id="5" name="Text 2"/>
+          <p:cNvSpPr txBox="1"/>
+          <p:nvPr/>
+        </p:nvSpPr>
+        <p:spPr>
+          <a:xfrm>
+            <a:off x="548640" y="2011680"/>
+            <a:ext cx="2011680" cy="914400"/>
+          </a:xfrm>
+          <a:prstGeom prst="roundRect">
+            <a:avLst>
+              <a:gd name="adj" fmla="val 8000"/>
+            </a:avLst>
+          </a:prstGeom>
+          <a:solidFill>
+            <a:schemeClr val="accent4"/>
+          </a:solidFill>
+          <a:ln w="12700">
+            <a:solidFill>
+              <a:schemeClr val="accent4"/>
+            </a:solidFill>
+          </a:ln>
+        </p:spPr>
+        <p:txBody>
+          <a:bodyPr wrap="square" lIns="50800" tIns="50800" rIns="50800" bIns="50800" rtlCol="0" anchor="ctr"/>
+          <a:lstStyle/>
+          <a:p>
+            <a:pPr algn="ctr" indent="0" marL="0">
+              <a:buNone/>
+            </a:pPr>
+            <a:r>
+              <a:rPr lang="en-US" sz="1200" dirty="0">
+                <a:solidFill>
+                  <a:schemeClr val="bg1"/>
+                </a:solidFill>
+              </a:rPr>
+              <a:t>Operations user</a:t>
+            </a:r>
+            <a:endParaRPr lang="en-US" sz="1200" dirty="0"/>
+          </a:p>
+          <a:p>
+            <a:pPr algn="ctr" indent="0" marL="0">
+              <a:buNone/>
+            </a:pPr>
+            <a:r>
+              <a:rPr lang="en-US" sz="1200" dirty="0">
+                <a:solidFill>
+                  <a:schemeClr val="bg1"/>
+                </a:solidFill>
+              </a:rPr>
+              <a:t>Browser</a:t>
+            </a:r>
+            <a:endParaRPr lang="en-US" sz="1200" dirty="0"/>
+          </a:p>
+        </p:txBody>
+      </p:sp>
+      <p:sp>
+        <p:nvSpPr>
+          <p:cNvPr id="6" name="Text 3"/>
+          <p:cNvSpPr txBox="1"/>
+          <p:nvPr/>
+        </p:nvSpPr>
+        <p:spPr>
+          <a:xfrm>
+            <a:off x="3291840" y="1828800"/>
+            <a:ext cx="3108960" cy="1280160"/>
+          </a:xfrm>
+          <a:prstGeom prst="roundRect">
+            <a:avLst>
+              <a:gd name="adj" fmla="val 5714"/>
+            </a:avLst>
+          </a:prstGeom>
+          <a:solidFill>
+            <a:schemeClr val="accent1"/>
+          </a:solidFill>
+          <a:ln w="12700">
+            <a:solidFill>
+              <a:schemeClr val="accent1"/>
+            </a:solidFill>
+          </a:ln>
+        </p:spPr>
+        <p:txBody>
+          <a:bodyPr wrap="square" lIns="50800" tIns="50800" rIns="50800" bIns="50800" rtlCol="0" anchor="ctr"/>
+          <a:lstStyle/>
+          <a:p>
+            <a:pPr algn="ctr" indent="0" marL="0">
+              <a:buNone/>
+            </a:pPr>
+            <a:r>
+              <a:rPr lang="en-US" sz="1400" b="1" dirty="0">
+                <a:solidFill>
+                  <a:schemeClr val="bg1"/>
+                </a:solidFill>
+              </a:rPr>
+              <a:t>lending-admin-service</a:t>
+            </a:r>
+            <a:endParaRPr lang="en-US" sz="1200" dirty="0"/>
+          </a:p>
+          <a:p>
+            <a:pPr algn="ctr" indent="0" marL="0">
+              <a:buNone/>
+            </a:pPr>
+            <a:r>
+              <a:rPr lang="en-US" sz="1200" dirty="0">
+                <a:solidFill>
+                  <a:schemeClr val="bg1"/>
+                </a:solidFill>
+              </a:rPr>
+              <a:t>React UI + Spring Boot API</a:t>
+            </a:r>
+            <a:endParaRPr lang="en-US" sz="1200" dirty="0"/>
+          </a:p>
+          <a:p>
+            <a:pPr algn="ctr" indent="0" marL="0">
+              <a:buNone/>
+            </a:pPr>
+            <a:r>
+              <a:rPr lang="en-US" sz="1100" dirty="0">
+                <a:solidFill>
+                  <a:schemeClr val="bg1"/>
+                </a:solidFill>
+              </a:rPr>
+              <a:t>port 8082  |  HTTP Basic login</a:t>
+            </a:r>
+            <a:endParaRPr lang="en-US" sz="1200" dirty="0"/>
+          </a:p>
+        </p:txBody>
+      </p:sp>
+      <p:sp>
+        <p:nvSpPr>
+          <p:cNvPr id="7" name="Text 4"/>
+          <p:cNvSpPr txBox="1"/>
+          <p:nvPr/>
+        </p:nvSpPr>
+        <p:spPr>
+          <a:xfrm>
+            <a:off x="7223760" y="1828800"/>
+            <a:ext cx="2377440" cy="1280160"/>
+          </a:xfrm>
+          <a:prstGeom prst="roundRect">
+            <a:avLst>
+              <a:gd name="adj" fmla="val 5714"/>
+            </a:avLst>
+          </a:prstGeom>
+          <a:solidFill>
+            <a:schemeClr val="accent2"/>
+          </a:solidFill>
+          <a:ln w="12700">
+            <a:solidFill>
+              <a:schemeClr val="accent2"/>
+            </a:solidFill>
+          </a:ln>
+        </p:spPr>
+        <p:txBody>
+          <a:bodyPr wrap="square" lIns="50800" tIns="50800" rIns="50800" bIns="50800" rtlCol="0" anchor="ctr"/>
+          <a:lstStyle/>
+          <a:p>
+            <a:pPr algn="ctr" indent="0" marL="0">
+              <a:buNone/>
+            </a:pPr>
+            <a:r>
+              <a:rPr lang="en-US" sz="1400" b="1" dirty="0">
+                <a:solidFill>
+                  <a:schemeClr val="tx1"/>
+                </a:solidFill>
+              </a:rPr>
+              <a:t>PostgreSQL "lending"</a:t>
+            </a:r>
+            <a:endParaRPr lang="en-US" sz="1200" dirty="0"/>
+          </a:p>
+          <a:p>
+            <a:pPr algn="ctr" indent="0" marL="0">
+              <a:buNone/>
+            </a:pPr>
+            <a:r>
+              <a:rPr lang="en-US" sz="1200" dirty="0">
+                <a:solidFill>
+                  <a:schemeClr val="tx1"/>
+                </a:solidFill>
+              </a:rPr>
+              <a:t>public + batch schemas</a:t>
+            </a:r>
+            <a:endParaRPr lang="en-US" sz="1200" dirty="0"/>
+          </a:p>
+        </p:txBody>
+      </p:sp>
+      <p:sp>
+        <p:nvSpPr>
+          <p:cNvPr id="8" name="Text 5"/>
+          <p:cNvSpPr txBox="1"/>
+          <p:nvPr/>
+        </p:nvSpPr>
+        <p:spPr>
+          <a:xfrm>
+            <a:off x="3291840" y="3749040"/>
+            <a:ext cx="3108960" cy="822960"/>
+          </a:xfrm>
+          <a:prstGeom prst="roundRect">
+            <a:avLst>
+              <a:gd name="adj" fmla="val 8889"/>
+            </a:avLst>
+          </a:prstGeom>
+          <a:solidFill>
+            <a:schemeClr val="accent4"/>
+          </a:solidFill>
+          <a:ln w="12700">
+            <a:solidFill>
+              <a:schemeClr val="accent4"/>
+            </a:solidFill>
+          </a:ln>
+        </p:spPr>
+        <p:txBody>
+          <a:bodyPr wrap="square" lIns="50800" tIns="50800" rIns="50800" bIns="50800" rtlCol="0" anchor="ctr"/>
+          <a:lstStyle/>
+          <a:p>
+            <a:pPr algn="ctr" indent="0" marL="0">
+              <a:buNone/>
+            </a:pPr>
+            <a:r>
+              <a:rPr lang="en-US" sz="1200" dirty="0">
+                <a:solidFill>
+                  <a:schemeClr val="bg1"/>
+                </a:solidFill>
+              </a:rPr>
+              <a:t>lending-service</a:t>
+            </a:r>
+            <a:endParaRPr lang="en-US" sz="1200" dirty="0"/>
+          </a:p>
+          <a:p>
+            <a:pPr algn="ctr" indent="0" marL="0">
+              <a:buNone/>
+            </a:pPr>
+            <a:r>
+              <a:rPr lang="en-US" sz="1200" dirty="0">
+                <a:solidFill>
+                  <a:schemeClr val="bg1"/>
+                </a:solidFill>
+              </a:rPr>
+              <a:t>(statement PDF only)</a:t>
+            </a:r>
+            <a:endParaRPr lang="en-US" sz="1200" dirty="0"/>
+          </a:p>
+        </p:txBody>
+      </p:sp>
+      <p:sp>
+        <p:nvSpPr>
+          <p:cNvPr id="9" name="Shape 6"/>
+          <p:cNvSpPr/>
+          <p:nvPr/>
+        </p:nvSpPr>
+        <p:spPr>
+          <a:xfrm>
+            <a:off x="2560320" y="2468880"/>
+            <a:ext cx="731520" cy="0"/>
+          </a:xfrm>
+          <a:prstGeom prst="line">
+            <a:avLst/>
+          </a:prstGeom>
+          <a:noFill/>
+          <a:ln w="22225">
+            <a:solidFill>
+              <a:schemeClr val="tx2"/>
+            </a:solidFill>
+            <a:prstDash val="solid"/>
+            <a:tailEnd type="triangle"/>
+          </a:ln>
+        </p:spPr>
+      </p:sp>
+      <p:sp>
+        <p:nvSpPr>
+          <p:cNvPr id="10" name="Text 7"/>
+          <p:cNvSpPr txBox="1"/>
+          <p:nvPr/>
+        </p:nvSpPr>
+        <p:spPr>
+          <a:xfrm>
+            <a:off x="2560320" y="2194560"/>
+            <a:ext cx="731520" cy="228600"/>
+          </a:xfrm>
+          <a:prstGeom prst="rect">
+            <a:avLst/>
+          </a:prstGeom>
+          <a:noFill/>
+          <a:ln/>
+        </p:spPr>
+        <p:txBody>
+          <a:bodyPr wrap="square" lIns="0" tIns="0" rIns="0" bIns="0" rtlCol="0" anchor="ctr"/>
+          <a:lstStyle/>
+          <a:p>
+            <a:pPr algn="ctr" indent="0" marL="0">
+              <a:buNone/>
+            </a:pPr>
+            <a:r>
+              <a:rPr lang="en-US" sz="1000" i="1" dirty="0">
+                <a:solidFill>
+                  <a:schemeClr val="accent4"/>
+                </a:solidFill>
+              </a:rPr>
+              <a:t>HTTPS</a:t>
+            </a:r>
+            <a:endParaRPr lang="en-US" sz="1000" dirty="0"/>
+          </a:p>
+        </p:txBody>
+      </p:sp>
+      <p:sp>
+        <p:nvSpPr>
+          <p:cNvPr id="11" name="Shape 8"/>
+          <p:cNvSpPr/>
+          <p:nvPr/>
+        </p:nvSpPr>
+        <p:spPr>
+          <a:xfrm>
+            <a:off x="6400800" y="2468880"/>
+            <a:ext cx="822960" cy="0"/>
+          </a:xfrm>
+          <a:prstGeom prst="line">
+            <a:avLst/>
+          </a:prstGeom>
+          <a:noFill/>
+          <a:ln w="22225">
+            <a:solidFill>
+              <a:schemeClr val="tx2"/>
+            </a:solidFill>
+            <a:prstDash val="solid"/>
+            <a:tailEnd type="triangle"/>
+          </a:ln>
+        </p:spPr>
+      </p:sp>
+      <p:sp>
+        <p:nvSpPr>
+          <p:cNvPr id="12" name="Text 9"/>
+          <p:cNvSpPr txBox="1"/>
+          <p:nvPr/>
+        </p:nvSpPr>
+        <p:spPr>
+          <a:xfrm>
+            <a:off x="6355080" y="2194560"/>
+            <a:ext cx="914400" cy="228600"/>
+          </a:xfrm>
+          <a:prstGeom prst="rect">
+            <a:avLst/>
+          </a:prstGeom>
+          <a:noFill/>
+          <a:ln/>
+        </p:spPr>
+        <p:txBody>
+          <a:bodyPr wrap="square" lIns="0" tIns="0" rIns="0" bIns="0" rtlCol="0" anchor="ctr"/>
+          <a:lstStyle/>
+          <a:p>
+            <a:pPr algn="ctr" indent="0" marL="0">
+              <a:buNone/>
+            </a:pPr>
+            <a:r>
+              <a:rPr lang="en-US" sz="1000" i="1" dirty="0">
+                <a:solidFill>
+                  <a:schemeClr val="accent4"/>
+                </a:solidFill>
+              </a:rPr>
+              <a:t>SELECT only</a:t>
+            </a:r>
+            <a:endParaRPr lang="en-US" sz="1000" dirty="0"/>
+          </a:p>
+        </p:txBody>
+      </p:sp>
+      <p:sp>
+        <p:nvSpPr>
+          <p:cNvPr id="13" name="Shape 10"/>
+          <p:cNvSpPr/>
+          <p:nvPr/>
+        </p:nvSpPr>
+        <p:spPr>
+          <a:xfrm>
+            <a:off x="4846320" y="3108960"/>
+            <a:ext cx="0" cy="640080"/>
+          </a:xfrm>
+          <a:prstGeom prst="line">
+            <a:avLst/>
+          </a:prstGeom>
+          <a:noFill/>
+          <a:ln w="22225">
+            <a:solidFill>
+              <a:schemeClr val="tx2"/>
+            </a:solidFill>
+            <a:prstDash val="dash"/>
+            <a:tailEnd type="triangle"/>
+          </a:ln>
+        </p:spPr>
+      </p:sp>
+      <p:sp>
+        <p:nvSpPr>
+          <p:cNvPr id="14" name="Text 11"/>
+          <p:cNvSpPr txBox="1"/>
+          <p:nvPr/>
+        </p:nvSpPr>
+        <p:spPr>
+          <a:xfrm>
+            <a:off x="4937760" y="3291840"/>
+            <a:ext cx="1097280" cy="228600"/>
+          </a:xfrm>
+          <a:prstGeom prst="rect">
+            <a:avLst/>
+          </a:prstGeom>
+          <a:noFill/>
+          <a:ln/>
+        </p:spPr>
+        <p:txBody>
+          <a:bodyPr wrap="square" lIns="0" tIns="0" rIns="0" bIns="0" rtlCol="0" anchor="ctr"/>
+          <a:lstStyle/>
+          <a:p>
+            <a:pPr algn="l" indent="0" marL="0">
+              <a:buNone/>
+            </a:pPr>
+            <a:r>
+              <a:rPr lang="en-US" sz="1000" i="1" dirty="0">
+                <a:solidFill>
+                  <a:schemeClr val="accent4"/>
+                </a:solidFill>
+              </a:rPr>
+              <a:t>PDF proxy</a:t>
+            </a:r>
+            <a:endParaRPr lang="en-US" sz="1000" dirty="0"/>
+          </a:p>
+        </p:txBody>
+      </p:sp>
+      <p:sp>
+        <p:nvSpPr>
+          <p:cNvPr id="15" name="Text 12"/>
+          <p:cNvSpPr txBox="1"/>
+          <p:nvPr/>
+        </p:nvSpPr>
+        <p:spPr>
+          <a:xfrm>
+            <a:off x="9875520" y="1783080"/>
+            <a:ext cx="1828800" cy="457200"/>
+          </a:xfrm>
+          <a:prstGeom prst="rect">
+            <a:avLst/>
+          </a:prstGeom>
+          <a:noFill/>
+          <a:ln/>
+        </p:spPr>
+        <p:txBody>
+          <a:bodyPr wrap="square" lIns="0" tIns="0" rIns="0" bIns="0" rtlCol="0" anchor="t"/>
+          <a:lstStyle/>
+          <a:p>
+            <a:pPr indent="0" marL="0">
+              <a:buNone/>
+            </a:pPr>
+            <a:r>
+              <a:rPr lang="en-US" sz="1200" b="1" dirty="0">
+                <a:solidFill>
+                  <a:schemeClr val="tx2"/>
+                </a:solidFill>
+              </a:rPr>
+              <a:t>Why read the database directly</a:t>
+            </a:r>
+            <a:endParaRPr lang="en-US" sz="1200" dirty="0"/>
+          </a:p>
+        </p:txBody>
+      </p:sp>
+      <p:sp>
+        <p:nvSpPr>
+          <p:cNvPr id="16" name="Text 13"/>
+          <p:cNvSpPr txBox="1"/>
+          <p:nvPr/>
+        </p:nvSpPr>
+        <p:spPr>
+          <a:xfrm>
+            <a:off x="9875520" y="2286000"/>
+            <a:ext cx="1737360" cy="1463040"/>
+          </a:xfrm>
+          <a:prstGeom prst="rect">
+            <a:avLst/>
+          </a:prstGeom>
+          <a:noFill/>
+          <a:ln/>
+        </p:spPr>
+        <p:txBody>
+          <a:bodyPr wrap="square" lIns="0" tIns="0" rIns="0" bIns="0" rtlCol="0" anchor="t"/>
+          <a:lstStyle/>
+          <a:p>
+            <a:pPr indent="0" marL="0">
+              <a:buNone/>
+            </a:pPr>
+            <a:r>
+              <a:rPr lang="en-US" sz="1100" dirty="0">
+                <a:solidFill>
+                  <a:schemeClr val="tx1"/>
+                </a:solidFill>
+              </a:rPr>
+              <a:t>The REST API cannot list, search or total up the book. Adding that would change the core service.</a:t>
+            </a:r>
+            <a:endParaRPr lang="en-US" sz="1100" dirty="0"/>
+          </a:p>
+        </p:txBody>
+      </p:sp>
+      <p:sp>
+        <p:nvSpPr>
+          <p:cNvPr id="17" name="Text 14"/>
+          <p:cNvSpPr txBox="1"/>
+          <p:nvPr/>
+        </p:nvSpPr>
+        <p:spPr>
+          <a:xfrm>
+            <a:off x="548640" y="4892040"/>
+            <a:ext cx="3566160" cy="1371600"/>
+          </a:xfrm>
+          <a:prstGeom prst="roundRect">
+            <a:avLst>
+              <a:gd name="adj" fmla="val 5333"/>
+            </a:avLst>
+          </a:prstGeom>
+          <a:solidFill>
+            <a:schemeClr val="accent1">
+              <a:alpha val="10000"/>
+            </a:schemeClr>
+          </a:solidFill>
+          <a:ln w="12700">
+            <a:solidFill>
+              <a:schemeClr val="accent1"/>
+            </a:solidFill>
+          </a:ln>
+        </p:spPr>
+        <p:txBody>
+          <a:bodyPr wrap="square" lIns="101600" tIns="101600" rIns="101600" bIns="101600" rtlCol="0" anchor="t"/>
+          <a:lstStyle/>
+          <a:p>
+            <a:pPr algn="l" indent="0" marL="0">
+              <a:buNone/>
+            </a:pPr>
+            <a:r>
+              <a:rPr lang="en-US" sz="1400" b="1" dirty="0">
+                <a:solidFill>
+                  <a:schemeClr val="tx2"/>
+                </a:solidFill>
+              </a:rPr>
+              <a:t>Read-only by construction</a:t>
+            </a:r>
+            <a:endParaRPr lang="en-US" sz="1200" dirty="0"/>
+          </a:p>
+          <a:p>
+            <a:pPr algn="l" indent="0" marL="0">
+              <a:buNone/>
+            </a:pPr>
+            <a:r>
+              <a:rPr lang="en-US" sz="1200" dirty="0">
+                <a:solidFill>
+                  <a:schemeClr val="tx1"/>
+                </a:solidFill>
+              </a:rPr>
+              <a:t>Hikari read-only pool and SET SESSION ... READ ONLY on every connection. An optional SELECT-only DB role adds a second lock.</a:t>
+            </a:r>
+            <a:endParaRPr lang="en-US" sz="1200" dirty="0"/>
+          </a:p>
+        </p:txBody>
+      </p:sp>
+      <p:sp>
+        <p:nvSpPr>
+          <p:cNvPr id="18" name="Text 15"/>
+          <p:cNvSpPr txBox="1"/>
+          <p:nvPr/>
+        </p:nvSpPr>
+        <p:spPr>
+          <a:xfrm>
+            <a:off x="4297680" y="4892040"/>
+            <a:ext cx="3566160" cy="1371600"/>
+          </a:xfrm>
+          <a:prstGeom prst="roundRect">
+            <a:avLst>
+              <a:gd name="adj" fmla="val 5333"/>
+            </a:avLst>
+          </a:prstGeom>
+          <a:solidFill>
+            <a:schemeClr val="accent1">
+              <a:alpha val="10000"/>
+            </a:schemeClr>
+          </a:solidFill>
+          <a:ln w="12700">
+            <a:solidFill>
+              <a:schemeClr val="accent1"/>
+            </a:solidFill>
+          </a:ln>
+        </p:spPr>
+        <p:txBody>
+          <a:bodyPr wrap="square" lIns="101600" tIns="101600" rIns="101600" bIns="101600" rtlCol="0" anchor="t"/>
+          <a:lstStyle/>
+          <a:p>
+            <a:pPr algn="l" indent="0" marL="0">
+              <a:buNone/>
+            </a:pPr>
+            <a:r>
+              <a:rPr lang="en-US" sz="1400" b="1" dirty="0">
+                <a:solidFill>
+                  <a:schemeClr val="tx2"/>
+                </a:solidFill>
+              </a:rPr>
+              <a:t>Current schedule rule</a:t>
+            </a:r>
+            <a:endParaRPr lang="en-US" sz="1200" dirty="0"/>
+          </a:p>
+          <a:p>
+            <a:pPr algn="l" indent="0" marL="0">
+              <a:buNone/>
+            </a:pPr>
+            <a:r>
+              <a:rPr lang="en-US" sz="1200" dirty="0">
+                <a:solidFill>
+                  <a:schemeClr val="tx1"/>
+                </a:solidFill>
+              </a:rPr>
+              <a:t>A part-payment or rate reset creates a new schedule version; the portal shows the latest per instalment and keeps older versions viewable.</a:t>
+            </a:r>
+            <a:endParaRPr lang="en-US" sz="1200" dirty="0"/>
+          </a:p>
+        </p:txBody>
+      </p:sp>
+      <p:sp>
+        <p:nvSpPr>
+          <p:cNvPr id="19" name="Text 16"/>
+          <p:cNvSpPr txBox="1"/>
+          <p:nvPr/>
+        </p:nvSpPr>
+        <p:spPr>
+          <a:xfrm>
+            <a:off x="8046720" y="4892040"/>
+            <a:ext cx="3566160" cy="1371600"/>
+          </a:xfrm>
+          <a:prstGeom prst="roundRect">
+            <a:avLst>
+              <a:gd name="adj" fmla="val 5333"/>
+            </a:avLst>
+          </a:prstGeom>
+          <a:solidFill>
+            <a:schemeClr val="accent1">
+              <a:alpha val="10000"/>
+            </a:schemeClr>
+          </a:solidFill>
+          <a:ln w="12700">
+            <a:solidFill>
+              <a:schemeClr val="accent1"/>
+            </a:solidFill>
+          </a:ln>
+        </p:spPr>
+        <p:txBody>
+          <a:bodyPr wrap="square" lIns="101600" tIns="101600" rIns="101600" bIns="101600" rtlCol="0" anchor="t"/>
+          <a:lstStyle/>
+          <a:p>
+            <a:pPr algn="l" indent="0" marL="0">
+              <a:buNone/>
+            </a:pPr>
+            <a:r>
+              <a:rPr lang="en-US" sz="1400" b="1" dirty="0">
+                <a:solidFill>
+                  <a:schemeClr val="tx2"/>
+                </a:solidFill>
+              </a:rPr>
+              <a:t>One image, one service</a:t>
+            </a:r>
+            <a:endParaRPr lang="en-US" sz="1200" dirty="0"/>
+          </a:p>
+          <a:p>
+            <a:pPr algn="l" indent="0" marL="0">
+              <a:buNone/>
+            </a:pPr>
+            <a:r>
+              <a:rPr lang="en-US" sz="1200" dirty="0">
+                <a:solidFill>
+                  <a:schemeClr val="tx1"/>
+                </a:solidFill>
+              </a:rPr>
+              <a:t>Node builds the UI, Maven bundles it into the jar, a JRE image runs it. Registered in the root pom, render.yaml and docker-compose.</a:t>
+            </a:r>
+            <a:endParaRPr lang="en-US" sz="1200" dirty="0"/>
+          </a:p>
+        </p:txBody>
+      </p:sp>
+      <p:sp>
+        <p:nvSpPr>
+          <p:cNvPr id="25" name="Slide Number Placeholder 0"/>
+          <p:cNvSpPr>
+            <a:spLocks noGrp="1"/>
+          </p:cNvSpPr>
+          <p:nvPr>
+            <p:ph type="sldNum" sz="quarter" idx="4294967295"/>
+          </p:nvPr>
+        </p:nvSpPr>
+        <p:spPr>
+          <a:xfrm>
+            <a:off x="11064240" y="6446520"/>
+            <a:ext cx="548640" cy="274320"/>
+          </a:xfrm>
+          <a:prstGeom prst="rect">
+            <a:avLst/>
+          </a:prstGeom>
+          <a:extLst>
+            <a:ext uri="{C572A759-6A51-4108-AA02-DFA0A04FC94B}">
+              <ma14:wrappingTextBoxFlag xmlns:ma14="http://schemas.microsoft.com/office/mac/drawingml/2011/main" val="0"/>
+            </a:ext>
+          </a:extLst>
+        </p:spPr>
+        <p:txBody>
+          <a:bodyPr/>
+          <a:lstStyle>
+            <a:lvl1pPr>
+              <a:defRPr sz="1000">
+                <a:solidFill>
+                  <a:schemeClr val="accent4"/>
+                </a:solidFill>
+              </a:defRPr>
+            </a:lvl1pPr>
+          </a:lstStyle>
+          <a:p>
+            <a:pPr algn="r"/>
+            <a:fld id="{F7021451-1387-4CA6-816F-3879F97B5CBC}" type="slidenum">
+              <a:rPr b="0" lang="en-US"/>
+              <a:t>13</a:t>
+            </a:fld>
+            <a:endParaRPr lang="en-US"/>
+          </a:p>
+        </p:txBody>
+      </p:sp>
+    </p:spTree>
+  </p:cSld>
+  <p:clrMapOvr>
+    <a:masterClrMapping/>
+  </p:clrMapOvr>
+</p:sld>
+</file>
+
+<file path=ppt/slides/slide14.xml><?xml version="1.0" encoding="utf-8"?>
+<p:sld xmlns:a="http://schemas.openxmlformats.org/drawingml/2006/main" xmlns:r="http://schemas.openxmlformats.org/officeDocument/2006/relationships" xmlns:p="http://schemas.openxmlformats.org/presentationml/2006/main">
+  <p:cSld name="Slide 14">
+    <p:spTree>
+      <p:nvGrpSpPr>
+        <p:cNvPr id="1" name=""/>
+        <p:cNvGrpSpPr/>
+        <p:nvPr/>
+      </p:nvGrpSpPr>
+      <p:grpSpPr>
+        <a:xfrm>
+          <a:off x="0" y="0"/>
+          <a:ext cx="0" cy="0"/>
+          <a:chOff x="0" y="0"/>
+          <a:chExt cx="0" cy="0"/>
+        </a:xfrm>
+      </p:grpSpPr>
+      <p:sp>
+        <p:nvSpPr>
+          <p:cNvPr id="2" name="Text 2"/>
+          <p:cNvSpPr/>
+          <p:nvPr>
+            <p:ph idx="102" type="title" hasCustomPrompt="1"/>
+          </p:nvPr>
+        </p:nvSpPr>
+        <p:spPr>
+          <a:xfrm>
+            <a:off x="548640" y="274320"/>
+            <a:ext cx="11064240" cy="685800"/>
+          </a:xfrm>
+          <a:prstGeom prst="rect">
+            <a:avLst/>
+          </a:prstGeom>
+          <a:noFill/>
+          <a:ln/>
+        </p:spPr>
+        <p:txBody>
+          <a:bodyPr wrap="square" lIns="0" tIns="0" rIns="0" bIns="0" rtlCol="0" anchor="ctr"/>
+          <a:lstStyle/>
+          <a:p>
+            <a:pPr algn="l" indent="0" marL="0">
+              <a:buNone/>
+            </a:pPr>
+            <a:r>
+              <a:rPr lang="en-US" sz="3400" b="1" dirty="0">
+                <a:solidFill>
+                  <a:schemeClr val="tx2"/>
+                </a:solidFill>
+              </a:rPr>
+              <a:t>What the portal shows</a:t>
+            </a:r>
+            <a:endParaRPr lang="en-US" sz="3400" dirty="0"/>
+          </a:p>
+        </p:txBody>
+      </p:sp>
+      <p:sp>
+        <p:nvSpPr>
+          <p:cNvPr id="3" name="Text 2"/>
+          <p:cNvSpPr/>
+          <p:nvPr>
+            <p:ph idx="103" type="body" hasCustomPrompt="1"/>
+          </p:nvPr>
+        </p:nvSpPr>
+        <p:spPr>
+          <a:xfrm>
+            <a:off x="548640" y="960120"/>
+            <a:ext cx="11064240" cy="365760"/>
+          </a:xfrm>
+          <a:prstGeom prst="rect">
+            <a:avLst/>
+          </a:prstGeom>
+          <a:noFill/>
+          <a:ln/>
+        </p:spPr>
+        <p:txBody>
+          <a:bodyPr wrap="square" lIns="0" tIns="0" rIns="0" bIns="0" rtlCol="0" anchor="t"/>
+          <a:lstStyle/>
+          <a:p>
+            <a:pPr algn="l" indent="0" marL="0">
+              <a:buNone/>
+            </a:pPr>
+            <a:r>
+              <a:rPr lang="en-US" sz="1400" dirty="0">
+                <a:solidFill>
+                  <a:schemeClr val="accent4"/>
+                </a:solidFill>
+              </a:rPr>
+              <a:t>Inquiry on accounts, schedules, accruals, payments and the book as a whole</a:t>
             </a:r>
             <a:endParaRPr lang="en-US" sz="1400" dirty="0"/>
           </a:p>
@@ -8046,7 +9144,2511 @@
       </p:sp>
       <p:graphicFrame>
         <p:nvGraphicFramePr>
-          <p:cNvPr id="14" name="Table 0"/>
+          <p:cNvPr id="15" name="Table 0"/>
+          <p:cNvGraphicFramePr>
+            <a:graphicFrameLocks noGrp="1"/>
+          </p:cNvGraphicFramePr>
+          <p:nvPr>
+            <p:extLst>
+              <p:ext uri="{D42A27DB-BD31-4B8C-83A1-F6EECF244321}">
+                <p14:modId xmlns:p14="http://schemas.microsoft.com/office/powerpoint/2010/main" val="1579011935"/>
+              </p:ext>
+            </p:extLst>
+          </p:nvPr>
+        </p:nvGraphicFramePr>
+        <p:xfrm>
+          <a:off x="548640" y="1463040"/>
+          <a:ext cx="7315200" cy="914400"/>
+        </p:xfrm>
+        <a:graphic>
+          <a:graphicData uri="http://schemas.openxmlformats.org/drawingml/2006/table">
+            <a:tbl>
+              <a:tblPr/>
+              <a:tblGrid>
+                <a:gridCol w="2103120"/>
+                <a:gridCol w="5212080"/>
+              </a:tblGrid>
+              <a:tr h="548640">
+                <a:tc>
+                  <a:txBody>
+                    <a:bodyPr/>
+                    <a:lstStyle/>
+                    <a:p>
+                      <a:pPr indent="0" marL="0">
+                        <a:buNone/>
+                      </a:pPr>
+                      <a:r>
+                        <a:rPr lang="en-US" sz="1200" b="1" dirty="0">
+                          <a:solidFill>
+                            <a:schemeClr val="bg1"/>
+                          </a:solidFill>
+                        </a:rPr>
+                        <a:t>Screen</a:t>
+                      </a:r>
+                      <a:endParaRPr lang="en-US" sz="1200" dirty="0"/>
+                    </a:p>
+                  </a:txBody>
+                  <a:tcPr marL="91440" marR="91440" marT="27432" marB="27432" anchor="ctr">
+                    <a:lnL w="6350" cap="flat" cmpd="sng" algn="ctr">
+                      <a:solidFill>
+                        <a:schemeClr val="bg2"/>
+                      </a:solidFill>
+                      <a:prstDash val="solid"/>
+                      <a:round/>
+                      <a:headEnd type="none" w="med" len="med"/>
+                      <a:tailEnd type="none" w="med" len="med"/>
+                    </a:lnL>
+                    <a:lnR w="6350" cap="flat" cmpd="sng" algn="ctr">
+                      <a:solidFill>
+                        <a:schemeClr val="bg2"/>
+                      </a:solidFill>
+                      <a:prstDash val="solid"/>
+                      <a:round/>
+                      <a:headEnd type="none" w="med" len="med"/>
+                      <a:tailEnd type="none" w="med" len="med"/>
+                    </a:lnR>
+                    <a:lnT w="6350" cap="flat" cmpd="sng" algn="ctr">
+                      <a:solidFill>
+                        <a:schemeClr val="bg2"/>
+                      </a:solidFill>
+                      <a:prstDash val="solid"/>
+                      <a:round/>
+                      <a:headEnd type="none" w="med" len="med"/>
+                      <a:tailEnd type="none" w="med" len="med"/>
+                    </a:lnT>
+                    <a:lnB w="6350" cap="flat" cmpd="sng" algn="ctr">
+                      <a:solidFill>
+                        <a:schemeClr val="bg2"/>
+                      </a:solidFill>
+                      <a:prstDash val="solid"/>
+                      <a:round/>
+                      <a:headEnd type="none" w="med" len="med"/>
+                      <a:tailEnd type="none" w="med" len="med"/>
+                    </a:lnB>
+                    <a:solidFill>
+                      <a:schemeClr val="tx2"/>
+                    </a:solidFill>
+                  </a:tcPr>
+                </a:tc>
+                <a:tc>
+                  <a:txBody>
+                    <a:bodyPr/>
+                    <a:lstStyle/>
+                    <a:p>
+                      <a:pPr indent="0" marL="0">
+                        <a:buNone/>
+                      </a:pPr>
+                      <a:r>
+                        <a:rPr lang="en-US" sz="1200" b="1" dirty="0">
+                          <a:solidFill>
+                            <a:schemeClr val="bg1"/>
+                          </a:solidFill>
+                        </a:rPr>
+                        <a:t>What it gives you</a:t>
+                      </a:r>
+                      <a:endParaRPr lang="en-US" sz="1200" dirty="0"/>
+                    </a:p>
+                  </a:txBody>
+                  <a:tcPr marL="91440" marR="91440" marT="27432" marB="27432" anchor="ctr">
+                    <a:lnL w="6350" cap="flat" cmpd="sng" algn="ctr">
+                      <a:solidFill>
+                        <a:schemeClr val="bg2"/>
+                      </a:solidFill>
+                      <a:prstDash val="solid"/>
+                      <a:round/>
+                      <a:headEnd type="none" w="med" len="med"/>
+                      <a:tailEnd type="none" w="med" len="med"/>
+                    </a:lnL>
+                    <a:lnR w="6350" cap="flat" cmpd="sng" algn="ctr">
+                      <a:solidFill>
+                        <a:schemeClr val="bg2"/>
+                      </a:solidFill>
+                      <a:prstDash val="solid"/>
+                      <a:round/>
+                      <a:headEnd type="none" w="med" len="med"/>
+                      <a:tailEnd type="none" w="med" len="med"/>
+                    </a:lnR>
+                    <a:lnT w="6350" cap="flat" cmpd="sng" algn="ctr">
+                      <a:solidFill>
+                        <a:schemeClr val="bg2"/>
+                      </a:solidFill>
+                      <a:prstDash val="solid"/>
+                      <a:round/>
+                      <a:headEnd type="none" w="med" len="med"/>
+                      <a:tailEnd type="none" w="med" len="med"/>
+                    </a:lnT>
+                    <a:lnB w="6350" cap="flat" cmpd="sng" algn="ctr">
+                      <a:solidFill>
+                        <a:schemeClr val="bg2"/>
+                      </a:solidFill>
+                      <a:prstDash val="solid"/>
+                      <a:round/>
+                      <a:headEnd type="none" w="med" len="med"/>
+                      <a:tailEnd type="none" w="med" len="med"/>
+                    </a:lnB>
+                    <a:solidFill>
+                      <a:schemeClr val="tx2"/>
+                    </a:solidFill>
+                  </a:tcPr>
+                </a:tc>
+              </a:tr>
+              <a:tr h="548640">
+                <a:tc>
+                  <a:txBody>
+                    <a:bodyPr/>
+                    <a:lstStyle/>
+                    <a:p>
+                      <a:pPr indent="0" marL="0">
+                        <a:buNone/>
+                      </a:pPr>
+                      <a:r>
+                        <a:rPr lang="en-US" sz="1300" b="1" dirty="0">
+                          <a:solidFill>
+                            <a:schemeClr val="tx2"/>
+                          </a:solidFill>
+                        </a:rPr>
+                        <a:t>Dashboard</a:t>
+                      </a:r>
+                      <a:endParaRPr lang="en-US" sz="1300" dirty="0"/>
+                    </a:p>
+                  </a:txBody>
+                  <a:tcPr marL="91440" marR="91440" marT="27432" marB="27432" anchor="ctr">
+                    <a:lnL w="6350" cap="flat" cmpd="sng" algn="ctr">
+                      <a:solidFill>
+                        <a:schemeClr val="bg2"/>
+                      </a:solidFill>
+                      <a:prstDash val="solid"/>
+                      <a:round/>
+                      <a:headEnd type="none" w="med" len="med"/>
+                      <a:tailEnd type="none" w="med" len="med"/>
+                    </a:lnL>
+                    <a:lnR w="6350" cap="flat" cmpd="sng" algn="ctr">
+                      <a:solidFill>
+                        <a:schemeClr val="bg2"/>
+                      </a:solidFill>
+                      <a:prstDash val="solid"/>
+                      <a:round/>
+                      <a:headEnd type="none" w="med" len="med"/>
+                      <a:tailEnd type="none" w="med" len="med"/>
+                    </a:lnR>
+                    <a:lnT w="6350" cap="flat" cmpd="sng" algn="ctr">
+                      <a:solidFill>
+                        <a:schemeClr val="bg2"/>
+                      </a:solidFill>
+                      <a:prstDash val="solid"/>
+                      <a:round/>
+                      <a:headEnd type="none" w="med" len="med"/>
+                      <a:tailEnd type="none" w="med" len="med"/>
+                    </a:lnT>
+                    <a:lnB w="6350" cap="flat" cmpd="sng" algn="ctr">
+                      <a:solidFill>
+                        <a:schemeClr val="bg2"/>
+                      </a:solidFill>
+                      <a:prstDash val="solid"/>
+                      <a:round/>
+                      <a:headEnd type="none" w="med" len="med"/>
+                      <a:tailEnd type="none" w="med" len="med"/>
+                    </a:lnB>
+                    <a:solidFill>
+                      <a:schemeClr val="bg2"/>
+                    </a:solidFill>
+                  </a:tcPr>
+                </a:tc>
+                <a:tc>
+                  <a:txBody>
+                    <a:bodyPr/>
+                    <a:lstStyle/>
+                    <a:p>
+                      <a:pPr indent="0" marL="0">
+                        <a:buNone/>
+                      </a:pPr>
+                      <a:r>
+                        <a:rPr lang="en-US" sz="1300" dirty="0">
+                          <a:solidFill>
+                            <a:srgbClr val="000000"/>
+                          </a:solidFill>
+                        </a:rPr>
+                        <a:t>Accounts, outstanding principal, overdue, due in 7 days, collections month to date, status mix, trends</a:t>
+                      </a:r>
+                      <a:endParaRPr lang="en-US" sz="1300" dirty="0"/>
+                    </a:p>
+                  </a:txBody>
+                  <a:tcPr marL="91440" marR="91440" marT="27432" marB="27432" anchor="ctr">
+                    <a:lnL w="6350" cap="flat" cmpd="sng" algn="ctr">
+                      <a:solidFill>
+                        <a:schemeClr val="bg2"/>
+                      </a:solidFill>
+                      <a:prstDash val="solid"/>
+                      <a:round/>
+                      <a:headEnd type="none" w="med" len="med"/>
+                      <a:tailEnd type="none" w="med" len="med"/>
+                    </a:lnL>
+                    <a:lnR w="6350" cap="flat" cmpd="sng" algn="ctr">
+                      <a:solidFill>
+                        <a:schemeClr val="bg2"/>
+                      </a:solidFill>
+                      <a:prstDash val="solid"/>
+                      <a:round/>
+                      <a:headEnd type="none" w="med" len="med"/>
+                      <a:tailEnd type="none" w="med" len="med"/>
+                    </a:lnR>
+                    <a:lnT w="6350" cap="flat" cmpd="sng" algn="ctr">
+                      <a:solidFill>
+                        <a:schemeClr val="bg2"/>
+                      </a:solidFill>
+                      <a:prstDash val="solid"/>
+                      <a:round/>
+                      <a:headEnd type="none" w="med" len="med"/>
+                      <a:tailEnd type="none" w="med" len="med"/>
+                    </a:lnT>
+                    <a:lnB w="6350" cap="flat" cmpd="sng" algn="ctr">
+                      <a:solidFill>
+                        <a:schemeClr val="bg2"/>
+                      </a:solidFill>
+                      <a:prstDash val="solid"/>
+                      <a:round/>
+                      <a:headEnd type="none" w="med" len="med"/>
+                      <a:tailEnd type="none" w="med" len="med"/>
+                    </a:lnB>
+                    <a:solidFill>
+                      <a:schemeClr val="bg2"/>
+                    </a:solidFill>
+                  </a:tcPr>
+                </a:tc>
+              </a:tr>
+              <a:tr h="548640">
+                <a:tc>
+                  <a:txBody>
+                    <a:bodyPr/>
+                    <a:lstStyle/>
+                    <a:p>
+                      <a:pPr indent="0" marL="0">
+                        <a:buNone/>
+                      </a:pPr>
+                      <a:r>
+                        <a:rPr lang="en-US" sz="1300" b="1" dirty="0">
+                          <a:solidFill>
+                            <a:schemeClr val="tx2"/>
+                          </a:solidFill>
+                        </a:rPr>
+                        <a:t>Accounts</a:t>
+                      </a:r>
+                      <a:endParaRPr lang="en-US" sz="1300" dirty="0"/>
+                    </a:p>
+                  </a:txBody>
+                  <a:tcPr marL="91440" marR="91440" marT="27432" marB="27432" anchor="ctr">
+                    <a:lnL w="6350" cap="flat" cmpd="sng" algn="ctr">
+                      <a:solidFill>
+                        <a:schemeClr val="bg2"/>
+                      </a:solidFill>
+                      <a:prstDash val="solid"/>
+                      <a:round/>
+                      <a:headEnd type="none" w="med" len="med"/>
+                      <a:tailEnd type="none" w="med" len="med"/>
+                    </a:lnL>
+                    <a:lnR w="6350" cap="flat" cmpd="sng" algn="ctr">
+                      <a:solidFill>
+                        <a:schemeClr val="bg2"/>
+                      </a:solidFill>
+                      <a:prstDash val="solid"/>
+                      <a:round/>
+                      <a:headEnd type="none" w="med" len="med"/>
+                      <a:tailEnd type="none" w="med" len="med"/>
+                    </a:lnR>
+                    <a:lnT w="6350" cap="flat" cmpd="sng" algn="ctr">
+                      <a:solidFill>
+                        <a:schemeClr val="bg2"/>
+                      </a:solidFill>
+                      <a:prstDash val="solid"/>
+                      <a:round/>
+                      <a:headEnd type="none" w="med" len="med"/>
+                      <a:tailEnd type="none" w="med" len="med"/>
+                    </a:lnT>
+                    <a:lnB w="6350" cap="flat" cmpd="sng" algn="ctr">
+                      <a:solidFill>
+                        <a:schemeClr val="bg2"/>
+                      </a:solidFill>
+                      <a:prstDash val="solid"/>
+                      <a:round/>
+                      <a:headEnd type="none" w="med" len="med"/>
+                      <a:tailEnd type="none" w="med" len="med"/>
+                    </a:lnB>
+                    <a:solidFill>
+                      <a:schemeClr val="bg1"/>
+                    </a:solidFill>
+                  </a:tcPr>
+                </a:tc>
+                <a:tc>
+                  <a:txBody>
+                    <a:bodyPr/>
+                    <a:lstStyle/>
+                    <a:p>
+                      <a:pPr indent="0" marL="0">
+                        <a:buNone/>
+                      </a:pPr>
+                      <a:r>
+                        <a:rPr lang="en-US" sz="1300" dirty="0">
+                          <a:solidFill>
+                            <a:srgbClr val="000000"/>
+                          </a:solidFill>
+                        </a:rPr>
+                        <a:t>Search by number or customer; filter by status, type, product; sort and page</a:t>
+                      </a:r>
+                      <a:endParaRPr lang="en-US" sz="1300" dirty="0"/>
+                    </a:p>
+                  </a:txBody>
+                  <a:tcPr marL="91440" marR="91440" marT="27432" marB="27432" anchor="ctr">
+                    <a:lnL w="6350" cap="flat" cmpd="sng" algn="ctr">
+                      <a:solidFill>
+                        <a:schemeClr val="bg2"/>
+                      </a:solidFill>
+                      <a:prstDash val="solid"/>
+                      <a:round/>
+                      <a:headEnd type="none" w="med" len="med"/>
+                      <a:tailEnd type="none" w="med" len="med"/>
+                    </a:lnL>
+                    <a:lnR w="6350" cap="flat" cmpd="sng" algn="ctr">
+                      <a:solidFill>
+                        <a:schemeClr val="bg2"/>
+                      </a:solidFill>
+                      <a:prstDash val="solid"/>
+                      <a:round/>
+                      <a:headEnd type="none" w="med" len="med"/>
+                      <a:tailEnd type="none" w="med" len="med"/>
+                    </a:lnR>
+                    <a:lnT w="6350" cap="flat" cmpd="sng" algn="ctr">
+                      <a:solidFill>
+                        <a:schemeClr val="bg2"/>
+                      </a:solidFill>
+                      <a:prstDash val="solid"/>
+                      <a:round/>
+                      <a:headEnd type="none" w="med" len="med"/>
+                      <a:tailEnd type="none" w="med" len="med"/>
+                    </a:lnT>
+                    <a:lnB w="6350" cap="flat" cmpd="sng" algn="ctr">
+                      <a:solidFill>
+                        <a:schemeClr val="bg2"/>
+                      </a:solidFill>
+                      <a:prstDash val="solid"/>
+                      <a:round/>
+                      <a:headEnd type="none" w="med" len="med"/>
+                      <a:tailEnd type="none" w="med" len="med"/>
+                    </a:lnB>
+                    <a:solidFill>
+                      <a:schemeClr val="bg1"/>
+                    </a:solidFill>
+                  </a:tcPr>
+                </a:tc>
+              </a:tr>
+              <a:tr h="548640">
+                <a:tc>
+                  <a:txBody>
+                    <a:bodyPr/>
+                    <a:lstStyle/>
+                    <a:p>
+                      <a:pPr indent="0" marL="0">
+                        <a:buNone/>
+                      </a:pPr>
+                      <a:r>
+                        <a:rPr lang="en-US" sz="1300" b="1" dirty="0">
+                          <a:solidFill>
+                            <a:schemeClr val="tx2"/>
+                          </a:solidFill>
+                        </a:rPr>
+                        <a:t>Account detail</a:t>
+                      </a:r>
+                      <a:endParaRPr lang="en-US" sz="1300" dirty="0"/>
+                    </a:p>
+                  </a:txBody>
+                  <a:tcPr marL="91440" marR="91440" marT="27432" marB="27432" anchor="ctr">
+                    <a:lnL w="6350" cap="flat" cmpd="sng" algn="ctr">
+                      <a:solidFill>
+                        <a:schemeClr val="bg2"/>
+                      </a:solidFill>
+                      <a:prstDash val="solid"/>
+                      <a:round/>
+                      <a:headEnd type="none" w="med" len="med"/>
+                      <a:tailEnd type="none" w="med" len="med"/>
+                    </a:lnL>
+                    <a:lnR w="6350" cap="flat" cmpd="sng" algn="ctr">
+                      <a:solidFill>
+                        <a:schemeClr val="bg2"/>
+                      </a:solidFill>
+                      <a:prstDash val="solid"/>
+                      <a:round/>
+                      <a:headEnd type="none" w="med" len="med"/>
+                      <a:tailEnd type="none" w="med" len="med"/>
+                    </a:lnR>
+                    <a:lnT w="6350" cap="flat" cmpd="sng" algn="ctr">
+                      <a:solidFill>
+                        <a:schemeClr val="bg2"/>
+                      </a:solidFill>
+                      <a:prstDash val="solid"/>
+                      <a:round/>
+                      <a:headEnd type="none" w="med" len="med"/>
+                      <a:tailEnd type="none" w="med" len="med"/>
+                    </a:lnT>
+                    <a:lnB w="6350" cap="flat" cmpd="sng" algn="ctr">
+                      <a:solidFill>
+                        <a:schemeClr val="bg2"/>
+                      </a:solidFill>
+                      <a:prstDash val="solid"/>
+                      <a:round/>
+                      <a:headEnd type="none" w="med" len="med"/>
+                      <a:tailEnd type="none" w="med" len="med"/>
+                    </a:lnB>
+                    <a:solidFill>
+                      <a:schemeClr val="bg2"/>
+                    </a:solidFill>
+                  </a:tcPr>
+                </a:tc>
+                <a:tc>
+                  <a:txBody>
+                    <a:bodyPr/>
+                    <a:lstStyle/>
+                    <a:p>
+                      <a:pPr indent="0" marL="0">
+                        <a:buNone/>
+                      </a:pPr>
+                      <a:r>
+                        <a:rPr lang="en-US" sz="1300" dirty="0">
+                          <a:solidFill>
+                            <a:srgbClr val="000000"/>
+                          </a:solidFill>
+                        </a:rPr>
+                        <a:t>Overview, Amortization (all versions, CSV), Accruals (range and chart), Payments (CSV), Mortgage, Statement PDF</a:t>
+                      </a:r>
+                      <a:endParaRPr lang="en-US" sz="1300" dirty="0"/>
+                    </a:p>
+                  </a:txBody>
+                  <a:tcPr marL="91440" marR="91440" marT="27432" marB="27432" anchor="ctr">
+                    <a:lnL w="6350" cap="flat" cmpd="sng" algn="ctr">
+                      <a:solidFill>
+                        <a:schemeClr val="bg2"/>
+                      </a:solidFill>
+                      <a:prstDash val="solid"/>
+                      <a:round/>
+                      <a:headEnd type="none" w="med" len="med"/>
+                      <a:tailEnd type="none" w="med" len="med"/>
+                    </a:lnL>
+                    <a:lnR w="6350" cap="flat" cmpd="sng" algn="ctr">
+                      <a:solidFill>
+                        <a:schemeClr val="bg2"/>
+                      </a:solidFill>
+                      <a:prstDash val="solid"/>
+                      <a:round/>
+                      <a:headEnd type="none" w="med" len="med"/>
+                      <a:tailEnd type="none" w="med" len="med"/>
+                    </a:lnR>
+                    <a:lnT w="6350" cap="flat" cmpd="sng" algn="ctr">
+                      <a:solidFill>
+                        <a:schemeClr val="bg2"/>
+                      </a:solidFill>
+                      <a:prstDash val="solid"/>
+                      <a:round/>
+                      <a:headEnd type="none" w="med" len="med"/>
+                      <a:tailEnd type="none" w="med" len="med"/>
+                    </a:lnT>
+                    <a:lnB w="6350" cap="flat" cmpd="sng" algn="ctr">
+                      <a:solidFill>
+                        <a:schemeClr val="bg2"/>
+                      </a:solidFill>
+                      <a:prstDash val="solid"/>
+                      <a:round/>
+                      <a:headEnd type="none" w="med" len="med"/>
+                      <a:tailEnd type="none" w="med" len="med"/>
+                    </a:lnB>
+                    <a:solidFill>
+                      <a:schemeClr val="bg2"/>
+                    </a:solidFill>
+                  </a:tcPr>
+                </a:tc>
+              </a:tr>
+              <a:tr h="548640">
+                <a:tc>
+                  <a:txBody>
+                    <a:bodyPr/>
+                    <a:lstStyle/>
+                    <a:p>
+                      <a:pPr indent="0" marL="0">
+                        <a:buNone/>
+                      </a:pPr>
+                      <a:r>
+                        <a:rPr lang="en-US" sz="1300" b="1" dirty="0">
+                          <a:solidFill>
+                            <a:schemeClr val="tx2"/>
+                          </a:solidFill>
+                        </a:rPr>
+                        <a:t>Upcoming payments</a:t>
+                      </a:r>
+                      <a:endParaRPr lang="en-US" sz="1300" dirty="0"/>
+                    </a:p>
+                  </a:txBody>
+                  <a:tcPr marL="91440" marR="91440" marT="27432" marB="27432" anchor="ctr">
+                    <a:lnL w="6350" cap="flat" cmpd="sng" algn="ctr">
+                      <a:solidFill>
+                        <a:schemeClr val="bg2"/>
+                      </a:solidFill>
+                      <a:prstDash val="solid"/>
+                      <a:round/>
+                      <a:headEnd type="none" w="med" len="med"/>
+                      <a:tailEnd type="none" w="med" len="med"/>
+                    </a:lnL>
+                    <a:lnR w="6350" cap="flat" cmpd="sng" algn="ctr">
+                      <a:solidFill>
+                        <a:schemeClr val="bg2"/>
+                      </a:solidFill>
+                      <a:prstDash val="solid"/>
+                      <a:round/>
+                      <a:headEnd type="none" w="med" len="med"/>
+                      <a:tailEnd type="none" w="med" len="med"/>
+                    </a:lnR>
+                    <a:lnT w="6350" cap="flat" cmpd="sng" algn="ctr">
+                      <a:solidFill>
+                        <a:schemeClr val="bg2"/>
+                      </a:solidFill>
+                      <a:prstDash val="solid"/>
+                      <a:round/>
+                      <a:headEnd type="none" w="med" len="med"/>
+                      <a:tailEnd type="none" w="med" len="med"/>
+                    </a:lnT>
+                    <a:lnB w="6350" cap="flat" cmpd="sng" algn="ctr">
+                      <a:solidFill>
+                        <a:schemeClr val="bg2"/>
+                      </a:solidFill>
+                      <a:prstDash val="solid"/>
+                      <a:round/>
+                      <a:headEnd type="none" w="med" len="med"/>
+                      <a:tailEnd type="none" w="med" len="med"/>
+                    </a:lnB>
+                    <a:solidFill>
+                      <a:schemeClr val="bg1"/>
+                    </a:solidFill>
+                  </a:tcPr>
+                </a:tc>
+                <a:tc>
+                  <a:txBody>
+                    <a:bodyPr/>
+                    <a:lstStyle/>
+                    <a:p>
+                      <a:pPr indent="0" marL="0">
+                        <a:buNone/>
+                      </a:pPr>
+                      <a:r>
+                        <a:rPr lang="en-US" sz="1300" dirty="0">
+                          <a:solidFill>
+                            <a:srgbClr val="000000"/>
+                          </a:solidFill>
+                        </a:rPr>
+                        <a:t>Due in 7, 15, 30, 60 or 90 days, by product, with totals</a:t>
+                      </a:r>
+                      <a:endParaRPr lang="en-US" sz="1300" dirty="0"/>
+                    </a:p>
+                  </a:txBody>
+                  <a:tcPr marL="91440" marR="91440" marT="27432" marB="27432" anchor="ctr">
+                    <a:lnL w="6350" cap="flat" cmpd="sng" algn="ctr">
+                      <a:solidFill>
+                        <a:schemeClr val="bg2"/>
+                      </a:solidFill>
+                      <a:prstDash val="solid"/>
+                      <a:round/>
+                      <a:headEnd type="none" w="med" len="med"/>
+                      <a:tailEnd type="none" w="med" len="med"/>
+                    </a:lnL>
+                    <a:lnR w="6350" cap="flat" cmpd="sng" algn="ctr">
+                      <a:solidFill>
+                        <a:schemeClr val="bg2"/>
+                      </a:solidFill>
+                      <a:prstDash val="solid"/>
+                      <a:round/>
+                      <a:headEnd type="none" w="med" len="med"/>
+                      <a:tailEnd type="none" w="med" len="med"/>
+                    </a:lnR>
+                    <a:lnT w="6350" cap="flat" cmpd="sng" algn="ctr">
+                      <a:solidFill>
+                        <a:schemeClr val="bg2"/>
+                      </a:solidFill>
+                      <a:prstDash val="solid"/>
+                      <a:round/>
+                      <a:headEnd type="none" w="med" len="med"/>
+                      <a:tailEnd type="none" w="med" len="med"/>
+                    </a:lnT>
+                    <a:lnB w="6350" cap="flat" cmpd="sng" algn="ctr">
+                      <a:solidFill>
+                        <a:schemeClr val="bg2"/>
+                      </a:solidFill>
+                      <a:prstDash val="solid"/>
+                      <a:round/>
+                      <a:headEnd type="none" w="med" len="med"/>
+                      <a:tailEnd type="none" w="med" len="med"/>
+                    </a:lnB>
+                    <a:solidFill>
+                      <a:schemeClr val="bg1"/>
+                    </a:solidFill>
+                  </a:tcPr>
+                </a:tc>
+              </a:tr>
+              <a:tr h="548640">
+                <a:tc>
+                  <a:txBody>
+                    <a:bodyPr/>
+                    <a:lstStyle/>
+                    <a:p>
+                      <a:pPr indent="0" marL="0">
+                        <a:buNone/>
+                      </a:pPr>
+                      <a:r>
+                        <a:rPr lang="en-US" sz="1300" b="1" dirty="0">
+                          <a:solidFill>
+                            <a:schemeClr val="tx2"/>
+                          </a:solidFill>
+                        </a:rPr>
+                        <a:t>Overdue</a:t>
+                      </a:r>
+                      <a:endParaRPr lang="en-US" sz="1300" dirty="0"/>
+                    </a:p>
+                  </a:txBody>
+                  <a:tcPr marL="91440" marR="91440" marT="27432" marB="27432" anchor="ctr">
+                    <a:lnL w="6350" cap="flat" cmpd="sng" algn="ctr">
+                      <a:solidFill>
+                        <a:schemeClr val="bg2"/>
+                      </a:solidFill>
+                      <a:prstDash val="solid"/>
+                      <a:round/>
+                      <a:headEnd type="none" w="med" len="med"/>
+                      <a:tailEnd type="none" w="med" len="med"/>
+                    </a:lnL>
+                    <a:lnR w="6350" cap="flat" cmpd="sng" algn="ctr">
+                      <a:solidFill>
+                        <a:schemeClr val="bg2"/>
+                      </a:solidFill>
+                      <a:prstDash val="solid"/>
+                      <a:round/>
+                      <a:headEnd type="none" w="med" len="med"/>
+                      <a:tailEnd type="none" w="med" len="med"/>
+                    </a:lnR>
+                    <a:lnT w="6350" cap="flat" cmpd="sng" algn="ctr">
+                      <a:solidFill>
+                        <a:schemeClr val="bg2"/>
+                      </a:solidFill>
+                      <a:prstDash val="solid"/>
+                      <a:round/>
+                      <a:headEnd type="none" w="med" len="med"/>
+                      <a:tailEnd type="none" w="med" len="med"/>
+                    </a:lnT>
+                    <a:lnB w="6350" cap="flat" cmpd="sng" algn="ctr">
+                      <a:solidFill>
+                        <a:schemeClr val="bg2"/>
+                      </a:solidFill>
+                      <a:prstDash val="solid"/>
+                      <a:round/>
+                      <a:headEnd type="none" w="med" len="med"/>
+                      <a:tailEnd type="none" w="med" len="med"/>
+                    </a:lnB>
+                    <a:solidFill>
+                      <a:schemeClr val="bg2"/>
+                    </a:solidFill>
+                  </a:tcPr>
+                </a:tc>
+                <a:tc>
+                  <a:txBody>
+                    <a:bodyPr/>
+                    <a:lstStyle/>
+                    <a:p>
+                      <a:pPr indent="0" marL="0">
+                        <a:buNone/>
+                      </a:pPr>
+                      <a:r>
+                        <a:rPr lang="en-US" sz="1300" dirty="0">
+                          <a:solidFill>
+                            <a:srgbClr val="000000"/>
+                          </a:solidFill>
+                        </a:rPr>
+                        <a:t>Unpaid past due, days past due, buckets 1-30, 31-60, 61-90, 90+</a:t>
+                      </a:r>
+                      <a:endParaRPr lang="en-US" sz="1300" dirty="0"/>
+                    </a:p>
+                  </a:txBody>
+                  <a:tcPr marL="91440" marR="91440" marT="27432" marB="27432" anchor="ctr">
+                    <a:lnL w="6350" cap="flat" cmpd="sng" algn="ctr">
+                      <a:solidFill>
+                        <a:schemeClr val="bg2"/>
+                      </a:solidFill>
+                      <a:prstDash val="solid"/>
+                      <a:round/>
+                      <a:headEnd type="none" w="med" len="med"/>
+                      <a:tailEnd type="none" w="med" len="med"/>
+                    </a:lnL>
+                    <a:lnR w="6350" cap="flat" cmpd="sng" algn="ctr">
+                      <a:solidFill>
+                        <a:schemeClr val="bg2"/>
+                      </a:solidFill>
+                      <a:prstDash val="solid"/>
+                      <a:round/>
+                      <a:headEnd type="none" w="med" len="med"/>
+                      <a:tailEnd type="none" w="med" len="med"/>
+                    </a:lnR>
+                    <a:lnT w="6350" cap="flat" cmpd="sng" algn="ctr">
+                      <a:solidFill>
+                        <a:schemeClr val="bg2"/>
+                      </a:solidFill>
+                      <a:prstDash val="solid"/>
+                      <a:round/>
+                      <a:headEnd type="none" w="med" len="med"/>
+                      <a:tailEnd type="none" w="med" len="med"/>
+                    </a:lnT>
+                    <a:lnB w="6350" cap="flat" cmpd="sng" algn="ctr">
+                      <a:solidFill>
+                        <a:schemeClr val="bg2"/>
+                      </a:solidFill>
+                      <a:prstDash val="solid"/>
+                      <a:round/>
+                      <a:headEnd type="none" w="med" len="med"/>
+                      <a:tailEnd type="none" w="med" len="med"/>
+                    </a:lnB>
+                    <a:solidFill>
+                      <a:schemeClr val="bg2"/>
+                    </a:solidFill>
+                  </a:tcPr>
+                </a:tc>
+              </a:tr>
+              <a:tr h="548640">
+                <a:tc>
+                  <a:txBody>
+                    <a:bodyPr/>
+                    <a:lstStyle/>
+                    <a:p>
+                      <a:pPr indent="0" marL="0">
+                        <a:buNone/>
+                      </a:pPr>
+                      <a:r>
+                        <a:rPr lang="en-US" sz="1300" b="1" dirty="0">
+                          <a:solidFill>
+                            <a:schemeClr val="tx2"/>
+                          </a:solidFill>
+                        </a:rPr>
+                        <a:t>Payments and Accruals</a:t>
+                      </a:r>
+                      <a:endParaRPr lang="en-US" sz="1300" dirty="0"/>
+                    </a:p>
+                  </a:txBody>
+                  <a:tcPr marL="91440" marR="91440" marT="27432" marB="27432" anchor="ctr">
+                    <a:lnL w="6350" cap="flat" cmpd="sng" algn="ctr">
+                      <a:solidFill>
+                        <a:schemeClr val="bg2"/>
+                      </a:solidFill>
+                      <a:prstDash val="solid"/>
+                      <a:round/>
+                      <a:headEnd type="none" w="med" len="med"/>
+                      <a:tailEnd type="none" w="med" len="med"/>
+                    </a:lnL>
+                    <a:lnR w="6350" cap="flat" cmpd="sng" algn="ctr">
+                      <a:solidFill>
+                        <a:schemeClr val="bg2"/>
+                      </a:solidFill>
+                      <a:prstDash val="solid"/>
+                      <a:round/>
+                      <a:headEnd type="none" w="med" len="med"/>
+                      <a:tailEnd type="none" w="med" len="med"/>
+                    </a:lnR>
+                    <a:lnT w="6350" cap="flat" cmpd="sng" algn="ctr">
+                      <a:solidFill>
+                        <a:schemeClr val="bg2"/>
+                      </a:solidFill>
+                      <a:prstDash val="solid"/>
+                      <a:round/>
+                      <a:headEnd type="none" w="med" len="med"/>
+                      <a:tailEnd type="none" w="med" len="med"/>
+                    </a:lnT>
+                    <a:lnB w="6350" cap="flat" cmpd="sng" algn="ctr">
+                      <a:solidFill>
+                        <a:schemeClr val="bg2"/>
+                      </a:solidFill>
+                      <a:prstDash val="solid"/>
+                      <a:round/>
+                      <a:headEnd type="none" w="med" len="med"/>
+                      <a:tailEnd type="none" w="med" len="med"/>
+                    </a:lnB>
+                    <a:solidFill>
+                      <a:schemeClr val="bg1"/>
+                    </a:solidFill>
+                  </a:tcPr>
+                </a:tc>
+                <a:tc>
+                  <a:txBody>
+                    <a:bodyPr/>
+                    <a:lstStyle/>
+                    <a:p>
+                      <a:pPr indent="0" marL="0">
+                        <a:buNone/>
+                      </a:pPr>
+                      <a:r>
+                        <a:rPr lang="en-US" sz="1300" dirty="0">
+                          <a:solidFill>
+                            <a:srgbClr val="000000"/>
+                          </a:solidFill>
+                        </a:rPr>
+                        <a:t>Book-wide EMI transactions with filters; daily accrual totals with drill-down</a:t>
+                      </a:r>
+                      <a:endParaRPr lang="en-US" sz="1300" dirty="0"/>
+                    </a:p>
+                  </a:txBody>
+                  <a:tcPr marL="91440" marR="91440" marT="27432" marB="27432" anchor="ctr">
+                    <a:lnL w="6350" cap="flat" cmpd="sng" algn="ctr">
+                      <a:solidFill>
+                        <a:schemeClr val="bg2"/>
+                      </a:solidFill>
+                      <a:prstDash val="solid"/>
+                      <a:round/>
+                      <a:headEnd type="none" w="med" len="med"/>
+                      <a:tailEnd type="none" w="med" len="med"/>
+                    </a:lnL>
+                    <a:lnR w="6350" cap="flat" cmpd="sng" algn="ctr">
+                      <a:solidFill>
+                        <a:schemeClr val="bg2"/>
+                      </a:solidFill>
+                      <a:prstDash val="solid"/>
+                      <a:round/>
+                      <a:headEnd type="none" w="med" len="med"/>
+                      <a:tailEnd type="none" w="med" len="med"/>
+                    </a:lnR>
+                    <a:lnT w="6350" cap="flat" cmpd="sng" algn="ctr">
+                      <a:solidFill>
+                        <a:schemeClr val="bg2"/>
+                      </a:solidFill>
+                      <a:prstDash val="solid"/>
+                      <a:round/>
+                      <a:headEnd type="none" w="med" len="med"/>
+                      <a:tailEnd type="none" w="med" len="med"/>
+                    </a:lnT>
+                    <a:lnB w="6350" cap="flat" cmpd="sng" algn="ctr">
+                      <a:solidFill>
+                        <a:schemeClr val="bg2"/>
+                      </a:solidFill>
+                      <a:prstDash val="solid"/>
+                      <a:round/>
+                      <a:headEnd type="none" w="med" len="med"/>
+                      <a:tailEnd type="none" w="med" len="med"/>
+                    </a:lnB>
+                    <a:solidFill>
+                      <a:schemeClr val="bg1"/>
+                    </a:solidFill>
+                  </a:tcPr>
+                </a:tc>
+              </a:tr>
+              <a:tr h="548640">
+                <a:tc>
+                  <a:txBody>
+                    <a:bodyPr/>
+                    <a:lstStyle/>
+                    <a:p>
+                      <a:pPr indent="0" marL="0">
+                        <a:buNone/>
+                      </a:pPr>
+                      <a:r>
+                        <a:rPr lang="en-US" sz="1300" b="1" dirty="0">
+                          <a:solidFill>
+                            <a:schemeClr val="tx2"/>
+                          </a:solidFill>
+                        </a:rPr>
+                        <a:t>Ledger outbox and Batch</a:t>
+                      </a:r>
+                      <a:endParaRPr lang="en-US" sz="1300" dirty="0"/>
+                    </a:p>
+                  </a:txBody>
+                  <a:tcPr marL="91440" marR="91440" marT="27432" marB="27432" anchor="ctr">
+                    <a:lnL w="6350" cap="flat" cmpd="sng" algn="ctr">
+                      <a:solidFill>
+                        <a:schemeClr val="bg2"/>
+                      </a:solidFill>
+                      <a:prstDash val="solid"/>
+                      <a:round/>
+                      <a:headEnd type="none" w="med" len="med"/>
+                      <a:tailEnd type="none" w="med" len="med"/>
+                    </a:lnL>
+                    <a:lnR w="6350" cap="flat" cmpd="sng" algn="ctr">
+                      <a:solidFill>
+                        <a:schemeClr val="bg2"/>
+                      </a:solidFill>
+                      <a:prstDash val="solid"/>
+                      <a:round/>
+                      <a:headEnd type="none" w="med" len="med"/>
+                      <a:tailEnd type="none" w="med" len="med"/>
+                    </a:lnR>
+                    <a:lnT w="6350" cap="flat" cmpd="sng" algn="ctr">
+                      <a:solidFill>
+                        <a:schemeClr val="bg2"/>
+                      </a:solidFill>
+                      <a:prstDash val="solid"/>
+                      <a:round/>
+                      <a:headEnd type="none" w="med" len="med"/>
+                      <a:tailEnd type="none" w="med" len="med"/>
+                    </a:lnT>
+                    <a:lnB w="6350" cap="flat" cmpd="sng" algn="ctr">
+                      <a:solidFill>
+                        <a:schemeClr val="bg2"/>
+                      </a:solidFill>
+                      <a:prstDash val="solid"/>
+                      <a:round/>
+                      <a:headEnd type="none" w="med" len="med"/>
+                      <a:tailEnd type="none" w="med" len="med"/>
+                    </a:lnB>
+                    <a:solidFill>
+                      <a:schemeClr val="bg2"/>
+                    </a:solidFill>
+                  </a:tcPr>
+                </a:tc>
+                <a:tc>
+                  <a:txBody>
+                    <a:bodyPr/>
+                    <a:lstStyle/>
+                    <a:p>
+                      <a:pPr indent="0" marL="0">
+                        <a:buNone/>
+                      </a:pPr>
+                      <a:r>
+                        <a:rPr lang="en-US" sz="1300" dirty="0">
+                          <a:solidFill>
+                            <a:srgbClr val="000000"/>
+                          </a:solidFill>
+                        </a:rPr>
+                        <a:t>Posting status and retries; 36 job slots and recent executions</a:t>
+                      </a:r>
+                      <a:endParaRPr lang="en-US" sz="1300" dirty="0"/>
+                    </a:p>
+                  </a:txBody>
+                  <a:tcPr marL="91440" marR="91440" marT="27432" marB="27432" anchor="ctr">
+                    <a:lnL w="6350" cap="flat" cmpd="sng" algn="ctr">
+                      <a:solidFill>
+                        <a:schemeClr val="bg2"/>
+                      </a:solidFill>
+                      <a:prstDash val="solid"/>
+                      <a:round/>
+                      <a:headEnd type="none" w="med" len="med"/>
+                      <a:tailEnd type="none" w="med" len="med"/>
+                    </a:lnL>
+                    <a:lnR w="6350" cap="flat" cmpd="sng" algn="ctr">
+                      <a:solidFill>
+                        <a:schemeClr val="bg2"/>
+                      </a:solidFill>
+                      <a:prstDash val="solid"/>
+                      <a:round/>
+                      <a:headEnd type="none" w="med" len="med"/>
+                      <a:tailEnd type="none" w="med" len="med"/>
+                    </a:lnR>
+                    <a:lnT w="6350" cap="flat" cmpd="sng" algn="ctr">
+                      <a:solidFill>
+                        <a:schemeClr val="bg2"/>
+                      </a:solidFill>
+                      <a:prstDash val="solid"/>
+                      <a:round/>
+                      <a:headEnd type="none" w="med" len="med"/>
+                      <a:tailEnd type="none" w="med" len="med"/>
+                    </a:lnT>
+                    <a:lnB w="6350" cap="flat" cmpd="sng" algn="ctr">
+                      <a:solidFill>
+                        <a:schemeClr val="bg2"/>
+                      </a:solidFill>
+                      <a:prstDash val="solid"/>
+                      <a:round/>
+                      <a:headEnd type="none" w="med" len="med"/>
+                      <a:tailEnd type="none" w="med" len="med"/>
+                    </a:lnB>
+                    <a:solidFill>
+                      <a:schemeClr val="bg2"/>
+                    </a:solidFill>
+                  </a:tcPr>
+                </a:tc>
+              </a:tr>
+            </a:tbl>
+          </a:graphicData>
+        </a:graphic>
+      </p:graphicFrame>
+      <p:sp>
+        <p:nvSpPr>
+          <p:cNvPr id="6" name="Text 2"/>
+          <p:cNvSpPr txBox="1"/>
+          <p:nvPr/>
+        </p:nvSpPr>
+        <p:spPr>
+          <a:xfrm>
+            <a:off x="8229600" y="1463040"/>
+            <a:ext cx="3383280" cy="2377440"/>
+          </a:xfrm>
+          <a:prstGeom prst="roundRect">
+            <a:avLst>
+              <a:gd name="adj" fmla="val 3077"/>
+            </a:avLst>
+          </a:prstGeom>
+          <a:solidFill>
+            <a:schemeClr val="accent1">
+              <a:alpha val="10000"/>
+            </a:schemeClr>
+          </a:solidFill>
+          <a:ln w="12700">
+            <a:solidFill>
+              <a:schemeClr val="accent1"/>
+            </a:solidFill>
+          </a:ln>
+        </p:spPr>
+        <p:txBody>
+          <a:bodyPr wrap="square" lIns="152400" tIns="152400" rIns="152400" bIns="152400" rtlCol="0" anchor="t"/>
+          <a:lstStyle/>
+          <a:p>
+            <a:pPr algn="l" indent="0" marL="0">
+              <a:buNone/>
+            </a:pPr>
+            <a:r>
+              <a:rPr lang="en-US" sz="1600" b="1" dirty="0">
+                <a:solidFill>
+                  <a:schemeClr val="tx2"/>
+                </a:solidFill>
+              </a:rPr>
+              <a:t>Sign in</a:t>
+            </a:r>
+            <a:endParaRPr lang="en-US" sz="1200" dirty="0"/>
+          </a:p>
+          <a:p>
+            <a:pPr algn="l" indent="0" marL="0">
+              <a:buNone/>
+            </a:pPr>
+            <a:r>
+              <a:rPr lang="en-US" sz="1400" dirty="0">
+                <a:solidFill>
+                  <a:schemeClr val="tx1"/>
+                </a:solidFill>
+              </a:rPr>
+              <a:t>User id: admin</a:t>
+            </a:r>
+            <a:endParaRPr lang="en-US" sz="1200" dirty="0"/>
+          </a:p>
+          <a:p>
+            <a:pPr algn="l" indent="0" marL="0">
+              <a:buNone/>
+            </a:pPr>
+            <a:r>
+              <a:rPr lang="en-US" sz="1200" dirty="0">
+                <a:solidFill>
+                  <a:schemeClr val="tx1"/>
+                </a:solidFill>
+              </a:rPr>
+              <a:t>Password: ADMIN_PASSWORD from the Render dashboard (Environment tab). Local default: changeme</a:t>
+            </a:r>
+            <a:endParaRPr lang="en-US" sz="1200" dirty="0"/>
+          </a:p>
+          <a:p>
+            <a:pPr algn="l" indent="0" marL="0">
+              <a:buNone/>
+            </a:pPr>
+            <a:r>
+              <a:rPr lang="en-US" sz="600" dirty="0">
+                <a:solidFill>
+                  <a:schemeClr val="tx1"/>
+                </a:solidFill>
+              </a:rPr>
+              <a:t> </a:t>
+            </a:r>
+            <a:endParaRPr lang="en-US" sz="1200" dirty="0"/>
+          </a:p>
+          <a:p>
+            <a:pPr algn="l" indent="0" marL="0">
+              <a:buNone/>
+            </a:pPr>
+            <a:r>
+              <a:rPr lang="en-US" sz="1600" b="1" dirty="0">
+                <a:solidFill>
+                  <a:schemeClr val="tx2"/>
+                </a:solidFill>
+              </a:rPr>
+              <a:t>Limits</a:t>
+            </a:r>
+            <a:endParaRPr lang="en-US" sz="1200" dirty="0"/>
+          </a:p>
+          <a:p>
+            <a:pPr algn="l" indent="0" marL="0">
+              <a:buNone/>
+            </a:pPr>
+            <a:r>
+              <a:rPr lang="en-US" sz="1200" dirty="0">
+                <a:solidFill>
+                  <a:schemeClr val="tx1"/>
+                </a:solidFill>
+              </a:rPr>
+              <a:t>View only. One shared login, no roles or audit trail yet.</a:t>
+            </a:r>
+            <a:endParaRPr lang="en-US" sz="1200" dirty="0"/>
+          </a:p>
+        </p:txBody>
+      </p:sp>
+      <p:sp>
+        <p:nvSpPr>
+          <p:cNvPr id="25" name="Slide Number Placeholder 0"/>
+          <p:cNvSpPr>
+            <a:spLocks noGrp="1"/>
+          </p:cNvSpPr>
+          <p:nvPr>
+            <p:ph type="sldNum" sz="quarter" idx="4294967295"/>
+          </p:nvPr>
+        </p:nvSpPr>
+        <p:spPr>
+          <a:xfrm>
+            <a:off x="11064240" y="6446520"/>
+            <a:ext cx="548640" cy="274320"/>
+          </a:xfrm>
+          <a:prstGeom prst="rect">
+            <a:avLst/>
+          </a:prstGeom>
+          <a:extLst>
+            <a:ext uri="{C572A759-6A51-4108-AA02-DFA0A04FC94B}">
+              <ma14:wrappingTextBoxFlag xmlns:ma14="http://schemas.microsoft.com/office/mac/drawingml/2011/main" val="0"/>
+            </a:ext>
+          </a:extLst>
+        </p:spPr>
+        <p:txBody>
+          <a:bodyPr/>
+          <a:lstStyle>
+            <a:lvl1pPr>
+              <a:defRPr sz="1000">
+                <a:solidFill>
+                  <a:schemeClr val="accent4"/>
+                </a:solidFill>
+              </a:defRPr>
+            </a:lvl1pPr>
+          </a:lstStyle>
+          <a:p>
+            <a:pPr algn="r"/>
+            <a:fld id="{F7021451-1387-4CA6-816F-3879F97B5CBC}" type="slidenum">
+              <a:rPr b="0" lang="en-US"/>
+              <a:t>14</a:t>
+            </a:fld>
+            <a:endParaRPr lang="en-US"/>
+          </a:p>
+        </p:txBody>
+      </p:sp>
+    </p:spTree>
+  </p:cSld>
+  <p:clrMapOvr>
+    <a:masterClrMapping/>
+  </p:clrMapOvr>
+</p:sld>
+</file>
+
+<file path=ppt/slides/slide15.xml><?xml version="1.0" encoding="utf-8"?>
+<p:sld xmlns:a="http://schemas.openxmlformats.org/drawingml/2006/main" xmlns:r="http://schemas.openxmlformats.org/officeDocument/2006/relationships" xmlns:p="http://schemas.openxmlformats.org/presentationml/2006/main">
+  <p:cSld name="Slide 15">
+    <p:spTree>
+      <p:nvGrpSpPr>
+        <p:cNvPr id="1" name=""/>
+        <p:cNvGrpSpPr/>
+        <p:nvPr/>
+      </p:nvGrpSpPr>
+      <p:grpSpPr>
+        <a:xfrm>
+          <a:off x="0" y="0"/>
+          <a:ext cx="0" cy="0"/>
+          <a:chOff x="0" y="0"/>
+          <a:chExt cx="0" cy="0"/>
+        </a:xfrm>
+      </p:grpSpPr>
+      <p:sp>
+        <p:nvSpPr>
+          <p:cNvPr id="2" name="Text 2"/>
+          <p:cNvSpPr/>
+          <p:nvPr>
+            <p:ph idx="102" type="title" hasCustomPrompt="1"/>
+          </p:nvPr>
+        </p:nvSpPr>
+        <p:spPr>
+          <a:xfrm>
+            <a:off x="548640" y="274320"/>
+            <a:ext cx="11064240" cy="685800"/>
+          </a:xfrm>
+          <a:prstGeom prst="rect">
+            <a:avLst/>
+          </a:prstGeom>
+          <a:noFill/>
+          <a:ln/>
+        </p:spPr>
+        <p:txBody>
+          <a:bodyPr wrap="square" lIns="0" tIns="0" rIns="0" bIns="0" rtlCol="0" anchor="ctr"/>
+          <a:lstStyle/>
+          <a:p>
+            <a:pPr algn="l" indent="0" marL="0">
+              <a:buNone/>
+            </a:pPr>
+            <a:r>
+              <a:rPr lang="en-US" sz="3400" b="1" dirty="0">
+                <a:solidFill>
+                  <a:schemeClr val="tx2"/>
+                </a:solidFill>
+              </a:rPr>
+              <a:t>Sandbox URLs and changes since v1.0</a:t>
+            </a:r>
+            <a:endParaRPr lang="en-US" sz="3400" dirty="0"/>
+          </a:p>
+        </p:txBody>
+      </p:sp>
+      <p:sp>
+        <p:nvSpPr>
+          <p:cNvPr id="3" name="Text 2"/>
+          <p:cNvSpPr/>
+          <p:nvPr>
+            <p:ph idx="103" type="body" hasCustomPrompt="1"/>
+          </p:nvPr>
+        </p:nvSpPr>
+        <p:spPr>
+          <a:xfrm>
+            <a:off x="548640" y="960120"/>
+            <a:ext cx="11064240" cy="365760"/>
+          </a:xfrm>
+          <a:prstGeom prst="rect">
+            <a:avLst/>
+          </a:prstGeom>
+          <a:noFill/>
+          <a:ln/>
+        </p:spPr>
+        <p:txBody>
+          <a:bodyPr wrap="square" lIns="0" tIns="0" rIns="0" bIns="0" rtlCol="0" anchor="t"/>
+          <a:lstStyle/>
+          <a:p>
+            <a:pPr algn="l" indent="0" marL="0">
+              <a:buNone/>
+            </a:pPr>
+            <a:r>
+              <a:rPr lang="en-US" sz="1400" dirty="0">
+                <a:solidFill>
+                  <a:schemeClr val="accent4"/>
+                </a:solidFill>
+              </a:rPr>
+              <a:t>Render free tier: services sleep when idle, so the first request takes about a minute</a:t>
+            </a:r>
+            <a:endParaRPr lang="en-US" sz="1400" dirty="0"/>
+          </a:p>
+        </p:txBody>
+      </p:sp>
+      <p:graphicFrame>
+        <p:nvGraphicFramePr>
+          <p:cNvPr id="16" name="Table 0"/>
+          <p:cNvGraphicFramePr>
+            <a:graphicFrameLocks noGrp="1"/>
+          </p:cNvGraphicFramePr>
+          <p:nvPr>
+            <p:extLst>
+              <p:ext uri="{D42A27DB-BD31-4B8C-83A1-F6EECF244321}">
+                <p14:modId xmlns:p14="http://schemas.microsoft.com/office/powerpoint/2010/main" val="1579011935"/>
+              </p:ext>
+            </p:extLst>
+          </p:nvPr>
+        </p:nvGraphicFramePr>
+        <p:xfrm>
+          <a:off x="548640" y="1463040"/>
+          <a:ext cx="11064240" cy="914400"/>
+        </p:xfrm>
+        <a:graphic>
+          <a:graphicData uri="http://schemas.openxmlformats.org/drawingml/2006/table">
+            <a:tbl>
+              <a:tblPr/>
+              <a:tblGrid>
+                <a:gridCol w="2011680"/>
+                <a:gridCol w="9052560"/>
+              </a:tblGrid>
+              <a:tr h="384048">
+                <a:tc>
+                  <a:txBody>
+                    <a:bodyPr/>
+                    <a:lstStyle/>
+                    <a:p>
+                      <a:pPr indent="0" marL="0">
+                        <a:buNone/>
+                      </a:pPr>
+                      <a:r>
+                        <a:rPr lang="en-US" sz="1200" b="1" dirty="0">
+                          <a:solidFill>
+                            <a:schemeClr val="bg1"/>
+                          </a:solidFill>
+                        </a:rPr>
+                        <a:t>Sandbox</a:t>
+                      </a:r>
+                      <a:endParaRPr lang="en-US" sz="1200" dirty="0"/>
+                    </a:p>
+                  </a:txBody>
+                  <a:tcPr marL="91440" marR="91440" marT="18288" marB="18288" anchor="ctr">
+                    <a:lnL w="6350" cap="flat" cmpd="sng" algn="ctr">
+                      <a:solidFill>
+                        <a:schemeClr val="bg2"/>
+                      </a:solidFill>
+                      <a:prstDash val="solid"/>
+                      <a:round/>
+                      <a:headEnd type="none" w="med" len="med"/>
+                      <a:tailEnd type="none" w="med" len="med"/>
+                    </a:lnL>
+                    <a:lnR w="6350" cap="flat" cmpd="sng" algn="ctr">
+                      <a:solidFill>
+                        <a:schemeClr val="bg2"/>
+                      </a:solidFill>
+                      <a:prstDash val="solid"/>
+                      <a:round/>
+                      <a:headEnd type="none" w="med" len="med"/>
+                      <a:tailEnd type="none" w="med" len="med"/>
+                    </a:lnR>
+                    <a:lnT w="6350" cap="flat" cmpd="sng" algn="ctr">
+                      <a:solidFill>
+                        <a:schemeClr val="bg2"/>
+                      </a:solidFill>
+                      <a:prstDash val="solid"/>
+                      <a:round/>
+                      <a:headEnd type="none" w="med" len="med"/>
+                      <a:tailEnd type="none" w="med" len="med"/>
+                    </a:lnT>
+                    <a:lnB w="6350" cap="flat" cmpd="sng" algn="ctr">
+                      <a:solidFill>
+                        <a:schemeClr val="bg2"/>
+                      </a:solidFill>
+                      <a:prstDash val="solid"/>
+                      <a:round/>
+                      <a:headEnd type="none" w="med" len="med"/>
+                      <a:tailEnd type="none" w="med" len="med"/>
+                    </a:lnB>
+                    <a:solidFill>
+                      <a:schemeClr val="tx2"/>
+                    </a:solidFill>
+                  </a:tcPr>
+                </a:tc>
+                <a:tc>
+                  <a:txBody>
+                    <a:bodyPr/>
+                    <a:lstStyle/>
+                    <a:p>
+                      <a:pPr indent="0" marL="0">
+                        <a:buNone/>
+                      </a:pPr>
+                      <a:r>
+                        <a:rPr lang="en-US" sz="1200" b="1" dirty="0">
+                          <a:solidFill>
+                            <a:schemeClr val="bg1"/>
+                          </a:solidFill>
+                        </a:rPr>
+                        <a:t>URL</a:t>
+                      </a:r>
+                      <a:endParaRPr lang="en-US" sz="1200" dirty="0"/>
+                    </a:p>
+                  </a:txBody>
+                  <a:tcPr marL="91440" marR="91440" marT="18288" marB="18288" anchor="ctr">
+                    <a:lnL w="6350" cap="flat" cmpd="sng" algn="ctr">
+                      <a:solidFill>
+                        <a:schemeClr val="bg2"/>
+                      </a:solidFill>
+                      <a:prstDash val="solid"/>
+                      <a:round/>
+                      <a:headEnd type="none" w="med" len="med"/>
+                      <a:tailEnd type="none" w="med" len="med"/>
+                    </a:lnL>
+                    <a:lnR w="6350" cap="flat" cmpd="sng" algn="ctr">
+                      <a:solidFill>
+                        <a:schemeClr val="bg2"/>
+                      </a:solidFill>
+                      <a:prstDash val="solid"/>
+                      <a:round/>
+                      <a:headEnd type="none" w="med" len="med"/>
+                      <a:tailEnd type="none" w="med" len="med"/>
+                    </a:lnR>
+                    <a:lnT w="6350" cap="flat" cmpd="sng" algn="ctr">
+                      <a:solidFill>
+                        <a:schemeClr val="bg2"/>
+                      </a:solidFill>
+                      <a:prstDash val="solid"/>
+                      <a:round/>
+                      <a:headEnd type="none" w="med" len="med"/>
+                      <a:tailEnd type="none" w="med" len="med"/>
+                    </a:lnT>
+                    <a:lnB w="6350" cap="flat" cmpd="sng" algn="ctr">
+                      <a:solidFill>
+                        <a:schemeClr val="bg2"/>
+                      </a:solidFill>
+                      <a:prstDash val="solid"/>
+                      <a:round/>
+                      <a:headEnd type="none" w="med" len="med"/>
+                      <a:tailEnd type="none" w="med" len="med"/>
+                    </a:lnB>
+                    <a:solidFill>
+                      <a:schemeClr val="tx2"/>
+                    </a:solidFill>
+                  </a:tcPr>
+                </a:tc>
+              </a:tr>
+              <a:tr h="384048">
+                <a:tc>
+                  <a:txBody>
+                    <a:bodyPr/>
+                    <a:lstStyle/>
+                    <a:p>
+                      <a:pPr indent="0" marL="0">
+                        <a:buNone/>
+                      </a:pPr>
+                      <a:r>
+                        <a:rPr lang="en-US" sz="1200" b="1" dirty="0">
+                          <a:solidFill>
+                            <a:schemeClr val="tx2"/>
+                          </a:solidFill>
+                        </a:rPr>
+                        <a:t>Lending API</a:t>
+                      </a:r>
+                      <a:endParaRPr lang="en-US" sz="1200" dirty="0"/>
+                    </a:p>
+                  </a:txBody>
+                  <a:tcPr marL="91440" marR="91440" marT="18288" marB="18288" anchor="ctr">
+                    <a:lnL w="6350" cap="flat" cmpd="sng" algn="ctr">
+                      <a:solidFill>
+                        <a:schemeClr val="bg2"/>
+                      </a:solidFill>
+                      <a:prstDash val="solid"/>
+                      <a:round/>
+                      <a:headEnd type="none" w="med" len="med"/>
+                      <a:tailEnd type="none" w="med" len="med"/>
+                    </a:lnL>
+                    <a:lnR w="6350" cap="flat" cmpd="sng" algn="ctr">
+                      <a:solidFill>
+                        <a:schemeClr val="bg2"/>
+                      </a:solidFill>
+                      <a:prstDash val="solid"/>
+                      <a:round/>
+                      <a:headEnd type="none" w="med" len="med"/>
+                      <a:tailEnd type="none" w="med" len="med"/>
+                    </a:lnR>
+                    <a:lnT w="6350" cap="flat" cmpd="sng" algn="ctr">
+                      <a:solidFill>
+                        <a:schemeClr val="bg2"/>
+                      </a:solidFill>
+                      <a:prstDash val="solid"/>
+                      <a:round/>
+                      <a:headEnd type="none" w="med" len="med"/>
+                      <a:tailEnd type="none" w="med" len="med"/>
+                    </a:lnT>
+                    <a:lnB w="6350" cap="flat" cmpd="sng" algn="ctr">
+                      <a:solidFill>
+                        <a:schemeClr val="bg2"/>
+                      </a:solidFill>
+                      <a:prstDash val="solid"/>
+                      <a:round/>
+                      <a:headEnd type="none" w="med" len="med"/>
+                      <a:tailEnd type="none" w="med" len="med"/>
+                    </a:lnB>
+                    <a:solidFill>
+                      <a:schemeClr val="bg2"/>
+                    </a:solidFill>
+                  </a:tcPr>
+                </a:tc>
+                <a:tc>
+                  <a:txBody>
+                    <a:bodyPr/>
+                    <a:lstStyle/>
+                    <a:p>
+                      <a:pPr indent="0" marL="0">
+                        <a:buNone/>
+                      </a:pPr>
+                      <a:r>
+                        <a:rPr lang="en-US" sz="1100" dirty="0">
+                          <a:solidFill>
+                            <a:srgbClr val="000000"/>
+                          </a:solidFill>
+                          <a:latin typeface="Courier New" pitchFamily="34" charset="0"/>
+                          <a:ea typeface="Courier New" pitchFamily="34" charset="-122"/>
+                          <a:cs typeface="Courier New" pitchFamily="34" charset="-120"/>
+                        </a:rPr>
+                        <a:t>https://lending-service-5tqm.onrender.com</a:t>
+                      </a:r>
+                      <a:endParaRPr lang="en-US" sz="1100" dirty="0">
+                        <a:latin typeface="Courier New" charset="0"/>
+                        <a:ea typeface="Courier New" charset="0"/>
+                        <a:cs typeface="Courier New" charset="0"/>
+                      </a:endParaRPr>
+                    </a:p>
+                  </a:txBody>
+                  <a:tcPr marL="91440" marR="91440" marT="18288" marB="18288" anchor="ctr">
+                    <a:lnL w="6350" cap="flat" cmpd="sng" algn="ctr">
+                      <a:solidFill>
+                        <a:schemeClr val="bg2"/>
+                      </a:solidFill>
+                      <a:prstDash val="solid"/>
+                      <a:round/>
+                      <a:headEnd type="none" w="med" len="med"/>
+                      <a:tailEnd type="none" w="med" len="med"/>
+                    </a:lnL>
+                    <a:lnR w="6350" cap="flat" cmpd="sng" algn="ctr">
+                      <a:solidFill>
+                        <a:schemeClr val="bg2"/>
+                      </a:solidFill>
+                      <a:prstDash val="solid"/>
+                      <a:round/>
+                      <a:headEnd type="none" w="med" len="med"/>
+                      <a:tailEnd type="none" w="med" len="med"/>
+                    </a:lnR>
+                    <a:lnT w="6350" cap="flat" cmpd="sng" algn="ctr">
+                      <a:solidFill>
+                        <a:schemeClr val="bg2"/>
+                      </a:solidFill>
+                      <a:prstDash val="solid"/>
+                      <a:round/>
+                      <a:headEnd type="none" w="med" len="med"/>
+                      <a:tailEnd type="none" w="med" len="med"/>
+                    </a:lnT>
+                    <a:lnB w="6350" cap="flat" cmpd="sng" algn="ctr">
+                      <a:solidFill>
+                        <a:schemeClr val="bg2"/>
+                      </a:solidFill>
+                      <a:prstDash val="solid"/>
+                      <a:round/>
+                      <a:headEnd type="none" w="med" len="med"/>
+                      <a:tailEnd type="none" w="med" len="med"/>
+                    </a:lnB>
+                    <a:solidFill>
+                      <a:schemeClr val="bg2"/>
+                    </a:solidFill>
+                  </a:tcPr>
+                </a:tc>
+              </a:tr>
+              <a:tr h="384048">
+                <a:tc>
+                  <a:txBody>
+                    <a:bodyPr/>
+                    <a:lstStyle/>
+                    <a:p>
+                      <a:pPr indent="0" marL="0">
+                        <a:buNone/>
+                      </a:pPr>
+                      <a:r>
+                        <a:rPr lang="en-US" sz="1200" b="1" dirty="0">
+                          <a:solidFill>
+                            <a:schemeClr val="tx2"/>
+                          </a:solidFill>
+                        </a:rPr>
+                        <a:t>Lending Swagger</a:t>
+                      </a:r>
+                      <a:endParaRPr lang="en-US" sz="1200" dirty="0"/>
+                    </a:p>
+                  </a:txBody>
+                  <a:tcPr marL="91440" marR="91440" marT="18288" marB="18288" anchor="ctr">
+                    <a:lnL w="6350" cap="flat" cmpd="sng" algn="ctr">
+                      <a:solidFill>
+                        <a:schemeClr val="bg2"/>
+                      </a:solidFill>
+                      <a:prstDash val="solid"/>
+                      <a:round/>
+                      <a:headEnd type="none" w="med" len="med"/>
+                      <a:tailEnd type="none" w="med" len="med"/>
+                    </a:lnL>
+                    <a:lnR w="6350" cap="flat" cmpd="sng" algn="ctr">
+                      <a:solidFill>
+                        <a:schemeClr val="bg2"/>
+                      </a:solidFill>
+                      <a:prstDash val="solid"/>
+                      <a:round/>
+                      <a:headEnd type="none" w="med" len="med"/>
+                      <a:tailEnd type="none" w="med" len="med"/>
+                    </a:lnR>
+                    <a:lnT w="6350" cap="flat" cmpd="sng" algn="ctr">
+                      <a:solidFill>
+                        <a:schemeClr val="bg2"/>
+                      </a:solidFill>
+                      <a:prstDash val="solid"/>
+                      <a:round/>
+                      <a:headEnd type="none" w="med" len="med"/>
+                      <a:tailEnd type="none" w="med" len="med"/>
+                    </a:lnT>
+                    <a:lnB w="6350" cap="flat" cmpd="sng" algn="ctr">
+                      <a:solidFill>
+                        <a:schemeClr val="bg2"/>
+                      </a:solidFill>
+                      <a:prstDash val="solid"/>
+                      <a:round/>
+                      <a:headEnd type="none" w="med" len="med"/>
+                      <a:tailEnd type="none" w="med" len="med"/>
+                    </a:lnB>
+                    <a:solidFill>
+                      <a:schemeClr val="bg1"/>
+                    </a:solidFill>
+                  </a:tcPr>
+                </a:tc>
+                <a:tc>
+                  <a:txBody>
+                    <a:bodyPr/>
+                    <a:lstStyle/>
+                    <a:p>
+                      <a:pPr indent="0" marL="0">
+                        <a:buNone/>
+                      </a:pPr>
+                      <a:r>
+                        <a:rPr lang="en-US" sz="1100" dirty="0">
+                          <a:solidFill>
+                            <a:srgbClr val="000000"/>
+                          </a:solidFill>
+                          <a:latin typeface="Courier New" pitchFamily="34" charset="0"/>
+                          <a:ea typeface="Courier New" pitchFamily="34" charset="-122"/>
+                          <a:cs typeface="Courier New" pitchFamily="34" charset="-120"/>
+                        </a:rPr>
+                        <a:t>https://lending-service-5tqm.onrender.com/swagger-ui.html</a:t>
+                      </a:r>
+                      <a:endParaRPr lang="en-US" sz="1100" dirty="0">
+                        <a:latin typeface="Courier New" charset="0"/>
+                        <a:ea typeface="Courier New" charset="0"/>
+                        <a:cs typeface="Courier New" charset="0"/>
+                      </a:endParaRPr>
+                    </a:p>
+                  </a:txBody>
+                  <a:tcPr marL="91440" marR="91440" marT="18288" marB="18288" anchor="ctr">
+                    <a:lnL w="6350" cap="flat" cmpd="sng" algn="ctr">
+                      <a:solidFill>
+                        <a:schemeClr val="bg2"/>
+                      </a:solidFill>
+                      <a:prstDash val="solid"/>
+                      <a:round/>
+                      <a:headEnd type="none" w="med" len="med"/>
+                      <a:tailEnd type="none" w="med" len="med"/>
+                    </a:lnL>
+                    <a:lnR w="6350" cap="flat" cmpd="sng" algn="ctr">
+                      <a:solidFill>
+                        <a:schemeClr val="bg2"/>
+                      </a:solidFill>
+                      <a:prstDash val="solid"/>
+                      <a:round/>
+                      <a:headEnd type="none" w="med" len="med"/>
+                      <a:tailEnd type="none" w="med" len="med"/>
+                    </a:lnR>
+                    <a:lnT w="6350" cap="flat" cmpd="sng" algn="ctr">
+                      <a:solidFill>
+                        <a:schemeClr val="bg2"/>
+                      </a:solidFill>
+                      <a:prstDash val="solid"/>
+                      <a:round/>
+                      <a:headEnd type="none" w="med" len="med"/>
+                      <a:tailEnd type="none" w="med" len="med"/>
+                    </a:lnT>
+                    <a:lnB w="6350" cap="flat" cmpd="sng" algn="ctr">
+                      <a:solidFill>
+                        <a:schemeClr val="bg2"/>
+                      </a:solidFill>
+                      <a:prstDash val="solid"/>
+                      <a:round/>
+                      <a:headEnd type="none" w="med" len="med"/>
+                      <a:tailEnd type="none" w="med" len="med"/>
+                    </a:lnB>
+                    <a:solidFill>
+                      <a:schemeClr val="bg1"/>
+                    </a:solidFill>
+                  </a:tcPr>
+                </a:tc>
+              </a:tr>
+              <a:tr h="384048">
+                <a:tc>
+                  <a:txBody>
+                    <a:bodyPr/>
+                    <a:lstStyle/>
+                    <a:p>
+                      <a:pPr indent="0" marL="0">
+                        <a:buNone/>
+                      </a:pPr>
+                      <a:r>
+                        <a:rPr lang="en-US" sz="1200" b="1" dirty="0">
+                          <a:solidFill>
+                            <a:schemeClr val="tx2"/>
+                          </a:solidFill>
+                        </a:rPr>
+                        <a:t>Admin portal</a:t>
+                      </a:r>
+                      <a:endParaRPr lang="en-US" sz="1200" dirty="0"/>
+                    </a:p>
+                  </a:txBody>
+                  <a:tcPr marL="91440" marR="91440" marT="18288" marB="18288" anchor="ctr">
+                    <a:lnL w="6350" cap="flat" cmpd="sng" algn="ctr">
+                      <a:solidFill>
+                        <a:schemeClr val="bg2"/>
+                      </a:solidFill>
+                      <a:prstDash val="solid"/>
+                      <a:round/>
+                      <a:headEnd type="none" w="med" len="med"/>
+                      <a:tailEnd type="none" w="med" len="med"/>
+                    </a:lnL>
+                    <a:lnR w="6350" cap="flat" cmpd="sng" algn="ctr">
+                      <a:solidFill>
+                        <a:schemeClr val="bg2"/>
+                      </a:solidFill>
+                      <a:prstDash val="solid"/>
+                      <a:round/>
+                      <a:headEnd type="none" w="med" len="med"/>
+                      <a:tailEnd type="none" w="med" len="med"/>
+                    </a:lnR>
+                    <a:lnT w="6350" cap="flat" cmpd="sng" algn="ctr">
+                      <a:solidFill>
+                        <a:schemeClr val="bg2"/>
+                      </a:solidFill>
+                      <a:prstDash val="solid"/>
+                      <a:round/>
+                      <a:headEnd type="none" w="med" len="med"/>
+                      <a:tailEnd type="none" w="med" len="med"/>
+                    </a:lnT>
+                    <a:lnB w="6350" cap="flat" cmpd="sng" algn="ctr">
+                      <a:solidFill>
+                        <a:schemeClr val="bg2"/>
+                      </a:solidFill>
+                      <a:prstDash val="solid"/>
+                      <a:round/>
+                      <a:headEnd type="none" w="med" len="med"/>
+                      <a:tailEnd type="none" w="med" len="med"/>
+                    </a:lnB>
+                    <a:solidFill>
+                      <a:schemeClr val="bg2"/>
+                    </a:solidFill>
+                  </a:tcPr>
+                </a:tc>
+                <a:tc>
+                  <a:txBody>
+                    <a:bodyPr/>
+                    <a:lstStyle/>
+                    <a:p>
+                      <a:pPr indent="0" marL="0">
+                        <a:buNone/>
+                      </a:pPr>
+                      <a:r>
+                        <a:rPr lang="en-US" sz="1100" dirty="0">
+                          <a:solidFill>
+                            <a:srgbClr val="000000"/>
+                          </a:solidFill>
+                          <a:latin typeface="Courier New" pitchFamily="34" charset="0"/>
+                          <a:ea typeface="Courier New" pitchFamily="34" charset="-122"/>
+                          <a:cs typeface="Courier New" pitchFamily="34" charset="-120"/>
+                        </a:rPr>
+                        <a:t>https://lending-admin-service-&lt;suffix&gt;.onrender.com</a:t>
+                      </a:r>
+                      <a:endParaRPr lang="en-US" sz="1100" dirty="0">
+                        <a:latin typeface="Courier New" charset="0"/>
+                        <a:ea typeface="Courier New" charset="0"/>
+                        <a:cs typeface="Courier New" charset="0"/>
+                      </a:endParaRPr>
+                    </a:p>
+                  </a:txBody>
+                  <a:tcPr marL="91440" marR="91440" marT="18288" marB="18288" anchor="ctr">
+                    <a:lnL w="6350" cap="flat" cmpd="sng" algn="ctr">
+                      <a:solidFill>
+                        <a:schemeClr val="bg2"/>
+                      </a:solidFill>
+                      <a:prstDash val="solid"/>
+                      <a:round/>
+                      <a:headEnd type="none" w="med" len="med"/>
+                      <a:tailEnd type="none" w="med" len="med"/>
+                    </a:lnL>
+                    <a:lnR w="6350" cap="flat" cmpd="sng" algn="ctr">
+                      <a:solidFill>
+                        <a:schemeClr val="bg2"/>
+                      </a:solidFill>
+                      <a:prstDash val="solid"/>
+                      <a:round/>
+                      <a:headEnd type="none" w="med" len="med"/>
+                      <a:tailEnd type="none" w="med" len="med"/>
+                    </a:lnR>
+                    <a:lnT w="6350" cap="flat" cmpd="sng" algn="ctr">
+                      <a:solidFill>
+                        <a:schemeClr val="bg2"/>
+                      </a:solidFill>
+                      <a:prstDash val="solid"/>
+                      <a:round/>
+                      <a:headEnd type="none" w="med" len="med"/>
+                      <a:tailEnd type="none" w="med" len="med"/>
+                    </a:lnT>
+                    <a:lnB w="6350" cap="flat" cmpd="sng" algn="ctr">
+                      <a:solidFill>
+                        <a:schemeClr val="bg2"/>
+                      </a:solidFill>
+                      <a:prstDash val="solid"/>
+                      <a:round/>
+                      <a:headEnd type="none" w="med" len="med"/>
+                      <a:tailEnd type="none" w="med" len="med"/>
+                    </a:lnB>
+                    <a:solidFill>
+                      <a:schemeClr val="bg2"/>
+                    </a:solidFill>
+                  </a:tcPr>
+                </a:tc>
+              </a:tr>
+              <a:tr h="384048">
+                <a:tc>
+                  <a:txBody>
+                    <a:bodyPr/>
+                    <a:lstStyle/>
+                    <a:p>
+                      <a:pPr indent="0" marL="0">
+                        <a:buNone/>
+                      </a:pPr>
+                      <a:r>
+                        <a:rPr lang="en-US" sz="1200" b="1" dirty="0">
+                          <a:solidFill>
+                            <a:schemeClr val="tx2"/>
+                          </a:solidFill>
+                        </a:rPr>
+                        <a:t>Admin Swagger</a:t>
+                      </a:r>
+                      <a:endParaRPr lang="en-US" sz="1200" dirty="0"/>
+                    </a:p>
+                  </a:txBody>
+                  <a:tcPr marL="91440" marR="91440" marT="18288" marB="18288" anchor="ctr">
+                    <a:lnL w="6350" cap="flat" cmpd="sng" algn="ctr">
+                      <a:solidFill>
+                        <a:schemeClr val="bg2"/>
+                      </a:solidFill>
+                      <a:prstDash val="solid"/>
+                      <a:round/>
+                      <a:headEnd type="none" w="med" len="med"/>
+                      <a:tailEnd type="none" w="med" len="med"/>
+                    </a:lnL>
+                    <a:lnR w="6350" cap="flat" cmpd="sng" algn="ctr">
+                      <a:solidFill>
+                        <a:schemeClr val="bg2"/>
+                      </a:solidFill>
+                      <a:prstDash val="solid"/>
+                      <a:round/>
+                      <a:headEnd type="none" w="med" len="med"/>
+                      <a:tailEnd type="none" w="med" len="med"/>
+                    </a:lnR>
+                    <a:lnT w="6350" cap="flat" cmpd="sng" algn="ctr">
+                      <a:solidFill>
+                        <a:schemeClr val="bg2"/>
+                      </a:solidFill>
+                      <a:prstDash val="solid"/>
+                      <a:round/>
+                      <a:headEnd type="none" w="med" len="med"/>
+                      <a:tailEnd type="none" w="med" len="med"/>
+                    </a:lnT>
+                    <a:lnB w="6350" cap="flat" cmpd="sng" algn="ctr">
+                      <a:solidFill>
+                        <a:schemeClr val="bg2"/>
+                      </a:solidFill>
+                      <a:prstDash val="solid"/>
+                      <a:round/>
+                      <a:headEnd type="none" w="med" len="med"/>
+                      <a:tailEnd type="none" w="med" len="med"/>
+                    </a:lnB>
+                    <a:solidFill>
+                      <a:schemeClr val="bg1"/>
+                    </a:solidFill>
+                  </a:tcPr>
+                </a:tc>
+                <a:tc>
+                  <a:txBody>
+                    <a:bodyPr/>
+                    <a:lstStyle/>
+                    <a:p>
+                      <a:pPr indent="0" marL="0">
+                        <a:buNone/>
+                      </a:pPr>
+                      <a:r>
+                        <a:rPr lang="en-US" sz="1100" dirty="0">
+                          <a:solidFill>
+                            <a:srgbClr val="000000"/>
+                          </a:solidFill>
+                          <a:latin typeface="Courier New" pitchFamily="34" charset="0"/>
+                          <a:ea typeface="Courier New" pitchFamily="34" charset="-122"/>
+                          <a:cs typeface="Courier New" pitchFamily="34" charset="-120"/>
+                        </a:rPr>
+                        <a:t>https://lending-admin-service-&lt;suffix&gt;.onrender.com/swagger-ui.html</a:t>
+                      </a:r>
+                      <a:endParaRPr lang="en-US" sz="1100" dirty="0">
+                        <a:latin typeface="Courier New" charset="0"/>
+                        <a:ea typeface="Courier New" charset="0"/>
+                        <a:cs typeface="Courier New" charset="0"/>
+                      </a:endParaRPr>
+                    </a:p>
+                  </a:txBody>
+                  <a:tcPr marL="91440" marR="91440" marT="18288" marB="18288" anchor="ctr">
+                    <a:lnL w="6350" cap="flat" cmpd="sng" algn="ctr">
+                      <a:solidFill>
+                        <a:schemeClr val="bg2"/>
+                      </a:solidFill>
+                      <a:prstDash val="solid"/>
+                      <a:round/>
+                      <a:headEnd type="none" w="med" len="med"/>
+                      <a:tailEnd type="none" w="med" len="med"/>
+                    </a:lnL>
+                    <a:lnR w="6350" cap="flat" cmpd="sng" algn="ctr">
+                      <a:solidFill>
+                        <a:schemeClr val="bg2"/>
+                      </a:solidFill>
+                      <a:prstDash val="solid"/>
+                      <a:round/>
+                      <a:headEnd type="none" w="med" len="med"/>
+                      <a:tailEnd type="none" w="med" len="med"/>
+                    </a:lnR>
+                    <a:lnT w="6350" cap="flat" cmpd="sng" algn="ctr">
+                      <a:solidFill>
+                        <a:schemeClr val="bg2"/>
+                      </a:solidFill>
+                      <a:prstDash val="solid"/>
+                      <a:round/>
+                      <a:headEnd type="none" w="med" len="med"/>
+                      <a:tailEnd type="none" w="med" len="med"/>
+                    </a:lnT>
+                    <a:lnB w="6350" cap="flat" cmpd="sng" algn="ctr">
+                      <a:solidFill>
+                        <a:schemeClr val="bg2"/>
+                      </a:solidFill>
+                      <a:prstDash val="solid"/>
+                      <a:round/>
+                      <a:headEnd type="none" w="med" len="med"/>
+                      <a:tailEnd type="none" w="med" len="med"/>
+                    </a:lnB>
+                    <a:solidFill>
+                      <a:schemeClr val="bg1"/>
+                    </a:solidFill>
+                  </a:tcPr>
+                </a:tc>
+              </a:tr>
+            </a:tbl>
+          </a:graphicData>
+        </a:graphic>
+      </p:graphicFrame>
+      <p:sp>
+        <p:nvSpPr>
+          <p:cNvPr id="6" name="Text 2"/>
+          <p:cNvSpPr txBox="1"/>
+          <p:nvPr/>
+        </p:nvSpPr>
+        <p:spPr>
+          <a:xfrm>
+            <a:off x="548640" y="3611880"/>
+            <a:ext cx="10972800" cy="320040"/>
+          </a:xfrm>
+          <a:prstGeom prst="rect">
+            <a:avLst/>
+          </a:prstGeom>
+          <a:noFill/>
+          <a:ln/>
+        </p:spPr>
+        <p:txBody>
+          <a:bodyPr wrap="square" lIns="0" tIns="0" rIns="0" bIns="0" rtlCol="0" anchor="t"/>
+          <a:lstStyle/>
+          <a:p>
+            <a:pPr indent="0" marL="0">
+              <a:buNone/>
+            </a:pPr>
+            <a:r>
+              <a:rPr lang="en-US" sz="1600" b="1" dirty="0">
+                <a:solidFill>
+                  <a:schemeClr val="tx2"/>
+                </a:solidFill>
+              </a:rPr>
+              <a:t>Added since the first documents (2 September)</a:t>
+            </a:r>
+            <a:endParaRPr lang="en-US" sz="1600" dirty="0"/>
+          </a:p>
+        </p:txBody>
+      </p:sp>
+      <p:sp>
+        <p:nvSpPr>
+          <p:cNvPr id="7" name="Text 3"/>
+          <p:cNvSpPr txBox="1"/>
+          <p:nvPr/>
+        </p:nvSpPr>
+        <p:spPr>
+          <a:xfrm>
+            <a:off x="548640" y="4069080"/>
+            <a:ext cx="3566160" cy="914400"/>
+          </a:xfrm>
+          <a:prstGeom prst="roundRect">
+            <a:avLst>
+              <a:gd name="adj" fmla="val 8000"/>
+            </a:avLst>
+          </a:prstGeom>
+          <a:solidFill>
+            <a:schemeClr val="accent1">
+              <a:alpha val="10000"/>
+            </a:schemeClr>
+          </a:solidFill>
+          <a:ln w="12700">
+            <a:solidFill>
+              <a:schemeClr val="accent1"/>
+            </a:solidFill>
+          </a:ln>
+        </p:spPr>
+        <p:txBody>
+          <a:bodyPr wrap="square" lIns="101600" tIns="101600" rIns="101600" bIns="101600" rtlCol="0" anchor="t"/>
+          <a:lstStyle/>
+          <a:p>
+            <a:pPr algn="l" indent="0" marL="0">
+              <a:buNone/>
+            </a:pPr>
+            <a:r>
+              <a:rPr lang="en-US" sz="1400" b="1" dirty="0">
+                <a:solidFill>
+                  <a:schemeClr val="tx2"/>
+                </a:solidFill>
+              </a:rPr>
+              <a:t>Admin portal</a:t>
+            </a:r>
+            <a:endParaRPr lang="en-US" sz="1200" dirty="0"/>
+          </a:p>
+          <a:p>
+            <a:pPr algn="l" indent="0" marL="0">
+              <a:buNone/>
+            </a:pPr>
+            <a:r>
+              <a:rPr lang="en-US" sz="1200" dirty="0">
+                <a:solidFill>
+                  <a:schemeClr val="tx1"/>
+                </a:solidFill>
+              </a:rPr>
+              <a:t>New read-only React + Spring Boot service</a:t>
+            </a:r>
+            <a:endParaRPr lang="en-US" sz="1200" dirty="0"/>
+          </a:p>
+        </p:txBody>
+      </p:sp>
+      <p:sp>
+        <p:nvSpPr>
+          <p:cNvPr id="8" name="Text 4"/>
+          <p:cNvSpPr txBox="1"/>
+          <p:nvPr/>
+        </p:nvSpPr>
+        <p:spPr>
+          <a:xfrm>
+            <a:off x="4297680" y="4069080"/>
+            <a:ext cx="3566160" cy="914400"/>
+          </a:xfrm>
+          <a:prstGeom prst="roundRect">
+            <a:avLst>
+              <a:gd name="adj" fmla="val 8000"/>
+            </a:avLst>
+          </a:prstGeom>
+          <a:solidFill>
+            <a:schemeClr val="accent1">
+              <a:alpha val="10000"/>
+            </a:schemeClr>
+          </a:solidFill>
+          <a:ln w="12700">
+            <a:solidFill>
+              <a:schemeClr val="accent1"/>
+            </a:solidFill>
+          </a:ln>
+        </p:spPr>
+        <p:txBody>
+          <a:bodyPr wrap="square" lIns="101600" tIns="101600" rIns="101600" bIns="101600" rtlCol="0" anchor="t"/>
+          <a:lstStyle/>
+          <a:p>
+            <a:pPr algn="l" indent="0" marL="0">
+              <a:buNone/>
+            </a:pPr>
+            <a:r>
+              <a:rPr lang="en-US" sz="1400" b="1" dirty="0">
+                <a:solidFill>
+                  <a:schemeClr val="tx2"/>
+                </a:solidFill>
+              </a:rPr>
+              <a:t>PDF statement</a:t>
+            </a:r>
+            <a:endParaRPr lang="en-US" sz="1200" dirty="0"/>
+          </a:p>
+          <a:p>
+            <a:pPr algn="l" indent="0" marL="0">
+              <a:buNone/>
+            </a:pPr>
+            <a:r>
+              <a:rPr lang="en-US" sz="1200" dirty="0">
+                <a:solidFill>
+                  <a:schemeClr val="tx1"/>
+                </a:solidFill>
+              </a:rPr>
+              <a:t>Two GET endpoints, OpenPDF</a:t>
+            </a:r>
+            <a:endParaRPr lang="en-US" sz="1200" dirty="0"/>
+          </a:p>
+        </p:txBody>
+      </p:sp>
+      <p:sp>
+        <p:nvSpPr>
+          <p:cNvPr id="9" name="Text 5"/>
+          <p:cNvSpPr txBox="1"/>
+          <p:nvPr/>
+        </p:nvSpPr>
+        <p:spPr>
+          <a:xfrm>
+            <a:off x="8046720" y="4069080"/>
+            <a:ext cx="3566160" cy="914400"/>
+          </a:xfrm>
+          <a:prstGeom prst="roundRect">
+            <a:avLst>
+              <a:gd name="adj" fmla="val 8000"/>
+            </a:avLst>
+          </a:prstGeom>
+          <a:solidFill>
+            <a:schemeClr val="accent1">
+              <a:alpha val="10000"/>
+            </a:schemeClr>
+          </a:solidFill>
+          <a:ln w="12700">
+            <a:solidFill>
+              <a:schemeClr val="accent1"/>
+            </a:solidFill>
+          </a:ln>
+        </p:spPr>
+        <p:txBody>
+          <a:bodyPr wrap="square" lIns="101600" tIns="101600" rIns="101600" bIns="101600" rtlCol="0" anchor="t"/>
+          <a:lstStyle/>
+          <a:p>
+            <a:pPr algn="l" indent="0" marL="0">
+              <a:buNone/>
+            </a:pPr>
+            <a:r>
+              <a:rPr lang="en-US" sz="1400" b="1" dirty="0">
+                <a:solidFill>
+                  <a:schemeClr val="tx2"/>
+                </a:solidFill>
+              </a:rPr>
+              <a:t>Bulk operations</a:t>
+            </a:r>
+            <a:endParaRPr lang="en-US" sz="1200" dirty="0"/>
+          </a:p>
+          <a:p>
+            <a:pPr algn="l" indent="0" marL="0">
+              <a:buNone/>
+            </a:pPr>
+            <a:r>
+              <a:rPr lang="en-US" sz="1200" dirty="0">
+                <a:solidFill>
+                  <a:schemeClr val="tx1"/>
+                </a:solidFill>
+              </a:rPr>
+              <a:t>Create and disburse up to 200 per call</a:t>
+            </a:r>
+            <a:endParaRPr lang="en-US" sz="1200" dirty="0"/>
+          </a:p>
+        </p:txBody>
+      </p:sp>
+      <p:sp>
+        <p:nvSpPr>
+          <p:cNvPr id="10" name="Text 6"/>
+          <p:cNvSpPr txBox="1"/>
+          <p:nvPr/>
+        </p:nvSpPr>
+        <p:spPr>
+          <a:xfrm>
+            <a:off x="548640" y="5166360"/>
+            <a:ext cx="3566160" cy="914400"/>
+          </a:xfrm>
+          <a:prstGeom prst="roundRect">
+            <a:avLst>
+              <a:gd name="adj" fmla="val 8000"/>
+            </a:avLst>
+          </a:prstGeom>
+          <a:solidFill>
+            <a:schemeClr val="accent1">
+              <a:alpha val="10000"/>
+            </a:schemeClr>
+          </a:solidFill>
+          <a:ln w="12700">
+            <a:solidFill>
+              <a:schemeClr val="accent1"/>
+            </a:solidFill>
+          </a:ln>
+        </p:spPr>
+        <p:txBody>
+          <a:bodyPr wrap="square" lIns="101600" tIns="101600" rIns="101600" bIns="101600" rtlCol="0" anchor="t"/>
+          <a:lstStyle/>
+          <a:p>
+            <a:pPr algn="l" indent="0" marL="0">
+              <a:buNone/>
+            </a:pPr>
+            <a:r>
+              <a:rPr lang="en-US" sz="1400" b="1" dirty="0">
+                <a:solidFill>
+                  <a:schemeClr val="tx2"/>
+                </a:solidFill>
+              </a:rPr>
+              <a:t>Partition fix (V9)</a:t>
+            </a:r>
+            <a:endParaRPr lang="en-US" sz="1200" dirty="0"/>
+          </a:p>
+          <a:p>
+            <a:pPr algn="l" indent="0" marL="0">
+              <a:buNone/>
+            </a:pPr>
+            <a:r>
+              <a:rPr lang="en-US" sz="1200" dirty="0">
+                <a:solidFill>
+                  <a:schemeClr val="tx1"/>
+                </a:solidFill>
+              </a:rPr>
+              <a:t>Ends 409 on accrual and EMI posting; auto-creates months</a:t>
+            </a:r>
+            <a:endParaRPr lang="en-US" sz="1200" dirty="0"/>
+          </a:p>
+        </p:txBody>
+      </p:sp>
+      <p:sp>
+        <p:nvSpPr>
+          <p:cNvPr id="11" name="Text 7"/>
+          <p:cNvSpPr txBox="1"/>
+          <p:nvPr/>
+        </p:nvSpPr>
+        <p:spPr>
+          <a:xfrm>
+            <a:off x="4297680" y="5166360"/>
+            <a:ext cx="3566160" cy="914400"/>
+          </a:xfrm>
+          <a:prstGeom prst="roundRect">
+            <a:avLst>
+              <a:gd name="adj" fmla="val 8000"/>
+            </a:avLst>
+          </a:prstGeom>
+          <a:solidFill>
+            <a:schemeClr val="accent1">
+              <a:alpha val="10000"/>
+            </a:schemeClr>
+          </a:solidFill>
+          <a:ln w="12700">
+            <a:solidFill>
+              <a:schemeClr val="accent1"/>
+            </a:solidFill>
+          </a:ln>
+        </p:spPr>
+        <p:txBody>
+          <a:bodyPr wrap="square" lIns="101600" tIns="101600" rIns="101600" bIns="101600" rtlCol="0" anchor="t"/>
+          <a:lstStyle/>
+          <a:p>
+            <a:pPr algn="l" indent="0" marL="0">
+              <a:buNone/>
+            </a:pPr>
+            <a:r>
+              <a:rPr lang="en-US" sz="1400" b="1" dirty="0">
+                <a:solidFill>
+                  <a:schemeClr val="tx2"/>
+                </a:solidFill>
+              </a:rPr>
+              <a:t>Scripts and samples</a:t>
+            </a:r>
+            <a:endParaRPr lang="en-US" sz="1200" dirty="0"/>
+          </a:p>
+          <a:p>
+            <a:pPr algn="l" indent="0" marL="0">
+              <a:buNone/>
+            </a:pPr>
+            <a:r>
+              <a:rPr lang="en-US" sz="1200" dirty="0">
+                <a:solidFill>
+                  <a:schemeClr val="tx1"/>
+                </a:solidFill>
+              </a:rPr>
+              <a:t>create-account, run-accrual, bulk JSON</a:t>
+            </a:r>
+            <a:endParaRPr lang="en-US" sz="1200" dirty="0"/>
+          </a:p>
+        </p:txBody>
+      </p:sp>
+      <p:sp>
+        <p:nvSpPr>
+          <p:cNvPr id="12" name="Text 8"/>
+          <p:cNvSpPr txBox="1"/>
+          <p:nvPr/>
+        </p:nvSpPr>
+        <p:spPr>
+          <a:xfrm>
+            <a:off x="8046720" y="5166360"/>
+            <a:ext cx="3566160" cy="914400"/>
+          </a:xfrm>
+          <a:prstGeom prst="roundRect">
+            <a:avLst>
+              <a:gd name="adj" fmla="val 8000"/>
+            </a:avLst>
+          </a:prstGeom>
+          <a:solidFill>
+            <a:schemeClr val="accent1">
+              <a:alpha val="10000"/>
+            </a:schemeClr>
+          </a:solidFill>
+          <a:ln w="12700">
+            <a:solidFill>
+              <a:schemeClr val="accent1"/>
+            </a:solidFill>
+          </a:ln>
+        </p:spPr>
+        <p:txBody>
+          <a:bodyPr wrap="square" lIns="101600" tIns="101600" rIns="101600" bIns="101600" rtlCol="0" anchor="t"/>
+          <a:lstStyle/>
+          <a:p>
+            <a:pPr algn="l" indent="0" marL="0">
+              <a:buNone/>
+            </a:pPr>
+            <a:r>
+              <a:rPr lang="en-US" sz="1400" b="1" dirty="0">
+                <a:solidFill>
+                  <a:schemeClr val="tx2"/>
+                </a:solidFill>
+              </a:rPr>
+              <a:t>Render blueprint</a:t>
+            </a:r>
+            <a:endParaRPr lang="en-US" sz="1200" dirty="0"/>
+          </a:p>
+          <a:p>
+            <a:pPr algn="l" indent="0" marL="0">
+              <a:buNone/>
+            </a:pPr>
+            <a:r>
+              <a:rPr lang="en-US" sz="1200" dirty="0">
+                <a:solidFill>
+                  <a:schemeClr val="tx1"/>
+                </a:solidFill>
+              </a:rPr>
+              <a:t>Postgres plus three services, capped heap</a:t>
+            </a:r>
+            <a:endParaRPr lang="en-US" sz="1200" dirty="0"/>
+          </a:p>
+        </p:txBody>
+      </p:sp>
+      <p:sp>
+        <p:nvSpPr>
+          <p:cNvPr id="25" name="Slide Number Placeholder 0"/>
+          <p:cNvSpPr>
+            <a:spLocks noGrp="1"/>
+          </p:cNvSpPr>
+          <p:nvPr>
+            <p:ph type="sldNum" sz="quarter" idx="4294967295"/>
+          </p:nvPr>
+        </p:nvSpPr>
+        <p:spPr>
+          <a:xfrm>
+            <a:off x="11064240" y="6446520"/>
+            <a:ext cx="548640" cy="274320"/>
+          </a:xfrm>
+          <a:prstGeom prst="rect">
+            <a:avLst/>
+          </a:prstGeom>
+          <a:extLst>
+            <a:ext uri="{C572A759-6A51-4108-AA02-DFA0A04FC94B}">
+              <ma14:wrappingTextBoxFlag xmlns:ma14="http://schemas.microsoft.com/office/mac/drawingml/2011/main" val="0"/>
+            </a:ext>
+          </a:extLst>
+        </p:spPr>
+        <p:txBody>
+          <a:bodyPr/>
+          <a:lstStyle>
+            <a:lvl1pPr>
+              <a:defRPr sz="1000">
+                <a:solidFill>
+                  <a:schemeClr val="accent4"/>
+                </a:solidFill>
+              </a:defRPr>
+            </a:lvl1pPr>
+          </a:lstStyle>
+          <a:p>
+            <a:pPr algn="r"/>
+            <a:fld id="{F7021451-1387-4CA6-816F-3879F97B5CBC}" type="slidenum">
+              <a:rPr b="0" lang="en-US"/>
+              <a:t>15</a:t>
+            </a:fld>
+            <a:endParaRPr lang="en-US"/>
+          </a:p>
+        </p:txBody>
+      </p:sp>
+    </p:spTree>
+  </p:cSld>
+  <p:clrMapOvr>
+    <a:masterClrMapping/>
+  </p:clrMapOvr>
+</p:sld>
+</file>
+
+<file path=ppt/slides/slide16.xml><?xml version="1.0" encoding="utf-8"?>
+<p:sld xmlns:a="http://schemas.openxmlformats.org/drawingml/2006/main" xmlns:r="http://schemas.openxmlformats.org/officeDocument/2006/relationships" xmlns:p="http://schemas.openxmlformats.org/presentationml/2006/main">
+  <p:cSld name="Slide 16">
+    <p:spTree>
+      <p:nvGrpSpPr>
+        <p:cNvPr id="1" name=""/>
+        <p:cNvGrpSpPr/>
+        <p:nvPr/>
+      </p:nvGrpSpPr>
+      <p:grpSpPr>
+        <a:xfrm>
+          <a:off x="0" y="0"/>
+          <a:ext cx="0" cy="0"/>
+          <a:chOff x="0" y="0"/>
+          <a:chExt cx="0" cy="0"/>
+        </a:xfrm>
+      </p:grpSpPr>
+      <p:sp>
+        <p:nvSpPr>
+          <p:cNvPr id="2" name="Text 2"/>
+          <p:cNvSpPr/>
+          <p:nvPr>
+            <p:ph idx="102" type="title" hasCustomPrompt="1"/>
+          </p:nvPr>
+        </p:nvSpPr>
+        <p:spPr>
+          <a:xfrm>
+            <a:off x="548640" y="274320"/>
+            <a:ext cx="11064240" cy="685800"/>
+          </a:xfrm>
+          <a:prstGeom prst="rect">
+            <a:avLst/>
+          </a:prstGeom>
+          <a:noFill/>
+          <a:ln/>
+        </p:spPr>
+        <p:txBody>
+          <a:bodyPr wrap="square" lIns="0" tIns="0" rIns="0" bIns="0" rtlCol="0" anchor="ctr"/>
+          <a:lstStyle/>
+          <a:p>
+            <a:pPr algn="l" indent="0" marL="0">
+              <a:buNone/>
+            </a:pPr>
+            <a:r>
+              <a:rPr lang="en-US" sz="3400" b="1" dirty="0">
+                <a:solidFill>
+                  <a:schemeClr val="tx2"/>
+                </a:solidFill>
+              </a:rPr>
+              <a:t>API catalogue</a:t>
+            </a:r>
+            <a:endParaRPr lang="en-US" sz="3400" dirty="0"/>
+          </a:p>
+        </p:txBody>
+      </p:sp>
+      <p:sp>
+        <p:nvSpPr>
+          <p:cNvPr id="3" name="Text 2"/>
+          <p:cNvSpPr/>
+          <p:nvPr>
+            <p:ph idx="103" type="body" hasCustomPrompt="1"/>
+          </p:nvPr>
+        </p:nvSpPr>
+        <p:spPr>
+          <a:xfrm>
+            <a:off x="548640" y="960120"/>
+            <a:ext cx="11064240" cy="365760"/>
+          </a:xfrm>
+          <a:prstGeom prst="rect">
+            <a:avLst/>
+          </a:prstGeom>
+          <a:noFill/>
+          <a:ln/>
+        </p:spPr>
+        <p:txBody>
+          <a:bodyPr wrap="square" lIns="0" tIns="0" rIns="0" bIns="0" rtlCol="0" anchor="t"/>
+          <a:lstStyle/>
+          <a:p>
+            <a:pPr algn="l" indent="0" marL="0">
+              <a:buNone/>
+            </a:pPr>
+            <a:r>
+              <a:rPr lang="en-US" sz="1400" dirty="0">
+                <a:solidFill>
+                  <a:schemeClr val="accent4"/>
+                </a:solidFill>
+              </a:rPr>
+              <a:t>Base path /api/v1; lending-service on port 8080, batch admin on lending-batch-service</a:t>
+            </a:r>
+            <a:endParaRPr lang="en-US" sz="1400" dirty="0"/>
+          </a:p>
+        </p:txBody>
+      </p:sp>
+      <p:graphicFrame>
+        <p:nvGraphicFramePr>
+          <p:cNvPr id="17" name="Table 0"/>
           <p:cNvGraphicFramePr>
             <a:graphicFrameLocks noGrp="1"/>
           </p:cNvGraphicFramePr>
@@ -10939,7 +14541,7 @@
             <a:pPr algn="r"/>
             <a:fld id="{F7021451-1387-4CA6-816F-3879F97B5CBC}" type="slidenum">
               <a:rPr b="0" lang="en-US"/>
-              <a:t>13</a:t>
+              <a:t>16</a:t>
             </a:fld>
             <a:endParaRPr lang="en-US"/>
           </a:p>
@@ -10953,9 +14555,9 @@
 </p:sld>
 </file>
 
-<file path=ppt/slides/slide14.xml><?xml version="1.0" encoding="utf-8"?>
+<file path=ppt/slides/slide17.xml><?xml version="1.0" encoding="utf-8"?>
 <p:sld xmlns:a="http://schemas.openxmlformats.org/drawingml/2006/main" xmlns:r="http://schemas.openxmlformats.org/officeDocument/2006/relationships" xmlns:p="http://schemas.openxmlformats.org/presentationml/2006/main">
-  <p:cSld name="Slide 14">
+  <p:cSld name="Slide 17">
     <p:spTree>
       <p:nvGrpSpPr>
         <p:cNvPr id="1" name=""/>
@@ -11230,6 +14832,24 @@
                 </a:solidFill>
               </a:rPr>
               <a:t>Customer PDF statement download</a:t>
+            </a:r>
+            <a:endParaRPr lang="en-US" sz="1700" dirty="0"/>
+          </a:p>
+          <a:p>
+            <a:pPr marL="342900" indent="-342900">
+              <a:spcAft>
+                <a:spcPts val="1000"/>
+              </a:spcAft>
+              <a:buSzPct val="100000"/>
+              <a:buChar char="•"/>
+            </a:pPr>
+            <a:r>
+              <a:rPr lang="en-US" sz="1700" dirty="0">
+                <a:solidFill>
+                  <a:schemeClr val="bg1"/>
+                </a:solidFill>
+              </a:rPr>
+              <a:t>Read-only admin portal for inquiry</a:t>
             </a:r>
             <a:endParaRPr lang="en-US" sz="1700" dirty="0"/>
           </a:p>

</xml_diff>

<commit_message>
Docs: configuration inventory, admin Configuration screen, updated deck
- TDD chapter 15 and Functional Spec chapter 13 extended (Configuration screen, batch edit endpoint,
  15.11 full settings inventory); deck slides 2-4 now cover all three services, new configuration slide;
  README, CHANGELOG and CLOUD_DEPLOYMENT updated.

Co-Authored-By: Claude Sonnet 5.5 <noreply@anthropic.com>
Claude-Session: https://claude.ai/code/session_011Ly3TH5YUMArmTYksVUGUE
</commit_message>
<xml_diff>
--- a/docs/Lending-Platform-Architecture.pptx
+++ b/docs/Lending-Platform-Architecture.pptx
@@ -22,9 +22,10 @@
     <p:sldId id="270" r:id="rId16"/>
     <p:sldId id="271" r:id="rId17"/>
     <p:sldId id="272" r:id="rId18"/>
+    <p:sldId id="273" r:id="rId19"/>
   </p:sldIdLst>
   <p:notesMasterIdLst>
-    <p:notesMasterId r:id="rId19"/>
+    <p:notesMasterId r:id="rId20"/>
   </p:notesMasterIdLst>
   <p:sldSz cx="12192000" cy="6858000"/>
   <p:notesSz cx="6858000" cy="12192000"/>
@@ -123,25 +124,25 @@
   <p:extLst>
     <p:ext uri="{521415D9-36F7-43E2-AB2F-B90AF26B5E84}">
       <p14:sectionLst xmlns:p14="http://schemas.microsoft.com/office/powerpoint/2010/main">
-        <p14:section name="Overview" id="{01dbbad1-870d-0c9d-1075-751aacd08455}">
+        <p14:section name="Overview" id="{8d55649c-0b39-2a8a-58eb-f02f21f2648c}">
           <p14:sldIdLst>
             <p14:sldId id="256"/>
             <p14:sldId id="257"/>
           </p14:sldIdLst>
         </p14:section>
-        <p14:section name="Architecture" id="{22bd3dad-cacc-4422-c56b-6a2efb2c63d7}">
+        <p14:section name="Architecture" id="{a3ffa1b9-21d8-4704-1f46-a834cbda2f97}">
           <p14:sldIdLst>
             <p14:sldId id="258"/>
             <p14:sldId id="259"/>
           </p14:sldIdLst>
         </p14:section>
-        <p14:section name="Data model" id="{2ce81484-b38b-a088-1de2-9a3707ebccdf}">
+        <p14:section name="Data model" id="{7a75fe53-2b4a-4c2e-c896-53b1bd374d99}">
           <p14:sldIdLst>
             <p14:sldId id="260"/>
             <p14:sldId id="261"/>
           </p14:sldIdLst>
         </p14:section>
-        <p14:section name="Flows" id="{67806dcc-00bd-36e8-67fb-dbf6ad549151}">
+        <p14:section name="Flows" id="{80ca3e10-566b-9f92-c664-8da8020c72f2}">
           <p14:sldIdLst>
             <p14:sldId id="262"/>
             <p14:sldId id="263"/>
@@ -149,23 +150,24 @@
             <p14:sldId id="265"/>
           </p14:sldIdLst>
         </p14:section>
-        <p14:section name="Lifecycle" id="{4e938ae8-0ef7-10ff-abff-a8b42297007b}">
+        <p14:section name="Lifecycle" id="{41a8da41-461b-b44a-5209-6a6f9930257c}">
           <p14:sldIdLst>
             <p14:sldId id="266"/>
             <p14:sldId id="267"/>
           </p14:sldIdLst>
         </p14:section>
-        <p14:section name="Admin portal" id="{06c620dd-cf29-46b3-a4a9-6260e0a3cd9a}">
+        <p14:section name="Admin portal" id="{735005b0-3d2c-1b7b-b526-df4657b74434}">
           <p14:sldIdLst>
             <p14:sldId id="268"/>
             <p14:sldId id="269"/>
             <p14:sldId id="270"/>
+            <p14:sldId id="271"/>
           </p14:sldIdLst>
         </p14:section>
-        <p14:section name="Reference" id="{43441d28-e7b4-6c4e-1203-4e7bcd536994}">
+        <p14:section name="Reference" id="{6c097ee2-baec-2fb6-dad2-a8ed98871ea4}">
           <p14:sldIdLst>
-            <p14:sldId id="271"/>
             <p14:sldId id="272"/>
+            <p14:sldId id="273"/>
           </p14:sldIdLst>
         </p14:section>
       </p14:sectionLst>
@@ -1100,7 +1102,7 @@
           <a:p>
             <a:r>
               <a:rPr lang="en-US" dirty="0"/>
-              <a:t>The admin portal URL suffix is assigned by Render when the service is first created; copy it from the dashboard.</a:t>
+              <a:t>Answers: what are all the configurations. Three tiers. Runtime-editable: batch job settings in batch.batch_job_config, edited on the Configuration screen. Startup: environment variables on each service. Fixed: business rules in code.</a:t>
             </a:r>
             <a:endParaRPr lang="en-US" dirty="0"/>
           </a:p>
@@ -1188,7 +1190,7 @@
           <a:p>
             <a:r>
               <a:rPr lang="en-US" dirty="0"/>
-              <a:t>Reference table. Paths are relative to /api/v1.</a:t>
+              <a:t>The admin portal URL suffix is assigned by Render when the service is first created; copy it from the dashboard.</a:t>
             </a:r>
             <a:endParaRPr lang="en-US" dirty="0"/>
           </a:p>
@@ -1276,7 +1278,7 @@
           <a:p>
             <a:r>
               <a:rPr lang="en-US" dirty="0"/>
-              <a:t>Be candid: the REST lifecycle is real; the batch job bodies, ledger integration, Kafka and authentication are still to do.</a:t>
+              <a:t>Reference table. Paths are relative to /api/v1.</a:t>
             </a:r>
             <a:endParaRPr lang="en-US" dirty="0"/>
           </a:p>
@@ -1300,6 +1302,94 @@
             <a:fld id="{F7021451-1387-4CA6-816F-3879F97B5CBC}" type="slidenum">
               <a:rPr lang="en-US"/>
               <a:t>17</a:t>
+            </a:fld>
+            <a:endParaRPr lang="en-US"/>
+          </a:p>
+        </p:txBody>
+      </p:sp>
+    </p:spTree>
+    <p:extLst>
+      <p:ext uri="{BB962C8B-B14F-4D97-AF65-F5344CB8AC3E}">
+        <p14:creationId xmlns:p14="http://schemas.microsoft.com/office/powerpoint/2010/main" val="1024086991"/>
+      </p:ext>
+    </p:extLst>
+  </p:cSld>
+  <p:clrMapOvr>
+    <a:masterClrMapping/>
+  </p:clrMapOvr>
+</p:notes>
+</file>
+
+<file path=ppt/notesSlides/notesSlide18.xml><?xml version="1.0" encoding="utf-8"?>
+<p:notes xmlns:a="http://schemas.openxmlformats.org/drawingml/2006/main" xmlns:r="http://schemas.openxmlformats.org/officeDocument/2006/relationships" xmlns:p="http://schemas.openxmlformats.org/presentationml/2006/main">
+  <p:cSld>
+    <p:spTree>
+      <p:nvGrpSpPr>
+        <p:cNvPr id="1" name=""/>
+        <p:cNvGrpSpPr/>
+        <p:nvPr/>
+      </p:nvGrpSpPr>
+      <p:grpSpPr>
+        <a:xfrm>
+          <a:off x="0" y="0"/>
+          <a:ext cx="0" cy="0"/>
+          <a:chOff x="0" y="0"/>
+          <a:chExt cx="0" cy="0"/>
+        </a:xfrm>
+      </p:grpSpPr>
+      <p:sp>
+        <p:nvSpPr>
+          <p:cNvPr id="2" name="Slide Image Placeholder 1"/>
+          <p:cNvSpPr>
+            <a:spLocks noGrp="1" noRot="1" noChangeAspect="1"/>
+          </p:cNvSpPr>
+          <p:nvPr>
+            <p:ph type="sldImg"/>
+          </p:nvPr>
+        </p:nvSpPr>
+        <p:spPr/>
+      </p:sp>
+      <p:sp>
+        <p:nvSpPr>
+          <p:cNvPr id="3" name="Notes Placeholder 2"/>
+          <p:cNvSpPr>
+            <a:spLocks noGrp="1"/>
+          </p:cNvSpPr>
+          <p:nvPr>
+            <p:ph type="body" idx="1"/>
+          </p:nvPr>
+        </p:nvSpPr>
+        <p:spPr/>
+        <p:txBody>
+          <a:bodyPr/>
+          <a:lstStyle/>
+          <a:p>
+            <a:r>
+              <a:rPr lang="en-US" dirty="0"/>
+              <a:t>Be candid: the REST lifecycle is real; the batch job bodies, ledger integration, Kafka and authentication are still to do.</a:t>
+            </a:r>
+            <a:endParaRPr lang="en-US" dirty="0"/>
+          </a:p>
+        </p:txBody>
+      </p:sp>
+      <p:sp>
+        <p:nvSpPr>
+          <p:cNvPr id="4" name="Slide Number Placeholder 3"/>
+          <p:cNvSpPr>
+            <a:spLocks noGrp="1"/>
+          </p:cNvSpPr>
+          <p:nvPr>
+            <p:ph type="sldNum" sz="quarter" idx="10"/>
+          </p:nvPr>
+        </p:nvSpPr>
+        <p:spPr/>
+        <p:txBody>
+          <a:bodyPr/>
+          <a:lstStyle/>
+          <a:p>
+            <a:fld id="{F7021451-1387-4CA6-816F-3879F97B5CBC}" type="slidenum">
+              <a:rPr lang="en-US"/>
+              <a:t>18</a:t>
             </a:fld>
             <a:endParaRPr lang="en-US"/>
           </a:p>
@@ -1364,7 +1454,7 @@
           <a:p>
             <a:r>
               <a:rPr lang="en-US" dirty="0"/>
-              <a:t>Four headline numbers, then one card per service.</a:t>
+              <a:t>Four headline numbers, then one card per service. The admin portal is the newest: read-only inquiry plus one editable area, the batch job settings.</a:t>
             </a:r>
             <a:endParaRPr lang="en-US" dirty="0"/>
           </a:p>
@@ -1452,7 +1542,7 @@
           <a:p>
             <a:r>
               <a:rPr lang="en-US" dirty="0"/>
-              <a:t>Clients call lending-service over REST. Operators call the batch admin API. Both services use the same PostgreSQL instance, in different schemas. Kafka and the core ledger are external.</a:t>
+              <a:t>Clients call lending-service over REST. Operators call the batch admin API. The admin console serves a React UI, reads the database through read-only sessions, proxies the statement PDF from lending-service, and edits batch job settings through the batch admin API. Kafka and the core ledger are external.</a:t>
             </a:r>
             <a:endParaRPr lang="en-US" dirty="0"/>
           </a:p>
@@ -9168,7 +9258,7 @@
                 <a:gridCol w="2103120"/>
                 <a:gridCol w="5212080"/>
               </a:tblGrid>
-              <a:tr h="548640">
+              <a:tr h="475488">
                 <a:tc>
                   <a:txBody>
                     <a:bodyPr/>
@@ -9292,7 +9382,7 @@
                   </a:tcPr>
                 </a:tc>
               </a:tr>
-              <a:tr h="548640">
+              <a:tr h="475488">
                 <a:tc>
                   <a:txBody>
                     <a:bodyPr/>
@@ -9416,7 +9506,7 @@
                   </a:tcPr>
                 </a:tc>
               </a:tr>
-              <a:tr h="548640">
+              <a:tr h="475488">
                 <a:tc>
                   <a:txBody>
                     <a:bodyPr/>
@@ -9540,7 +9630,7 @@
                   </a:tcPr>
                 </a:tc>
               </a:tr>
-              <a:tr h="548640">
+              <a:tr h="475488">
                 <a:tc>
                   <a:txBody>
                     <a:bodyPr/>
@@ -9664,7 +9754,7 @@
                   </a:tcPr>
                 </a:tc>
               </a:tr>
-              <a:tr h="548640">
+              <a:tr h="475488">
                 <a:tc>
                   <a:txBody>
                     <a:bodyPr/>
@@ -9788,7 +9878,7 @@
                   </a:tcPr>
                 </a:tc>
               </a:tr>
-              <a:tr h="548640">
+              <a:tr h="475488">
                 <a:tc>
                   <a:txBody>
                     <a:bodyPr/>
@@ -9912,7 +10002,7 @@
                   </a:tcPr>
                 </a:tc>
               </a:tr>
-              <a:tr h="548640">
+              <a:tr h="475488">
                 <a:tc>
                   <a:txBody>
                     <a:bodyPr/>
@@ -10036,7 +10126,7 @@
                   </a:tcPr>
                 </a:tc>
               </a:tr>
-              <a:tr h="548640">
+              <a:tr h="475488">
                 <a:tc>
                   <a:txBody>
                     <a:bodyPr/>
@@ -10160,6 +10250,130 @@
                   </a:tcPr>
                 </a:tc>
               </a:tr>
+              <a:tr h="475488">
+                <a:tc>
+                  <a:txBody>
+                    <a:bodyPr/>
+                    <a:lstStyle/>
+                    <a:p>
+                      <a:pPr indent="0" marL="0">
+                        <a:buNone/>
+                      </a:pPr>
+                      <a:r>
+                        <a:rPr lang="en-US" sz="1300" b="1" dirty="0">
+                          <a:solidFill>
+                            <a:schemeClr val="tx2"/>
+                          </a:solidFill>
+                        </a:rPr>
+                        <a:t>Configuration</a:t>
+                      </a:r>
+                      <a:endParaRPr lang="en-US" sz="1300" dirty="0"/>
+                    </a:p>
+                  </a:txBody>
+                  <a:tcPr marL="91440" marR="91440" marT="27432" marB="27432" anchor="ctr">
+                    <a:lnL w="6350" cap="flat" cmpd="sng" algn="ctr">
+                      <a:solidFill>
+                        <a:schemeClr val="bg2"/>
+                      </a:solidFill>
+                      <a:prstDash val="solid"/>
+                      <a:round/>
+                      <a:headEnd type="none" w="med" len="med"/>
+                      <a:tailEnd type="none" w="med" len="med"/>
+                    </a:lnL>
+                    <a:lnR w="6350" cap="flat" cmpd="sng" algn="ctr">
+                      <a:solidFill>
+                        <a:schemeClr val="bg2"/>
+                      </a:solidFill>
+                      <a:prstDash val="solid"/>
+                      <a:round/>
+                      <a:headEnd type="none" w="med" len="med"/>
+                      <a:tailEnd type="none" w="med" len="med"/>
+                    </a:lnR>
+                    <a:lnT w="6350" cap="flat" cmpd="sng" algn="ctr">
+                      <a:solidFill>
+                        <a:schemeClr val="bg2"/>
+                      </a:solidFill>
+                      <a:prstDash val="solid"/>
+                      <a:round/>
+                      <a:headEnd type="none" w="med" len="med"/>
+                      <a:tailEnd type="none" w="med" len="med"/>
+                    </a:lnT>
+                    <a:lnB w="6350" cap="flat" cmpd="sng" algn="ctr">
+                      <a:solidFill>
+                        <a:schemeClr val="bg2"/>
+                      </a:solidFill>
+                      <a:prstDash val="solid"/>
+                      <a:round/>
+                      <a:headEnd type="none" w="med" len="med"/>
+                      <a:tailEnd type="none" w="med" len="med"/>
+                    </a:lnB>
+                    <a:solidFill>
+                      <a:schemeClr val="bg1"/>
+                    </a:solidFill>
+                  </a:tcPr>
+                </a:tc>
+                <a:tc>
+                  <a:txBody>
+                    <a:bodyPr/>
+                    <a:lstStyle/>
+                    <a:p>
+                      <a:pPr indent="0" marL="0">
+                        <a:buNone/>
+                      </a:pPr>
+                      <a:r>
+                        <a:rPr lang="en-US" sz="1300" dirty="0">
+                          <a:solidFill>
+                            <a:srgbClr val="000000"/>
+                          </a:solidFill>
+                        </a:rPr>
+                        <a:t>Edit batch job settings (the one write); view every service's settings and the fixed business rules</a:t>
+                      </a:r>
+                      <a:endParaRPr lang="en-US" sz="1300" dirty="0"/>
+                    </a:p>
+                  </a:txBody>
+                  <a:tcPr marL="91440" marR="91440" marT="27432" marB="27432" anchor="ctr">
+                    <a:lnL w="6350" cap="flat" cmpd="sng" algn="ctr">
+                      <a:solidFill>
+                        <a:schemeClr val="bg2"/>
+                      </a:solidFill>
+                      <a:prstDash val="solid"/>
+                      <a:round/>
+                      <a:headEnd type="none" w="med" len="med"/>
+                      <a:tailEnd type="none" w="med" len="med"/>
+                    </a:lnL>
+                    <a:lnR w="6350" cap="flat" cmpd="sng" algn="ctr">
+                      <a:solidFill>
+                        <a:schemeClr val="bg2"/>
+                      </a:solidFill>
+                      <a:prstDash val="solid"/>
+                      <a:round/>
+                      <a:headEnd type="none" w="med" len="med"/>
+                      <a:tailEnd type="none" w="med" len="med"/>
+                    </a:lnR>
+                    <a:lnT w="6350" cap="flat" cmpd="sng" algn="ctr">
+                      <a:solidFill>
+                        <a:schemeClr val="bg2"/>
+                      </a:solidFill>
+                      <a:prstDash val="solid"/>
+                      <a:round/>
+                      <a:headEnd type="none" w="med" len="med"/>
+                      <a:tailEnd type="none" w="med" len="med"/>
+                    </a:lnT>
+                    <a:lnB w="6350" cap="flat" cmpd="sng" algn="ctr">
+                      <a:solidFill>
+                        <a:schemeClr val="bg2"/>
+                      </a:solidFill>
+                      <a:prstDash val="solid"/>
+                      <a:round/>
+                      <a:headEnd type="none" w="med" len="med"/>
+                      <a:tailEnd type="none" w="med" len="med"/>
+                    </a:lnB>
+                    <a:solidFill>
+                      <a:schemeClr val="bg1"/>
+                    </a:solidFill>
+                  </a:tcPr>
+                </a:tc>
+              </a:tr>
             </a:tbl>
           </a:graphicData>
         </a:graphic>
@@ -10274,7 +10488,7 @@
                   <a:schemeClr val="tx1"/>
                 </a:solidFill>
               </a:rPr>
-              <a:t>View only. One shared login, no roles or audit trail yet.</a:t>
+              <a:t>Read-only except batch job settings, saved through the batch service. One shared login, no roles or audit trail yet.</a:t>
             </a:r>
             <a:endParaRPr lang="en-US" sz="1200" dirty="0"/>
           </a:p>
@@ -10382,7 +10596,7 @@
                   <a:schemeClr val="tx2"/>
                 </a:solidFill>
               </a:rPr>
-              <a:t>Sandbox URLs and changes since v1.0</a:t>
+              <a:t>Configuration: what can be changed, and where</a:t>
             </a:r>
             <a:endParaRPr lang="en-US" sz="3400" dirty="0"/>
           </a:p>
@@ -10420,6 +10634,800 @@
                   <a:schemeClr val="accent4"/>
                 </a:solidFill>
               </a:rPr>
+              <a:t>Only the batch job settings are editable at runtime; everything else needs a redeploy or a code change</a:t>
+            </a:r>
+            <a:endParaRPr lang="en-US" sz="1400" dirty="0"/>
+          </a:p>
+        </p:txBody>
+      </p:sp>
+      <p:sp>
+        <p:nvSpPr>
+          <p:cNvPr id="5" name="Text 2"/>
+          <p:cNvSpPr txBox="1"/>
+          <p:nvPr/>
+        </p:nvSpPr>
+        <p:spPr>
+          <a:xfrm>
+            <a:off x="548640" y="1463040"/>
+            <a:ext cx="3566160" cy="4023360"/>
+          </a:xfrm>
+          <a:prstGeom prst="roundRect">
+            <a:avLst>
+              <a:gd name="adj" fmla="val 2051"/>
+            </a:avLst>
+          </a:prstGeom>
+          <a:solidFill>
+            <a:schemeClr val="accent1">
+              <a:alpha val="12000"/>
+            </a:schemeClr>
+          </a:solidFill>
+          <a:ln w="19050">
+            <a:solidFill>
+              <a:schemeClr val="accent1"/>
+            </a:solidFill>
+          </a:ln>
+        </p:spPr>
+        <p:txBody>
+          <a:bodyPr wrap="square" lIns="50800" tIns="50800" rIns="50800" bIns="50800" rtlCol="0" anchor="ctr"/>
+          <a:lstStyle/>
+          <a:p>
+            <a:pPr algn="ctr" indent="0" marL="0">
+              <a:buNone/>
+            </a:pPr>
+            <a:endParaRPr lang="en-US" sz="1200" dirty="0"/>
+          </a:p>
+        </p:txBody>
+      </p:sp>
+      <p:sp>
+        <p:nvSpPr>
+          <p:cNvPr id="6" name="Text 3"/>
+          <p:cNvSpPr txBox="1"/>
+          <p:nvPr/>
+        </p:nvSpPr>
+        <p:spPr>
+          <a:xfrm>
+            <a:off x="731520" y="1572768"/>
+            <a:ext cx="3200400" cy="365760"/>
+          </a:xfrm>
+          <a:prstGeom prst="rect">
+            <a:avLst/>
+          </a:prstGeom>
+          <a:noFill/>
+          <a:ln/>
+        </p:spPr>
+        <p:txBody>
+          <a:bodyPr wrap="square" lIns="0" tIns="0" rIns="0" bIns="0" rtlCol="0" anchor="t"/>
+          <a:lstStyle/>
+          <a:p>
+            <a:pPr indent="0" marL="0">
+              <a:buNone/>
+            </a:pPr>
+            <a:r>
+              <a:rPr lang="en-US" sz="1800" b="1" dirty="0">
+                <a:solidFill>
+                  <a:schemeClr val="tx2"/>
+                </a:solidFill>
+              </a:rPr>
+              <a:t>Editable now</a:t>
+            </a:r>
+            <a:endParaRPr lang="en-US" sz="1800" dirty="0"/>
+          </a:p>
+        </p:txBody>
+      </p:sp>
+      <p:sp>
+        <p:nvSpPr>
+          <p:cNvPr id="7" name="Text 4"/>
+          <p:cNvSpPr txBox="1"/>
+          <p:nvPr/>
+        </p:nvSpPr>
+        <p:spPr>
+          <a:xfrm>
+            <a:off x="731520" y="1965960"/>
+            <a:ext cx="3246120" cy="457200"/>
+          </a:xfrm>
+          <a:prstGeom prst="rect">
+            <a:avLst/>
+          </a:prstGeom>
+          <a:noFill/>
+          <a:ln/>
+        </p:spPr>
+        <p:txBody>
+          <a:bodyPr wrap="square" lIns="0" tIns="0" rIns="0" bIns="0" rtlCol="0" anchor="t"/>
+          <a:lstStyle/>
+          <a:p>
+            <a:pPr indent="0" marL="0">
+              <a:buNone/>
+            </a:pPr>
+            <a:r>
+              <a:rPr lang="en-US" sz="1100" dirty="0">
+                <a:solidFill>
+                  <a:schemeClr val="accent4"/>
+                </a:solidFill>
+              </a:rPr>
+              <a:t>Configuration screen &gt; Batch jobs</a:t>
+            </a:r>
+            <a:endParaRPr lang="en-US" sz="1100" dirty="0"/>
+          </a:p>
+        </p:txBody>
+      </p:sp>
+      <p:sp>
+        <p:nvSpPr>
+          <p:cNvPr id="8" name="Text 5"/>
+          <p:cNvSpPr txBox="1"/>
+          <p:nvPr/>
+        </p:nvSpPr>
+        <p:spPr>
+          <a:xfrm>
+            <a:off x="731520" y="2514600"/>
+            <a:ext cx="3246120" cy="3566160"/>
+          </a:xfrm>
+          <a:prstGeom prst="rect">
+            <a:avLst/>
+          </a:prstGeom>
+          <a:noFill/>
+          <a:ln/>
+        </p:spPr>
+        <p:txBody>
+          <a:bodyPr wrap="square" lIns="0" tIns="0" rIns="0" bIns="0" rtlCol="0" anchor="t"/>
+          <a:lstStyle/>
+          <a:p>
+            <a:pPr marL="342900" indent="-342900">
+              <a:spcAft>
+                <a:spcPts val="800"/>
+              </a:spcAft>
+              <a:buSzPct val="100000"/>
+              <a:buChar char="•"/>
+            </a:pPr>
+            <a:r>
+              <a:rPr lang="en-US" sz="1400" dirty="0">
+                <a:solidFill>
+                  <a:schemeClr val="tx1"/>
+                </a:solidFill>
+              </a:rPr>
+              <a:t>Per job, 36 jobs: enabled, schedule (cron), restartable</a:t>
+            </a:r>
+            <a:endParaRPr lang="en-US" sz="1400" dirty="0"/>
+          </a:p>
+          <a:p>
+            <a:pPr marL="342900" indent="-342900">
+              <a:spcAft>
+                <a:spcPts val="800"/>
+              </a:spcAft>
+              <a:buSzPct val="100000"/>
+              <a:buChar char="•"/>
+            </a:pPr>
+            <a:r>
+              <a:rPr lang="en-US" sz="1400" dirty="0">
+                <a:solidFill>
+                  <a:schemeClr val="tx1"/>
+                </a:solidFill>
+              </a:rPr>
+              <a:t>Chunk size, concurrency, thread limit (chunk jobs)</a:t>
+            </a:r>
+            <a:endParaRPr lang="en-US" sz="1400" dirty="0"/>
+          </a:p>
+          <a:p>
+            <a:pPr marL="342900" indent="-342900">
+              <a:spcAft>
+                <a:spcPts val="800"/>
+              </a:spcAft>
+              <a:buSzPct val="100000"/>
+              <a:buChar char="•"/>
+            </a:pPr>
+            <a:r>
+              <a:rPr lang="en-US" sz="1400" dirty="0">
+                <a:solidFill>
+                  <a:schemeClr val="tx1"/>
+                </a:solidFill>
+              </a:rPr>
+              <a:t>Retry limit, skip limit, timeout, run order</a:t>
+            </a:r>
+            <a:endParaRPr lang="en-US" sz="1400" dirty="0"/>
+          </a:p>
+          <a:p>
+            <a:pPr marL="342900" indent="-342900">
+              <a:spcAft>
+                <a:spcPts val="800"/>
+              </a:spcAft>
+              <a:buSzPct val="100000"/>
+              <a:buChar char="•"/>
+            </a:pPr>
+            <a:r>
+              <a:rPr lang="en-US" sz="1400" dirty="0">
+                <a:solidFill>
+                  <a:schemeClr val="tx1"/>
+                </a:solidFill>
+              </a:rPr>
+              <a:t>Saved through the batch service (validated, version-checked), then Apply = reload; no restart</a:t>
+            </a:r>
+            <a:endParaRPr lang="en-US" sz="1400" dirty="0"/>
+          </a:p>
+        </p:txBody>
+      </p:sp>
+      <p:sp>
+        <p:nvSpPr>
+          <p:cNvPr id="9" name="Text 6"/>
+          <p:cNvSpPr txBox="1"/>
+          <p:nvPr/>
+        </p:nvSpPr>
+        <p:spPr>
+          <a:xfrm>
+            <a:off x="4297680" y="1463040"/>
+            <a:ext cx="3566160" cy="4023360"/>
+          </a:xfrm>
+          <a:prstGeom prst="roundRect">
+            <a:avLst>
+              <a:gd name="adj" fmla="val 2051"/>
+            </a:avLst>
+          </a:prstGeom>
+          <a:solidFill>
+            <a:schemeClr val="accent4">
+              <a:alpha val="12000"/>
+            </a:schemeClr>
+          </a:solidFill>
+          <a:ln w="19050">
+            <a:solidFill>
+              <a:schemeClr val="accent4"/>
+            </a:solidFill>
+          </a:ln>
+        </p:spPr>
+        <p:txBody>
+          <a:bodyPr wrap="square" lIns="50800" tIns="50800" rIns="50800" bIns="50800" rtlCol="0" anchor="ctr"/>
+          <a:lstStyle/>
+          <a:p>
+            <a:pPr algn="ctr" indent="0" marL="0">
+              <a:buNone/>
+            </a:pPr>
+            <a:endParaRPr lang="en-US" sz="1200" dirty="0"/>
+          </a:p>
+        </p:txBody>
+      </p:sp>
+      <p:sp>
+        <p:nvSpPr>
+          <p:cNvPr id="10" name="Text 7"/>
+          <p:cNvSpPr txBox="1"/>
+          <p:nvPr/>
+        </p:nvSpPr>
+        <p:spPr>
+          <a:xfrm>
+            <a:off x="4480560" y="1572768"/>
+            <a:ext cx="3200400" cy="365760"/>
+          </a:xfrm>
+          <a:prstGeom prst="rect">
+            <a:avLst/>
+          </a:prstGeom>
+          <a:noFill/>
+          <a:ln/>
+        </p:spPr>
+        <p:txBody>
+          <a:bodyPr wrap="square" lIns="0" tIns="0" rIns="0" bIns="0" rtlCol="0" anchor="t"/>
+          <a:lstStyle/>
+          <a:p>
+            <a:pPr indent="0" marL="0">
+              <a:buNone/>
+            </a:pPr>
+            <a:r>
+              <a:rPr lang="en-US" sz="1800" b="1" dirty="0">
+                <a:solidFill>
+                  <a:schemeClr val="tx2"/>
+                </a:solidFill>
+              </a:rPr>
+              <a:t>Environment variables</a:t>
+            </a:r>
+            <a:endParaRPr lang="en-US" sz="1800" dirty="0"/>
+          </a:p>
+        </p:txBody>
+      </p:sp>
+      <p:sp>
+        <p:nvSpPr>
+          <p:cNvPr id="11" name="Text 8"/>
+          <p:cNvSpPr txBox="1"/>
+          <p:nvPr/>
+        </p:nvSpPr>
+        <p:spPr>
+          <a:xfrm>
+            <a:off x="4480560" y="1965960"/>
+            <a:ext cx="3246120" cy="457200"/>
+          </a:xfrm>
+          <a:prstGeom prst="rect">
+            <a:avLst/>
+          </a:prstGeom>
+          <a:noFill/>
+          <a:ln/>
+        </p:spPr>
+        <p:txBody>
+          <a:bodyPr wrap="square" lIns="0" tIns="0" rIns="0" bIns="0" rtlCol="0" anchor="t"/>
+          <a:lstStyle/>
+          <a:p>
+            <a:pPr indent="0" marL="0">
+              <a:buNone/>
+            </a:pPr>
+            <a:r>
+              <a:rPr lang="en-US" sz="1100" dirty="0">
+                <a:solidFill>
+                  <a:schemeClr val="accent4"/>
+                </a:solidFill>
+              </a:rPr>
+              <a:t>Service settings tab (view); change in Render or compose</a:t>
+            </a:r>
+            <a:endParaRPr lang="en-US" sz="1100" dirty="0"/>
+          </a:p>
+        </p:txBody>
+      </p:sp>
+      <p:sp>
+        <p:nvSpPr>
+          <p:cNvPr id="12" name="Text 9"/>
+          <p:cNvSpPr txBox="1"/>
+          <p:nvPr/>
+        </p:nvSpPr>
+        <p:spPr>
+          <a:xfrm>
+            <a:off x="4480560" y="2514600"/>
+            <a:ext cx="3246120" cy="3566160"/>
+          </a:xfrm>
+          <a:prstGeom prst="rect">
+            <a:avLst/>
+          </a:prstGeom>
+          <a:noFill/>
+          <a:ln/>
+        </p:spPr>
+        <p:txBody>
+          <a:bodyPr wrap="square" lIns="0" tIns="0" rIns="0" bIns="0" rtlCol="0" anchor="t"/>
+          <a:lstStyle/>
+          <a:p>
+            <a:pPr marL="342900" indent="-342900">
+              <a:spcAft>
+                <a:spcPts val="800"/>
+              </a:spcAft>
+              <a:buSzPct val="100000"/>
+              <a:buChar char="•"/>
+            </a:pPr>
+            <a:r>
+              <a:rPr lang="en-US" sz="1400" dirty="0">
+                <a:solidFill>
+                  <a:schemeClr val="tx1"/>
+                </a:solidFill>
+              </a:rPr>
+              <a:t>Database host, user, password, pool size (all three)</a:t>
+            </a:r>
+            <a:endParaRPr lang="en-US" sz="1400" dirty="0"/>
+          </a:p>
+          <a:p>
+            <a:pPr marL="342900" indent="-342900">
+              <a:spcAft>
+                <a:spcPts val="800"/>
+              </a:spcAft>
+              <a:buSzPct val="100000"/>
+              <a:buChar char="•"/>
+            </a:pPr>
+            <a:r>
+              <a:rPr lang="en-US" sz="1400" dirty="0">
+                <a:solidFill>
+                  <a:schemeClr val="tx1"/>
+                </a:solidFill>
+              </a:rPr>
+              <a:t>Ports, JVM heap, Spring profile</a:t>
+            </a:r>
+            <a:endParaRPr lang="en-US" sz="1400" dirty="0"/>
+          </a:p>
+          <a:p>
+            <a:pPr marL="342900" indent="-342900">
+              <a:spcAft>
+                <a:spcPts val="800"/>
+              </a:spcAft>
+              <a:buSzPct val="100000"/>
+              <a:buChar char="•"/>
+            </a:pPr>
+            <a:r>
+              <a:rPr lang="en-US" sz="1400" dirty="0">
+                <a:solidFill>
+                  <a:schemeClr val="tx1"/>
+                </a:solidFill>
+              </a:rPr>
+              <a:t>Logins: ADMIN_*, BATCH_ADMIN_*; links: LENDING_SERVICE_URL, BATCH_SERVICE_URL</a:t>
+            </a:r>
+            <a:endParaRPr lang="en-US" sz="1400" dirty="0"/>
+          </a:p>
+          <a:p>
+            <a:pPr marL="342900" indent="-342900">
+              <a:spcAft>
+                <a:spcPts val="800"/>
+              </a:spcAft>
+              <a:buSzPct val="100000"/>
+              <a:buChar char="•"/>
+            </a:pPr>
+            <a:r>
+              <a:rPr lang="en-US" sz="1400" dirty="0">
+                <a:solidFill>
+                  <a:schemeClr val="tx1"/>
+                </a:solidFill>
+              </a:rPr>
+              <a:t>Statement text and timezone; Kafka address and timeout</a:t>
+            </a:r>
+            <a:endParaRPr lang="en-US" sz="1400" dirty="0"/>
+          </a:p>
+          <a:p>
+            <a:pPr marL="342900" indent="-342900">
+              <a:spcAft>
+                <a:spcPts val="800"/>
+              </a:spcAft>
+              <a:buSzPct val="100000"/>
+              <a:buChar char="•"/>
+            </a:pPr>
+            <a:r>
+              <a:rPr lang="en-US" sz="1400" dirty="0">
+                <a:solidFill>
+                  <a:schemeClr val="tx1"/>
+                </a:solidFill>
+              </a:rPr>
+              <a:t>Takes effect after a restart of that service</a:t>
+            </a:r>
+            <a:endParaRPr lang="en-US" sz="1400" dirty="0"/>
+          </a:p>
+        </p:txBody>
+      </p:sp>
+      <p:sp>
+        <p:nvSpPr>
+          <p:cNvPr id="13" name="Text 10"/>
+          <p:cNvSpPr txBox="1"/>
+          <p:nvPr/>
+        </p:nvSpPr>
+        <p:spPr>
+          <a:xfrm>
+            <a:off x="8046720" y="1463040"/>
+            <a:ext cx="3566160" cy="4023360"/>
+          </a:xfrm>
+          <a:prstGeom prst="roundRect">
+            <a:avLst>
+              <a:gd name="adj" fmla="val 2051"/>
+            </a:avLst>
+          </a:prstGeom>
+          <a:solidFill>
+            <a:schemeClr val="accent2">
+              <a:alpha val="12000"/>
+            </a:schemeClr>
+          </a:solidFill>
+          <a:ln w="19050">
+            <a:solidFill>
+              <a:schemeClr val="accent2"/>
+            </a:solidFill>
+          </a:ln>
+        </p:spPr>
+        <p:txBody>
+          <a:bodyPr wrap="square" lIns="50800" tIns="50800" rIns="50800" bIns="50800" rtlCol="0" anchor="ctr"/>
+          <a:lstStyle/>
+          <a:p>
+            <a:pPr algn="ctr" indent="0" marL="0">
+              <a:buNone/>
+            </a:pPr>
+            <a:endParaRPr lang="en-US" sz="1200" dirty="0"/>
+          </a:p>
+        </p:txBody>
+      </p:sp>
+      <p:sp>
+        <p:nvSpPr>
+          <p:cNvPr id="14" name="Text 11"/>
+          <p:cNvSpPr txBox="1"/>
+          <p:nvPr/>
+        </p:nvSpPr>
+        <p:spPr>
+          <a:xfrm>
+            <a:off x="8229600" y="1572768"/>
+            <a:ext cx="3200400" cy="365760"/>
+          </a:xfrm>
+          <a:prstGeom prst="rect">
+            <a:avLst/>
+          </a:prstGeom>
+          <a:noFill/>
+          <a:ln/>
+        </p:spPr>
+        <p:txBody>
+          <a:bodyPr wrap="square" lIns="0" tIns="0" rIns="0" bIns="0" rtlCol="0" anchor="t"/>
+          <a:lstStyle/>
+          <a:p>
+            <a:pPr indent="0" marL="0">
+              <a:buNone/>
+            </a:pPr>
+            <a:r>
+              <a:rPr lang="en-US" sz="1800" b="1" dirty="0">
+                <a:solidFill>
+                  <a:schemeClr val="tx2"/>
+                </a:solidFill>
+              </a:rPr>
+              <a:t>Fixed in code</a:t>
+            </a:r>
+            <a:endParaRPr lang="en-US" sz="1800" dirty="0"/>
+          </a:p>
+        </p:txBody>
+      </p:sp>
+      <p:sp>
+        <p:nvSpPr>
+          <p:cNvPr id="15" name="Text 12"/>
+          <p:cNvSpPr txBox="1"/>
+          <p:nvPr/>
+        </p:nvSpPr>
+        <p:spPr>
+          <a:xfrm>
+            <a:off x="8229600" y="1965960"/>
+            <a:ext cx="3246120" cy="457200"/>
+          </a:xfrm>
+          <a:prstGeom prst="rect">
+            <a:avLst/>
+          </a:prstGeom>
+          <a:noFill/>
+          <a:ln/>
+        </p:spPr>
+        <p:txBody>
+          <a:bodyPr wrap="square" lIns="0" tIns="0" rIns="0" bIns="0" rtlCol="0" anchor="t"/>
+          <a:lstStyle/>
+          <a:p>
+            <a:pPr indent="0" marL="0">
+              <a:buNone/>
+            </a:pPr>
+            <a:r>
+              <a:rPr lang="en-US" sz="1100" dirty="0">
+                <a:solidFill>
+                  <a:schemeClr val="accent4"/>
+                </a:solidFill>
+              </a:rPr>
+              <a:t>Fixed business rules tab (view)</a:t>
+            </a:r>
+            <a:endParaRPr lang="en-US" sz="1100" dirty="0"/>
+          </a:p>
+        </p:txBody>
+      </p:sp>
+      <p:sp>
+        <p:nvSpPr>
+          <p:cNvPr id="16" name="Text 13"/>
+          <p:cNvSpPr txBox="1"/>
+          <p:nvPr/>
+        </p:nvSpPr>
+        <p:spPr>
+          <a:xfrm>
+            <a:off x="8229600" y="2514600"/>
+            <a:ext cx="3246120" cy="3566160"/>
+          </a:xfrm>
+          <a:prstGeom prst="rect">
+            <a:avLst/>
+          </a:prstGeom>
+          <a:noFill/>
+          <a:ln/>
+        </p:spPr>
+        <p:txBody>
+          <a:bodyPr wrap="square" lIns="0" tIns="0" rIns="0" bIns="0" rtlCol="0" anchor="t"/>
+          <a:lstStyle/>
+          <a:p>
+            <a:pPr marL="342900" indent="-342900">
+              <a:spcAft>
+                <a:spcPts val="800"/>
+              </a:spcAft>
+              <a:buSzPct val="100000"/>
+              <a:buChar char="•"/>
+            </a:pPr>
+            <a:r>
+              <a:rPr lang="en-US" sz="1400" dirty="0">
+                <a:solidFill>
+                  <a:schemeClr val="tx1"/>
+                </a:solidFill>
+              </a:rPr>
+              <a:t>Accrual formula and day-count conventions</a:t>
+            </a:r>
+            <a:endParaRPr lang="en-US" sz="1400" dirty="0"/>
+          </a:p>
+          <a:p>
+            <a:pPr marL="342900" indent="-342900">
+              <a:spcAft>
+                <a:spcPts val="800"/>
+              </a:spcAft>
+              <a:buSzPct val="100000"/>
+              <a:buChar char="•"/>
+            </a:pPr>
+            <a:r>
+              <a:rPr lang="en-US" sz="1400" dirty="0">
+                <a:solidFill>
+                  <a:schemeClr val="tx1"/>
+                </a:solidFill>
+              </a:rPr>
+              <a:t>EMI formula; delinquency / NPA bands; LTV</a:t>
+            </a:r>
+            <a:endParaRPr lang="en-US" sz="1400" dirty="0"/>
+          </a:p>
+          <a:p>
+            <a:pPr marL="342900" indent="-342900">
+              <a:spcAft>
+                <a:spcPts val="800"/>
+              </a:spcAft>
+              <a:buSzPct val="100000"/>
+              <a:buChar char="•"/>
+            </a:pPr>
+            <a:r>
+              <a:rPr lang="en-US" sz="1400" dirty="0">
+                <a:solidFill>
+                  <a:schemeClr val="tx1"/>
+                </a:solidFill>
+              </a:rPr>
+              <a:t>Idempotency keys; bulk limit of 200</a:t>
+            </a:r>
+            <a:endParaRPr lang="en-US" sz="1400" dirty="0"/>
+          </a:p>
+          <a:p>
+            <a:pPr marL="342900" indent="-342900">
+              <a:spcAft>
+                <a:spcPts val="800"/>
+              </a:spcAft>
+              <a:buSzPct val="100000"/>
+              <a:buChar char="•"/>
+            </a:pPr>
+            <a:r>
+              <a:rPr lang="en-US" sz="1400" dirty="0">
+                <a:solidFill>
+                  <a:schemeClr val="tx1"/>
+                </a:solidFill>
+              </a:rPr>
+              <a:t>Monthly partitions: current + 6 ahead</a:t>
+            </a:r>
+            <a:endParaRPr lang="en-US" sz="1400" dirty="0"/>
+          </a:p>
+          <a:p>
+            <a:pPr marL="342900" indent="-342900">
+              <a:spcAft>
+                <a:spcPts val="800"/>
+              </a:spcAft>
+              <a:buSzPct val="100000"/>
+              <a:buChar char="•"/>
+            </a:pPr>
+            <a:r>
+              <a:rPr lang="en-US" sz="1400" dirty="0">
+                <a:solidFill>
+                  <a:schemeClr val="tx1"/>
+                </a:solidFill>
+              </a:rPr>
+              <a:t>A change here is a code change and a release</a:t>
+            </a:r>
+            <a:endParaRPr lang="en-US" sz="1400" dirty="0"/>
+          </a:p>
+        </p:txBody>
+      </p:sp>
+      <p:sp>
+        <p:nvSpPr>
+          <p:cNvPr id="25" name="Slide Number Placeholder 0"/>
+          <p:cNvSpPr>
+            <a:spLocks noGrp="1"/>
+          </p:cNvSpPr>
+          <p:nvPr>
+            <p:ph type="sldNum" sz="quarter" idx="4294967295"/>
+          </p:nvPr>
+        </p:nvSpPr>
+        <p:spPr>
+          <a:xfrm>
+            <a:off x="11064240" y="6446520"/>
+            <a:ext cx="548640" cy="274320"/>
+          </a:xfrm>
+          <a:prstGeom prst="rect">
+            <a:avLst/>
+          </a:prstGeom>
+          <a:extLst>
+            <a:ext uri="{C572A759-6A51-4108-AA02-DFA0A04FC94B}">
+              <ma14:wrappingTextBoxFlag xmlns:ma14="http://schemas.microsoft.com/office/mac/drawingml/2011/main" val="0"/>
+            </a:ext>
+          </a:extLst>
+        </p:spPr>
+        <p:txBody>
+          <a:bodyPr/>
+          <a:lstStyle>
+            <a:lvl1pPr>
+              <a:defRPr sz="1000">
+                <a:solidFill>
+                  <a:schemeClr val="accent4"/>
+                </a:solidFill>
+              </a:defRPr>
+            </a:lvl1pPr>
+          </a:lstStyle>
+          <a:p>
+            <a:pPr algn="r"/>
+            <a:fld id="{F7021451-1387-4CA6-816F-3879F97B5CBC}" type="slidenum">
+              <a:rPr b="0" lang="en-US"/>
+              <a:t>15</a:t>
+            </a:fld>
+            <a:endParaRPr lang="en-US"/>
+          </a:p>
+        </p:txBody>
+      </p:sp>
+    </p:spTree>
+  </p:cSld>
+  <p:clrMapOvr>
+    <a:masterClrMapping/>
+  </p:clrMapOvr>
+</p:sld>
+</file>
+
+<file path=ppt/slides/slide16.xml><?xml version="1.0" encoding="utf-8"?>
+<p:sld xmlns:a="http://schemas.openxmlformats.org/drawingml/2006/main" xmlns:r="http://schemas.openxmlformats.org/officeDocument/2006/relationships" xmlns:p="http://schemas.openxmlformats.org/presentationml/2006/main">
+  <p:cSld name="Slide 16">
+    <p:spTree>
+      <p:nvGrpSpPr>
+        <p:cNvPr id="1" name=""/>
+        <p:cNvGrpSpPr/>
+        <p:nvPr/>
+      </p:nvGrpSpPr>
+      <p:grpSpPr>
+        <a:xfrm>
+          <a:off x="0" y="0"/>
+          <a:ext cx="0" cy="0"/>
+          <a:chOff x="0" y="0"/>
+          <a:chExt cx="0" cy="0"/>
+        </a:xfrm>
+      </p:grpSpPr>
+      <p:sp>
+        <p:nvSpPr>
+          <p:cNvPr id="2" name="Text 2"/>
+          <p:cNvSpPr/>
+          <p:nvPr>
+            <p:ph idx="102" type="title" hasCustomPrompt="1"/>
+          </p:nvPr>
+        </p:nvSpPr>
+        <p:spPr>
+          <a:xfrm>
+            <a:off x="548640" y="274320"/>
+            <a:ext cx="11064240" cy="685800"/>
+          </a:xfrm>
+          <a:prstGeom prst="rect">
+            <a:avLst/>
+          </a:prstGeom>
+          <a:noFill/>
+          <a:ln/>
+        </p:spPr>
+        <p:txBody>
+          <a:bodyPr wrap="square" lIns="0" tIns="0" rIns="0" bIns="0" rtlCol="0" anchor="ctr"/>
+          <a:lstStyle/>
+          <a:p>
+            <a:pPr algn="l" indent="0" marL="0">
+              <a:buNone/>
+            </a:pPr>
+            <a:r>
+              <a:rPr lang="en-US" sz="3400" b="1" dirty="0">
+                <a:solidFill>
+                  <a:schemeClr val="tx2"/>
+                </a:solidFill>
+              </a:rPr>
+              <a:t>Sandbox URLs and changes since v1.0</a:t>
+            </a:r>
+            <a:endParaRPr lang="en-US" sz="3400" dirty="0"/>
+          </a:p>
+        </p:txBody>
+      </p:sp>
+      <p:sp>
+        <p:nvSpPr>
+          <p:cNvPr id="3" name="Text 2"/>
+          <p:cNvSpPr/>
+          <p:nvPr>
+            <p:ph idx="103" type="body" hasCustomPrompt="1"/>
+          </p:nvPr>
+        </p:nvSpPr>
+        <p:spPr>
+          <a:xfrm>
+            <a:off x="548640" y="960120"/>
+            <a:ext cx="11064240" cy="365760"/>
+          </a:xfrm>
+          <a:prstGeom prst="rect">
+            <a:avLst/>
+          </a:prstGeom>
+          <a:noFill/>
+          <a:ln/>
+        </p:spPr>
+        <p:txBody>
+          <a:bodyPr wrap="square" lIns="0" tIns="0" rIns="0" bIns="0" rtlCol="0" anchor="t"/>
+          <a:lstStyle/>
+          <a:p>
+            <a:pPr algn="l" indent="0" marL="0">
+              <a:buNone/>
+            </a:pPr>
+            <a:r>
+              <a:rPr lang="en-US" sz="1400" dirty="0">
+                <a:solidFill>
+                  <a:schemeClr val="accent4"/>
+                </a:solidFill>
+              </a:rPr>
               <a:t>Render free tier: services sleep when idle, so the first request takes about a minute</a:t>
             </a:r>
             <a:endParaRPr lang="en-US" sz="1400" dirty="0"/>
@@ -10428,7 +11436,7 @@
       </p:sp>
       <p:graphicFrame>
         <p:nvGraphicFramePr>
-          <p:cNvPr id="16" name="Table 0"/>
+          <p:cNvPr id="17" name="Table 0"/>
           <p:cNvGraphicFramePr>
             <a:graphicFrameLocks noGrp="1"/>
           </p:cNvGraphicFramePr>
@@ -11194,7 +12202,7 @@
                   <a:schemeClr val="tx1"/>
                 </a:solidFill>
               </a:rPr>
-              <a:t>New read-only React + Spring Boot service</a:t>
+              <a:t>New React + Spring Boot service; Configuration screen edits batch jobs (new PUT on the batch API)</a:t>
             </a:r>
             <a:endParaRPr lang="en-US" sz="1200" dirty="0"/>
           </a:p>
@@ -11539,7 +12547,7 @@
             <a:pPr algn="r"/>
             <a:fld id="{F7021451-1387-4CA6-816F-3879F97B5CBC}" type="slidenum">
               <a:rPr b="0" lang="en-US"/>
-              <a:t>15</a:t>
+              <a:t>16</a:t>
             </a:fld>
             <a:endParaRPr lang="en-US"/>
           </a:p>
@@ -11553,9 +12561,9 @@
 </p:sld>
 </file>
 
-<file path=ppt/slides/slide16.xml><?xml version="1.0" encoding="utf-8"?>
+<file path=ppt/slides/slide17.xml><?xml version="1.0" encoding="utf-8"?>
 <p:sld xmlns:a="http://schemas.openxmlformats.org/drawingml/2006/main" xmlns:r="http://schemas.openxmlformats.org/officeDocument/2006/relationships" xmlns:p="http://schemas.openxmlformats.org/presentationml/2006/main">
-  <p:cSld name="Slide 16">
+  <p:cSld name="Slide 17">
     <p:spTree>
       <p:nvGrpSpPr>
         <p:cNvPr id="1" name=""/>
@@ -11648,7 +12656,7 @@
       </p:sp>
       <p:graphicFrame>
         <p:nvGraphicFramePr>
-          <p:cNvPr id="17" name="Table 0"/>
+          <p:cNvPr id="18" name="Table 0"/>
           <p:cNvGraphicFramePr>
             <a:graphicFrameLocks noGrp="1"/>
           </p:cNvGraphicFramePr>
@@ -14541,7 +15549,7 @@
             <a:pPr algn="r"/>
             <a:fld id="{F7021451-1387-4CA6-816F-3879F97B5CBC}" type="slidenum">
               <a:rPr b="0" lang="en-US"/>
-              <a:t>16</a:t>
+              <a:t>17</a:t>
             </a:fld>
             <a:endParaRPr lang="en-US"/>
           </a:p>
@@ -14555,9 +15563,9 @@
 </p:sld>
 </file>
 
-<file path=ppt/slides/slide17.xml><?xml version="1.0" encoding="utf-8"?>
+<file path=ppt/slides/slide18.xml><?xml version="1.0" encoding="utf-8"?>
 <p:sld xmlns:a="http://schemas.openxmlformats.org/drawingml/2006/main" xmlns:r="http://schemas.openxmlformats.org/officeDocument/2006/relationships" xmlns:p="http://schemas.openxmlformats.org/presentationml/2006/main">
-  <p:cSld name="Slide 17">
+  <p:cSld name="Slide 18">
     <p:spTree>
       <p:nvGrpSpPr>
         <p:cNvPr id="1" name=""/>
@@ -15193,7 +16201,7 @@
                   <a:schemeClr val="accent4"/>
                 </a:solidFill>
               </a:rPr>
-              <a:t>Two services, one database, the full loan lifecycle from sanction to closure</a:t>
+              <a:t>Three services, one database: the full loan lifecycle from sanction to closure, plus an admin console to see and tune it</a:t>
             </a:r>
             <a:endParaRPr lang="en-US" sz="1400" dirty="0"/>
           </a:p>
@@ -15207,12 +16215,12 @@
         </p:nvSpPr>
         <p:spPr>
           <a:xfrm>
-            <a:off x="548640" y="1554480"/>
-            <a:ext cx="2606040" cy="1554480"/>
+            <a:off x="548640" y="1463040"/>
+            <a:ext cx="2606040" cy="1234440"/>
           </a:xfrm>
           <a:prstGeom prst="roundRect">
             <a:avLst>
-              <a:gd name="adj" fmla="val 4706"/>
+              <a:gd name="adj" fmla="val 5926"/>
             </a:avLst>
           </a:prstGeom>
           <a:solidFill>
@@ -15232,7 +16240,7 @@
               <a:buNone/>
             </a:pPr>
             <a:r>
-              <a:rPr lang="en-US" sz="4800" b="1" dirty="0">
+              <a:rPr lang="en-US" sz="4000" b="1" dirty="0">
                 <a:solidFill>
                   <a:schemeClr val="bg1"/>
                 </a:solidFill>
@@ -15240,7 +16248,7 @@
                 <a:ea typeface="Cambria" pitchFamily="34" charset="-122"/>
                 <a:cs typeface="Cambria" pitchFamily="34" charset="-120"/>
               </a:rPr>
-              <a:t>2</a:t>
+              <a:t>3</a:t>
             </a:r>
             <a:endParaRPr lang="en-US" sz="1200" dirty="0"/>
           </a:p>
@@ -15249,7 +16257,7 @@
               <a:buNone/>
             </a:pPr>
             <a:r>
-              <a:rPr lang="en-US" sz="1400" dirty="0">
+              <a:rPr lang="en-US" sz="1300" dirty="0">
                 <a:solidFill>
                   <a:schemeClr val="bg1"/>
                 </a:solidFill>
@@ -15268,12 +16276,12 @@
         </p:nvSpPr>
         <p:spPr>
           <a:xfrm>
-            <a:off x="3337560" y="1554480"/>
-            <a:ext cx="2606040" cy="1554480"/>
+            <a:off x="3337560" y="1463040"/>
+            <a:ext cx="2606040" cy="1234440"/>
           </a:xfrm>
           <a:prstGeom prst="roundRect">
             <a:avLst>
-              <a:gd name="adj" fmla="val 4706"/>
+              <a:gd name="adj" fmla="val 5926"/>
             </a:avLst>
           </a:prstGeom>
           <a:solidFill>
@@ -15293,7 +16301,7 @@
               <a:buNone/>
             </a:pPr>
             <a:r>
-              <a:rPr lang="en-US" sz="4800" b="1" dirty="0">
+              <a:rPr lang="en-US" sz="4000" b="1" dirty="0">
                 <a:solidFill>
                   <a:schemeClr val="bg1"/>
                 </a:solidFill>
@@ -15310,7 +16318,7 @@
               <a:buNone/>
             </a:pPr>
             <a:r>
-              <a:rPr lang="en-US" sz="1400" dirty="0">
+              <a:rPr lang="en-US" sz="1300" dirty="0">
                 <a:solidFill>
                   <a:schemeClr val="bg1"/>
                 </a:solidFill>
@@ -15329,12 +16337,12 @@
         </p:nvSpPr>
         <p:spPr>
           <a:xfrm>
-            <a:off x="6126480" y="1554480"/>
-            <a:ext cx="2606040" cy="1554480"/>
+            <a:off x="6126480" y="1463040"/>
+            <a:ext cx="2606040" cy="1234440"/>
           </a:xfrm>
           <a:prstGeom prst="roundRect">
             <a:avLst>
-              <a:gd name="adj" fmla="val 4706"/>
+              <a:gd name="adj" fmla="val 5926"/>
             </a:avLst>
           </a:prstGeom>
           <a:solidFill>
@@ -15354,7 +16362,7 @@
               <a:buNone/>
             </a:pPr>
             <a:r>
-              <a:rPr lang="en-US" sz="4800" b="1" dirty="0">
+              <a:rPr lang="en-US" sz="4000" b="1" dirty="0">
                 <a:solidFill>
                   <a:schemeClr val="bg1"/>
                 </a:solidFill>
@@ -15362,7 +16370,7 @@
                 <a:ea typeface="Cambria" pitchFamily="34" charset="-122"/>
                 <a:cs typeface="Cambria" pitchFamily="34" charset="-120"/>
               </a:rPr>
-              <a:t>25+</a:t>
+              <a:t>36</a:t>
             </a:r>
             <a:endParaRPr lang="en-US" sz="1200" dirty="0"/>
           </a:p>
@@ -15371,12 +16379,12 @@
               <a:buNone/>
             </a:pPr>
             <a:r>
-              <a:rPr lang="en-US" sz="1400" dirty="0">
+              <a:rPr lang="en-US" sz="1300" dirty="0">
                 <a:solidFill>
                   <a:schemeClr val="bg1"/>
                 </a:solidFill>
               </a:rPr>
-              <a:t>REST endpoints</a:t>
+              <a:t>batch job slots</a:t>
             </a:r>
             <a:endParaRPr lang="en-US" sz="1200" dirty="0"/>
           </a:p>
@@ -15390,12 +16398,12 @@
         </p:nvSpPr>
         <p:spPr>
           <a:xfrm>
-            <a:off x="8915400" y="1554480"/>
-            <a:ext cx="2606040" cy="1554480"/>
+            <a:off x="8915400" y="1463040"/>
+            <a:ext cx="2606040" cy="1234440"/>
           </a:xfrm>
           <a:prstGeom prst="roundRect">
             <a:avLst>
-              <a:gd name="adj" fmla="val 4706"/>
+              <a:gd name="adj" fmla="val 5926"/>
             </a:avLst>
           </a:prstGeom>
           <a:solidFill>
@@ -15415,7 +16423,7 @@
               <a:buNone/>
             </a:pPr>
             <a:r>
-              <a:rPr lang="en-US" sz="4800" b="1" dirty="0">
+              <a:rPr lang="en-US" sz="4000" b="1" dirty="0">
                 <a:solidFill>
                   <a:schemeClr val="bg1"/>
                 </a:solidFill>
@@ -15423,7 +16431,7 @@
                 <a:ea typeface="Cambria" pitchFamily="34" charset="-122"/>
                 <a:cs typeface="Cambria" pitchFamily="34" charset="-120"/>
               </a:rPr>
-              <a:t>36</a:t>
+              <a:t>10</a:t>
             </a:r>
             <a:endParaRPr lang="en-US" sz="1200" dirty="0"/>
           </a:p>
@@ -15432,12 +16440,12 @@
               <a:buNone/>
             </a:pPr>
             <a:r>
-              <a:rPr lang="en-US" sz="1400" dirty="0">
+              <a:rPr lang="en-US" sz="1300" dirty="0">
                 <a:solidFill>
                   <a:schemeClr val="bg1"/>
                 </a:solidFill>
               </a:rPr>
-              <a:t>batch job slots</a:t>
+              <a:t>admin portal screens</a:t>
             </a:r>
             <a:endParaRPr lang="en-US" sz="1200" dirty="0"/>
           </a:p>
@@ -15451,20 +16459,20 @@
         </p:nvSpPr>
         <p:spPr>
           <a:xfrm>
-            <a:off x="548640" y="3383280"/>
-            <a:ext cx="5440680" cy="2651760"/>
+            <a:off x="548640" y="2926080"/>
+            <a:ext cx="3566160" cy="3383280"/>
           </a:xfrm>
           <a:prstGeom prst="roundRect">
             <a:avLst>
-              <a:gd name="adj" fmla="val 2759"/>
+              <a:gd name="adj" fmla="val 2162"/>
             </a:avLst>
           </a:prstGeom>
           <a:solidFill>
             <a:schemeClr val="accent1">
-              <a:alpha val="10000"/>
+              <a:alpha val="12000"/>
             </a:schemeClr>
           </a:solidFill>
-          <a:ln w="12700">
+          <a:ln w="19050">
             <a:solidFill>
               <a:schemeClr val="accent1"/>
             </a:solidFill>
@@ -15489,8 +16497,8 @@
         </p:nvSpPr>
         <p:spPr>
           <a:xfrm>
-            <a:off x="777240" y="3493008"/>
-            <a:ext cx="5029200" cy="320040"/>
+            <a:off x="731520" y="3017520"/>
+            <a:ext cx="3200400" cy="320040"/>
           </a:xfrm>
           <a:prstGeom prst="rect">
             <a:avLst/>
@@ -15506,14 +16514,14 @@
               <a:buNone/>
             </a:pPr>
             <a:r>
-              <a:rPr lang="en-US" sz="1800" b="1" dirty="0">
+              <a:rPr lang="en-US" sz="1600" b="1" dirty="0">
                 <a:solidFill>
                   <a:schemeClr val="tx2"/>
                 </a:solidFill>
               </a:rPr>
               <a:t>lending-service</a:t>
             </a:r>
-            <a:endParaRPr lang="en-US" sz="1800" dirty="0"/>
+            <a:endParaRPr lang="en-US" sz="1600" dirty="0"/>
           </a:p>
         </p:txBody>
       </p:sp>
@@ -15525,8 +16533,8 @@
         </p:nvSpPr>
         <p:spPr>
           <a:xfrm>
-            <a:off x="777240" y="3840480"/>
-            <a:ext cx="5029200" cy="274320"/>
+            <a:off x="731520" y="3346704"/>
+            <a:ext cx="3246120" cy="274320"/>
           </a:xfrm>
           <a:prstGeom prst="rect">
             <a:avLst/>
@@ -15542,14 +16550,14 @@
               <a:buNone/>
             </a:pPr>
             <a:r>
-              <a:rPr lang="en-US" sz="1200" dirty="0">
+              <a:rPr lang="en-US" sz="1050" dirty="0">
                 <a:solidFill>
                   <a:schemeClr val="accent4"/>
                 </a:solidFill>
               </a:rPr>
               <a:t>Java 21  |  Spring Boot 3.3  |  port 8080</a:t>
             </a:r>
-            <a:endParaRPr lang="en-US" sz="1200" dirty="0"/>
+            <a:endParaRPr lang="en-US" sz="1050" dirty="0"/>
           </a:p>
         </p:txBody>
       </p:sp>
@@ -15561,8 +16569,8 @@
         </p:nvSpPr>
         <p:spPr>
           <a:xfrm>
-            <a:off x="777240" y="4160520"/>
-            <a:ext cx="5029200" cy="1828800"/>
+            <a:off x="731520" y="3703320"/>
+            <a:ext cx="3246120" cy="2560320"/>
           </a:xfrm>
           <a:prstGeom prst="rect">
             <a:avLst/>
@@ -15576,110 +16584,110 @@
           <a:p>
             <a:pPr marL="342900" indent="-342900">
               <a:spcAft>
-                <a:spcPts val="300"/>
+                <a:spcPts val="400"/>
               </a:spcAft>
               <a:buSzPct val="100000"/>
               <a:buChar char="•"/>
             </a:pPr>
             <a:r>
-              <a:rPr lang="en-US" sz="1500" dirty="0">
+              <a:rPr lang="en-US" sz="1250" dirty="0">
                 <a:solidFill>
                   <a:schemeClr val="tx1"/>
                 </a:solidFill>
               </a:rPr>
               <a:t>Accounts: create, bulk create, disburse, lookup</a:t>
             </a:r>
-            <a:endParaRPr lang="en-US" sz="1500" dirty="0"/>
+            <a:endParaRPr lang="en-US" sz="1250" dirty="0"/>
           </a:p>
           <a:p>
             <a:pPr marL="342900" indent="-342900">
               <a:spcAft>
-                <a:spcPts val="300"/>
+                <a:spcPts val="400"/>
               </a:spcAft>
               <a:buSzPct val="100000"/>
               <a:buChar char="•"/>
             </a:pPr>
             <a:r>
-              <a:rPr lang="en-US" sz="1500" dirty="0">
+              <a:rPr lang="en-US" sz="1250" dirty="0">
                 <a:solidFill>
                   <a:schemeClr val="tx1"/>
                 </a:solidFill>
               </a:rPr>
               <a:t>Amortisation schedules with versioning</a:t>
             </a:r>
-            <a:endParaRPr lang="en-US" sz="1500" dirty="0"/>
+            <a:endParaRPr lang="en-US" sz="1250" dirty="0"/>
           </a:p>
           <a:p>
             <a:pPr marL="342900" indent="-342900">
               <a:spcAft>
-                <a:spcPts val="300"/>
+                <a:spcPts val="400"/>
               </a:spcAft>
               <a:buSzPct val="100000"/>
               <a:buChar char="•"/>
             </a:pPr>
             <a:r>
-              <a:rPr lang="en-US" sz="1500" dirty="0">
+              <a:rPr lang="en-US" sz="1250" dirty="0">
                 <a:solidFill>
                   <a:schemeClr val="tx1"/>
                 </a:solidFill>
               </a:rPr>
               <a:t>EMI, part-payment and foreclosure postings</a:t>
             </a:r>
-            <a:endParaRPr lang="en-US" sz="1500" dirty="0"/>
+            <a:endParaRPr lang="en-US" sz="1250" dirty="0"/>
           </a:p>
           <a:p>
             <a:pPr marL="342900" indent="-342900">
               <a:spcAft>
-                <a:spcPts val="300"/>
+                <a:spcPts val="400"/>
               </a:spcAft>
               <a:buSzPct val="100000"/>
               <a:buChar char="•"/>
             </a:pPr>
             <a:r>
-              <a:rPr lang="en-US" sz="1500" dirty="0">
+              <a:rPr lang="en-US" sz="1250" dirty="0">
                 <a:solidFill>
                   <a:schemeClr val="tx1"/>
                 </a:solidFill>
               </a:rPr>
-              <a:t>Daily interest accrual and delinquency (DPD / NPA) classification</a:t>
-            </a:r>
-            <a:endParaRPr lang="en-US" sz="1500" dirty="0"/>
+              <a:t>Daily accrual; delinquency (DPD / NPA) classification</a:t>
+            </a:r>
+            <a:endParaRPr lang="en-US" sz="1250" dirty="0"/>
           </a:p>
           <a:p>
             <a:pPr marL="342900" indent="-342900">
               <a:spcAft>
-                <a:spcPts val="300"/>
+                <a:spcPts val="400"/>
               </a:spcAft>
               <a:buSzPct val="100000"/>
               <a:buChar char="•"/>
             </a:pPr>
             <a:r>
-              <a:rPr lang="en-US" sz="1500" dirty="0">
+              <a:rPr lang="en-US" sz="1250" dirty="0">
                 <a:solidFill>
                   <a:schemeClr val="tx1"/>
                 </a:solidFill>
               </a:rPr>
               <a:t>Mortgage charge and valuation tracking</a:t>
             </a:r>
-            <a:endParaRPr lang="en-US" sz="1500" dirty="0"/>
+            <a:endParaRPr lang="en-US" sz="1250" dirty="0"/>
           </a:p>
           <a:p>
             <a:pPr marL="342900" indent="-342900">
               <a:spcAft>
-                <a:spcPts val="300"/>
+                <a:spcPts val="400"/>
               </a:spcAft>
               <a:buSzPct val="100000"/>
               <a:buChar char="•"/>
             </a:pPr>
             <a:r>
-              <a:rPr lang="en-US" sz="1500" dirty="0">
+              <a:rPr lang="en-US" sz="1250" dirty="0">
                 <a:solidFill>
                   <a:schemeClr val="tx1"/>
                 </a:solidFill>
               </a:rPr>
               <a:t>Ledger outbox and customer PDF statements</a:t>
             </a:r>
-            <a:endParaRPr lang="en-US" sz="1500" dirty="0"/>
+            <a:endParaRPr lang="en-US" sz="1250" dirty="0"/>
           </a:p>
         </p:txBody>
       </p:sp>
@@ -15691,22 +16699,22 @@
         </p:nvSpPr>
         <p:spPr>
           <a:xfrm>
-            <a:off x="6172200" y="3383280"/>
-            <a:ext cx="5440680" cy="2651760"/>
+            <a:off x="4297680" y="2926080"/>
+            <a:ext cx="3566160" cy="3383280"/>
           </a:xfrm>
           <a:prstGeom prst="roundRect">
             <a:avLst>
-              <a:gd name="adj" fmla="val 2759"/>
+              <a:gd name="adj" fmla="val 2162"/>
             </a:avLst>
           </a:prstGeom>
           <a:solidFill>
-            <a:schemeClr val="accent1">
-              <a:alpha val="10000"/>
+            <a:schemeClr val="accent4">
+              <a:alpha val="12000"/>
             </a:schemeClr>
           </a:solidFill>
-          <a:ln w="12700">
+          <a:ln w="19050">
             <a:solidFill>
-              <a:schemeClr val="accent1"/>
+              <a:schemeClr val="accent4"/>
             </a:solidFill>
           </a:ln>
         </p:spPr>
@@ -15729,8 +16737,8 @@
         </p:nvSpPr>
         <p:spPr>
           <a:xfrm>
-            <a:off x="6400800" y="3493008"/>
-            <a:ext cx="5029200" cy="320040"/>
+            <a:off x="4480560" y="3017520"/>
+            <a:ext cx="3200400" cy="320040"/>
           </a:xfrm>
           <a:prstGeom prst="rect">
             <a:avLst/>
@@ -15746,14 +16754,14 @@
               <a:buNone/>
             </a:pPr>
             <a:r>
-              <a:rPr lang="en-US" sz="1800" b="1" dirty="0">
+              <a:rPr lang="en-US" sz="1600" b="1" dirty="0">
                 <a:solidFill>
                   <a:schemeClr val="tx2"/>
                 </a:solidFill>
               </a:rPr>
               <a:t>lending-batch-service</a:t>
             </a:r>
-            <a:endParaRPr lang="en-US" sz="1800" dirty="0"/>
+            <a:endParaRPr lang="en-US" sz="1600" dirty="0"/>
           </a:p>
         </p:txBody>
       </p:sp>
@@ -15765,8 +16773,8 @@
         </p:nvSpPr>
         <p:spPr>
           <a:xfrm>
-            <a:off x="6400800" y="3840480"/>
-            <a:ext cx="5029200" cy="274320"/>
+            <a:off x="4480560" y="3346704"/>
+            <a:ext cx="3246120" cy="274320"/>
           </a:xfrm>
           <a:prstGeom prst="rect">
             <a:avLst/>
@@ -15782,14 +16790,14 @@
               <a:buNone/>
             </a:pPr>
             <a:r>
-              <a:rPr lang="en-US" sz="1200" dirty="0">
+              <a:rPr lang="en-US" sz="1050" dirty="0">
                 <a:solidFill>
                   <a:schemeClr val="accent4"/>
                 </a:solidFill>
               </a:rPr>
-              <a:t>Java 17  |  Spring Batch 5  |  Quartz  |  Kafka producer</a:t>
-            </a:r>
-            <a:endParaRPr lang="en-US" sz="1200" dirty="0"/>
+              <a:t>Java 17  |  Spring Batch 5  |  Quartz  |  Kafka</a:t>
+            </a:r>
+            <a:endParaRPr lang="en-US" sz="1050" dirty="0"/>
           </a:p>
         </p:txBody>
       </p:sp>
@@ -15801,8 +16809,8 @@
         </p:nvSpPr>
         <p:spPr>
           <a:xfrm>
-            <a:off x="6400800" y="4160520"/>
-            <a:ext cx="5029200" cy="1828800"/>
+            <a:off x="4480560" y="3703320"/>
+            <a:ext cx="3246120" cy="2560320"/>
           </a:xfrm>
           <a:prstGeom prst="rect">
             <a:avLst/>
@@ -15816,92 +16824,314 @@
           <a:p>
             <a:pPr marL="342900" indent="-342900">
               <a:spcAft>
-                <a:spcPts val="300"/>
+                <a:spcPts val="400"/>
               </a:spcAft>
               <a:buSzPct val="100000"/>
               <a:buChar char="•"/>
             </a:pPr>
             <a:r>
-              <a:rPr lang="en-US" sz="1500" dirty="0">
+              <a:rPr lang="en-US" sz="1250" dirty="0">
                 <a:solidFill>
                   <a:schemeClr val="tx1"/>
                 </a:solidFill>
               </a:rPr>
-              <a:t>Quartz clustered scheduler over the same PostgreSQL</a:t>
-            </a:r>
-            <a:endParaRPr lang="en-US" sz="1500" dirty="0"/>
+              <a:t>Clustered Quartz scheduler on the same PostgreSQL</a:t>
+            </a:r>
+            <a:endParaRPr lang="en-US" sz="1250" dirty="0"/>
           </a:p>
           <a:p>
             <a:pPr marL="342900" indent="-342900">
               <a:spcAft>
-                <a:spcPts val="300"/>
+                <a:spcPts val="400"/>
               </a:spcAft>
               <a:buSzPct val="100000"/>
               <a:buChar char="•"/>
             </a:pPr>
             <a:r>
-              <a:rPr lang="en-US" sz="1500" dirty="0">
+              <a:rPr lang="en-US" sz="1250" dirty="0">
                 <a:solidFill>
                   <a:schemeClr val="tx1"/>
                 </a:solidFill>
               </a:rPr>
-              <a:t>36 configured jobs: 13 daily, 11 monthly, 12 periodic</a:t>
-            </a:r>
-            <a:endParaRPr lang="en-US" sz="1500" dirty="0"/>
+              <a:t>36 jobs: 13 daily, 11 monthly, 12 periodic</a:t>
+            </a:r>
+            <a:endParaRPr lang="en-US" sz="1250" dirty="0"/>
           </a:p>
           <a:p>
             <a:pPr marL="342900" indent="-342900">
               <a:spcAft>
-                <a:spcPts val="300"/>
+                <a:spcPts val="400"/>
               </a:spcAft>
               <a:buSzPct val="100000"/>
               <a:buChar char="•"/>
             </a:pPr>
             <a:r>
-              <a:rPr lang="en-US" sz="1500" dirty="0">
+              <a:rPr lang="en-US" sz="1250" dirty="0">
                 <a:solidFill>
                   <a:schemeClr val="tx1"/>
                 </a:solidFill>
               </a:rPr>
               <a:t>Retry, skip and dead-letter handling per job</a:t>
             </a:r>
-            <a:endParaRPr lang="en-US" sz="1500" dirty="0"/>
+            <a:endParaRPr lang="en-US" sz="1250" dirty="0"/>
           </a:p>
           <a:p>
             <a:pPr marL="342900" indent="-342900">
               <a:spcAft>
-                <a:spcPts val="300"/>
+                <a:spcPts val="400"/>
               </a:spcAft>
               <a:buSzPct val="100000"/>
               <a:buChar char="•"/>
             </a:pPr>
             <a:r>
-              <a:rPr lang="en-US" sz="1500" dirty="0">
+              <a:rPr lang="en-US" sz="1250" dirty="0">
                 <a:solidFill>
                   <a:schemeClr val="tx1"/>
                 </a:solidFill>
               </a:rPr>
-              <a:t>Admin REST API: trigger, back-date, status, reload config</a:t>
-            </a:r>
-            <a:endParaRPr lang="en-US" sz="1500" dirty="0"/>
+              <a:t>Admin REST API: trigger, back-date, status, reload, edit a job</a:t>
+            </a:r>
+            <a:endParaRPr lang="en-US" sz="1250" dirty="0"/>
           </a:p>
           <a:p>
             <a:pPr marL="342900" indent="-342900">
               <a:spcAft>
-                <a:spcPts val="300"/>
+                <a:spcPts val="400"/>
               </a:spcAft>
               <a:buSzPct val="100000"/>
               <a:buChar char="•"/>
             </a:pPr>
             <a:r>
-              <a:rPr lang="en-US" sz="1500" dirty="0">
+              <a:rPr lang="en-US" sz="1250" dirty="0">
                 <a:solidFill>
                   <a:schemeClr val="tx1"/>
                 </a:solidFill>
               </a:rPr>
-              <a:t>Job definitions live in a database table, reloadable without restart</a:t>
-            </a:r>
-            <a:endParaRPr lang="en-US" sz="1500" dirty="0"/>
+              <a:t>Job settings live in a table; reload without restart</a:t>
+            </a:r>
+            <a:endParaRPr lang="en-US" sz="1250" dirty="0"/>
+          </a:p>
+        </p:txBody>
+      </p:sp>
+      <p:sp>
+        <p:nvSpPr>
+          <p:cNvPr id="17" name="Text 14"/>
+          <p:cNvSpPr txBox="1"/>
+          <p:nvPr/>
+        </p:nvSpPr>
+        <p:spPr>
+          <a:xfrm>
+            <a:off x="8046720" y="2926080"/>
+            <a:ext cx="3566160" cy="3383280"/>
+          </a:xfrm>
+          <a:prstGeom prst="roundRect">
+            <a:avLst>
+              <a:gd name="adj" fmla="val 2162"/>
+            </a:avLst>
+          </a:prstGeom>
+          <a:solidFill>
+            <a:schemeClr val="accent2">
+              <a:alpha val="12000"/>
+            </a:schemeClr>
+          </a:solidFill>
+          <a:ln w="19050">
+            <a:solidFill>
+              <a:schemeClr val="accent2"/>
+            </a:solidFill>
+          </a:ln>
+        </p:spPr>
+        <p:txBody>
+          <a:bodyPr wrap="square" lIns="50800" tIns="50800" rIns="50800" bIns="50800" rtlCol="0" anchor="ctr"/>
+          <a:lstStyle/>
+          <a:p>
+            <a:pPr algn="ctr" indent="0" marL="0">
+              <a:buNone/>
+            </a:pPr>
+            <a:endParaRPr lang="en-US" sz="1200" dirty="0"/>
+          </a:p>
+        </p:txBody>
+      </p:sp>
+      <p:sp>
+        <p:nvSpPr>
+          <p:cNvPr id="18" name="Text 15"/>
+          <p:cNvSpPr txBox="1"/>
+          <p:nvPr/>
+        </p:nvSpPr>
+        <p:spPr>
+          <a:xfrm>
+            <a:off x="8229600" y="3017520"/>
+            <a:ext cx="3200400" cy="320040"/>
+          </a:xfrm>
+          <a:prstGeom prst="rect">
+            <a:avLst/>
+          </a:prstGeom>
+          <a:noFill/>
+          <a:ln/>
+        </p:spPr>
+        <p:txBody>
+          <a:bodyPr wrap="square" lIns="0" tIns="0" rIns="0" bIns="0" rtlCol="0" anchor="t"/>
+          <a:lstStyle/>
+          <a:p>
+            <a:pPr indent="0" marL="0">
+              <a:buNone/>
+            </a:pPr>
+            <a:r>
+              <a:rPr lang="en-US" sz="1600" b="1" dirty="0">
+                <a:solidFill>
+                  <a:schemeClr val="tx2"/>
+                </a:solidFill>
+              </a:rPr>
+              <a:t>lending-admin-service  (new)</a:t>
+            </a:r>
+            <a:endParaRPr lang="en-US" sz="1600" dirty="0"/>
+          </a:p>
+        </p:txBody>
+      </p:sp>
+      <p:sp>
+        <p:nvSpPr>
+          <p:cNvPr id="19" name="Text 16"/>
+          <p:cNvSpPr txBox="1"/>
+          <p:nvPr/>
+        </p:nvSpPr>
+        <p:spPr>
+          <a:xfrm>
+            <a:off x="8229600" y="3346704"/>
+            <a:ext cx="3246120" cy="274320"/>
+          </a:xfrm>
+          <a:prstGeom prst="rect">
+            <a:avLst/>
+          </a:prstGeom>
+          <a:noFill/>
+          <a:ln/>
+        </p:spPr>
+        <p:txBody>
+          <a:bodyPr wrap="square" lIns="0" tIns="0" rIns="0" bIns="0" rtlCol="0" anchor="t"/>
+          <a:lstStyle/>
+          <a:p>
+            <a:pPr indent="0" marL="0">
+              <a:buNone/>
+            </a:pPr>
+            <a:r>
+              <a:rPr lang="en-US" sz="1050" dirty="0">
+                <a:solidFill>
+                  <a:schemeClr val="accent4"/>
+                </a:solidFill>
+              </a:rPr>
+              <a:t>Java 17  |  Spring Boot 3.3 + React 18  |  port 8082</a:t>
+            </a:r>
+            <a:endParaRPr lang="en-US" sz="1050" dirty="0"/>
+          </a:p>
+        </p:txBody>
+      </p:sp>
+      <p:sp>
+        <p:nvSpPr>
+          <p:cNvPr id="20" name="Text 17"/>
+          <p:cNvSpPr txBox="1"/>
+          <p:nvPr/>
+        </p:nvSpPr>
+        <p:spPr>
+          <a:xfrm>
+            <a:off x="8229600" y="3703320"/>
+            <a:ext cx="3246120" cy="2560320"/>
+          </a:xfrm>
+          <a:prstGeom prst="rect">
+            <a:avLst/>
+          </a:prstGeom>
+          <a:noFill/>
+          <a:ln/>
+        </p:spPr>
+        <p:txBody>
+          <a:bodyPr wrap="square" lIns="0" tIns="0" rIns="0" bIns="0" rtlCol="0" anchor="t"/>
+          <a:lstStyle/>
+          <a:p>
+            <a:pPr marL="342900" indent="-342900">
+              <a:spcAft>
+                <a:spcPts val="400"/>
+              </a:spcAft>
+              <a:buSzPct val="100000"/>
+              <a:buChar char="•"/>
+            </a:pPr>
+            <a:r>
+              <a:rPr lang="en-US" sz="1250" dirty="0">
+                <a:solidFill>
+                  <a:schemeClr val="tx1"/>
+                </a:solidFill>
+              </a:rPr>
+              <a:t>Account search and inquiry: amortisation, accruals, payments, mortgage, statement PDF</a:t>
+            </a:r>
+            <a:endParaRPr lang="en-US" sz="1250" dirty="0"/>
+          </a:p>
+          <a:p>
+            <a:pPr marL="342900" indent="-342900">
+              <a:spcAft>
+                <a:spcPts val="400"/>
+              </a:spcAft>
+              <a:buSzPct val="100000"/>
+              <a:buChar char="•"/>
+            </a:pPr>
+            <a:r>
+              <a:rPr lang="en-US" sz="1250" dirty="0">
+                <a:solidFill>
+                  <a:schemeClr val="tx1"/>
+                </a:solidFill>
+              </a:rPr>
+              <a:t>Upcoming payments and overdue by days past due</a:t>
+            </a:r>
+            <a:endParaRPr lang="en-US" sz="1250" dirty="0"/>
+          </a:p>
+          <a:p>
+            <a:pPr marL="342900" indent="-342900">
+              <a:spcAft>
+                <a:spcPts val="400"/>
+              </a:spcAft>
+              <a:buSzPct val="100000"/>
+              <a:buChar char="•"/>
+            </a:pPr>
+            <a:r>
+              <a:rPr lang="en-US" sz="1250" dirty="0">
+                <a:solidFill>
+                  <a:schemeClr val="tx1"/>
+                </a:solidFill>
+              </a:rPr>
+              <a:t>Portfolio dashboard, ledger outbox, batch runs</a:t>
+            </a:r>
+            <a:endParaRPr lang="en-US" sz="1250" dirty="0"/>
+          </a:p>
+          <a:p>
+            <a:pPr marL="342900" indent="-342900">
+              <a:spcAft>
+                <a:spcPts val="400"/>
+              </a:spcAft>
+              <a:buSzPct val="100000"/>
+              <a:buChar char="•"/>
+            </a:pPr>
+            <a:r>
+              <a:rPr lang="en-US" sz="1250" dirty="0">
+                <a:solidFill>
+                  <a:schemeClr val="tx1"/>
+                </a:solidFill>
+              </a:rPr>
+              <a:t>Configuration: edit batch job settings; view every service's settings</a:t>
+            </a:r>
+            <a:endParaRPr lang="en-US" sz="1250" dirty="0"/>
+          </a:p>
+          <a:p>
+            <a:pPr marL="342900" indent="-342900">
+              <a:spcAft>
+                <a:spcPts val="400"/>
+              </a:spcAft>
+              <a:buSzPct val="100000"/>
+              <a:buChar char="•"/>
+            </a:pPr>
+            <a:r>
+              <a:rPr lang="en-US" sz="1250" dirty="0">
+                <a:solidFill>
+                  <a:schemeClr val="tx1"/>
+                </a:solidFill>
+              </a:rPr>
+              <a:t>Basic login; read-only database session</a:t>
+            </a:r>
+            <a:endParaRPr lang="en-US" sz="1250" dirty="0"/>
           </a:p>
         </p:txBody>
       </p:sp>
@@ -16045,7 +17275,7 @@
                   <a:schemeClr val="accent4"/>
                 </a:solidFill>
               </a:rPr>
-              <a:t>Two stateless services share one PostgreSQL database; external systems sit at the edges</a:t>
+              <a:t>Three stateless services share one PostgreSQL database; the admin console only reads it</a:t>
             </a:r>
             <a:endParaRPr lang="en-US" sz="1400" dirty="0"/>
           </a:p>
@@ -16059,12 +17289,12 @@
         </p:nvSpPr>
         <p:spPr>
           <a:xfrm>
-            <a:off x="2651760" y="1463040"/>
-            <a:ext cx="3200400" cy="685800"/>
+            <a:off x="548640" y="1417320"/>
+            <a:ext cx="3566160" cy="640080"/>
           </a:xfrm>
           <a:prstGeom prst="roundRect">
             <a:avLst>
-              <a:gd name="adj" fmla="val 10667"/>
+              <a:gd name="adj" fmla="val 11429"/>
             </a:avLst>
           </a:prstGeom>
           <a:solidFill>
@@ -16086,73 +17316,27 @@
               <a:buNone/>
             </a:pPr>
             <a:r>
-              <a:rPr lang="en-US" sz="1200" dirty="0">
+              <a:rPr lang="en-US" sz="1100" dirty="0">
                 <a:solidFill>
                   <a:schemeClr val="tx1"/>
                 </a:solidFill>
               </a:rPr>
               <a:t>Swagger UI  |  channel and partner apps  |  scripts</a:t>
             </a:r>
-            <a:endParaRPr lang="en-US" sz="1200" dirty="0"/>
-          </a:p>
-        </p:txBody>
-      </p:sp>
-      <p:sp>
-        <p:nvSpPr>
-          <p:cNvPr id="6" name="Text 3"/>
-          <p:cNvSpPr txBox="1"/>
-          <p:nvPr/>
-        </p:nvSpPr>
-        <p:spPr>
-          <a:xfrm>
-            <a:off x="6217920" y="1463040"/>
-            <a:ext cx="3200400" cy="685800"/>
-          </a:xfrm>
-          <a:prstGeom prst="roundRect">
-            <a:avLst>
-              <a:gd name="adj" fmla="val 10667"/>
-            </a:avLst>
-          </a:prstGeom>
-          <a:solidFill>
-            <a:schemeClr val="accent1">
-              <a:alpha val="12000"/>
-            </a:schemeClr>
-          </a:solidFill>
-          <a:ln w="12700">
-            <a:solidFill>
-              <a:schemeClr val="accent1"/>
-            </a:solidFill>
-          </a:ln>
-        </p:spPr>
-        <p:txBody>
-          <a:bodyPr wrap="square" lIns="50800" tIns="50800" rIns="50800" bIns="50800" rtlCol="0" anchor="ctr"/>
-          <a:lstStyle/>
-          <a:p>
-            <a:pPr algn="ctr" indent="0" marL="0">
-              <a:buNone/>
-            </a:pPr>
-            <a:r>
-              <a:rPr lang="en-US" sz="1200" dirty="0">
-                <a:solidFill>
-                  <a:schemeClr val="tx1"/>
-                </a:solidFill>
-              </a:rPr>
-              <a:t>Operators  (HTTP Basic, BATCH_ADMIN role)</a:t>
-            </a:r>
-            <a:endParaRPr lang="en-US" sz="1200" dirty="0"/>
-          </a:p>
-        </p:txBody>
-      </p:sp>
-      <p:sp>
-        <p:nvSpPr>
-          <p:cNvPr id="7" name="Shape 4"/>
+            <a:endParaRPr lang="en-US" sz="1100" dirty="0"/>
+          </a:p>
+        </p:txBody>
+      </p:sp>
+      <p:sp>
+        <p:nvSpPr>
+          <p:cNvPr id="6" name="Shape 3"/>
           <p:cNvSpPr/>
           <p:nvPr/>
         </p:nvSpPr>
         <p:spPr>
           <a:xfrm>
-            <a:off x="4251960" y="2148840"/>
-            <a:ext cx="0" cy="548640"/>
+            <a:off x="2331720" y="2057400"/>
+            <a:ext cx="0" cy="457200"/>
           </a:xfrm>
           <a:prstGeom prst="line">
             <a:avLst/>
@@ -16169,13 +17353,13 @@
       </p:sp>
       <p:sp>
         <p:nvSpPr>
-          <p:cNvPr id="8" name="Text 5"/>
-          <p:cNvSpPr txBox="1"/>
-          <p:nvPr/>
-        </p:nvSpPr>
-        <p:spPr>
-          <a:xfrm>
-            <a:off x="4343400" y="2240280"/>
+          <p:cNvPr id="7" name="Text 4"/>
+          <p:cNvSpPr txBox="1"/>
+          <p:nvPr/>
+        </p:nvSpPr>
+        <p:spPr>
+          <a:xfrm>
+            <a:off x="2423160" y="2103120"/>
             <a:ext cx="1097280" cy="228600"/>
           </a:xfrm>
           <a:prstGeom prst="rect">
@@ -16205,78 +17389,18 @@
       </p:sp>
       <p:sp>
         <p:nvSpPr>
-          <p:cNvPr id="9" name="Shape 6"/>
-          <p:cNvSpPr/>
-          <p:nvPr/>
-        </p:nvSpPr>
-        <p:spPr>
-          <a:xfrm>
-            <a:off x="7818120" y="2148840"/>
-            <a:ext cx="0" cy="548640"/>
-          </a:xfrm>
-          <a:prstGeom prst="line">
-            <a:avLst/>
-          </a:prstGeom>
-          <a:noFill/>
-          <a:ln w="22225">
-            <a:solidFill>
-              <a:schemeClr val="tx2"/>
-            </a:solidFill>
-            <a:prstDash val="solid"/>
-            <a:tailEnd type="triangle"/>
-          </a:ln>
-        </p:spPr>
-      </p:sp>
-      <p:sp>
-        <p:nvSpPr>
-          <p:cNvPr id="10" name="Text 7"/>
-          <p:cNvSpPr txBox="1"/>
-          <p:nvPr/>
-        </p:nvSpPr>
-        <p:spPr>
-          <a:xfrm>
-            <a:off x="7909560" y="2240280"/>
-            <a:ext cx="1097280" cy="228600"/>
-          </a:xfrm>
-          <a:prstGeom prst="rect">
-            <a:avLst/>
-          </a:prstGeom>
-          <a:noFill/>
-          <a:ln/>
-        </p:spPr>
-        <p:txBody>
-          <a:bodyPr wrap="square" lIns="0" tIns="0" rIns="0" bIns="0" rtlCol="0" anchor="ctr"/>
-          <a:lstStyle/>
-          <a:p>
-            <a:pPr algn="l" indent="0" marL="0">
-              <a:buNone/>
-            </a:pPr>
-            <a:r>
-              <a:rPr lang="en-US" sz="1000" i="1" dirty="0">
-                <a:solidFill>
-                  <a:schemeClr val="accent4"/>
-                </a:solidFill>
-              </a:rPr>
-              <a:t>REST / JSON</a:t>
-            </a:r>
-            <a:endParaRPr lang="en-US" sz="1000" dirty="0"/>
-          </a:p>
-        </p:txBody>
-      </p:sp>
-      <p:sp>
-        <p:nvSpPr>
-          <p:cNvPr id="11" name="Text 8"/>
-          <p:cNvSpPr txBox="1"/>
-          <p:nvPr/>
-        </p:nvSpPr>
-        <p:spPr>
-          <a:xfrm>
-            <a:off x="2651760" y="2697480"/>
-            <a:ext cx="3200400" cy="2194560"/>
+          <p:cNvPr id="8" name="Text 5"/>
+          <p:cNvSpPr txBox="1"/>
+          <p:nvPr/>
+        </p:nvSpPr>
+        <p:spPr>
+          <a:xfrm>
+            <a:off x="548640" y="2514600"/>
+            <a:ext cx="3566160" cy="2286000"/>
           </a:xfrm>
           <a:prstGeom prst="roundRect">
             <a:avLst>
-              <a:gd name="adj" fmla="val 3333"/>
+              <a:gd name="adj" fmla="val 3200"/>
             </a:avLst>
           </a:prstGeom>
           <a:solidFill>
@@ -16303,14 +17427,14 @@
       </p:sp>
       <p:sp>
         <p:nvSpPr>
-          <p:cNvPr id="12" name="Text 9"/>
-          <p:cNvSpPr txBox="1"/>
-          <p:nvPr/>
-        </p:nvSpPr>
-        <p:spPr>
-          <a:xfrm>
-            <a:off x="2788920" y="2770632"/>
-            <a:ext cx="2926080" cy="457200"/>
+          <p:cNvPr id="9" name="Text 6"/>
+          <p:cNvSpPr txBox="1"/>
+          <p:nvPr/>
+        </p:nvSpPr>
+        <p:spPr>
+          <a:xfrm>
+            <a:off x="685800" y="2587752"/>
+            <a:ext cx="3291840" cy="457200"/>
           </a:xfrm>
           <a:prstGeom prst="rect">
             <a:avLst/>
@@ -16326,7 +17450,7 @@
               <a:buNone/>
             </a:pPr>
             <a:r>
-              <a:rPr lang="en-US" sz="1500" b="1" dirty="0">
+              <a:rPr lang="en-US" sz="1400" b="1" dirty="0">
                 <a:solidFill>
                   <a:schemeClr val="tx2"/>
                 </a:solidFill>
@@ -16340,7 +17464,7 @@
               <a:buNone/>
             </a:pPr>
             <a:r>
-              <a:rPr lang="en-US" sz="1100" dirty="0">
+              <a:rPr lang="en-US" sz="1050" dirty="0">
                 <a:solidFill>
                   <a:schemeClr val="tx2"/>
                 </a:solidFill>
@@ -16353,18 +17477,18 @@
       </p:sp>
       <p:sp>
         <p:nvSpPr>
-          <p:cNvPr id="13" name="Text 10"/>
-          <p:cNvSpPr txBox="1"/>
-          <p:nvPr/>
-        </p:nvSpPr>
-        <p:spPr>
-          <a:xfrm>
-            <a:off x="2743200" y="3337560"/>
-            <a:ext cx="1463040" cy="429768"/>
+          <p:cNvPr id="10" name="Text 7"/>
+          <p:cNvSpPr txBox="1"/>
+          <p:nvPr/>
+        </p:nvSpPr>
+        <p:spPr>
+          <a:xfrm>
+            <a:off x="640080" y="3200400"/>
+            <a:ext cx="1645920" cy="457200"/>
           </a:xfrm>
           <a:prstGeom prst="roundRect">
             <a:avLst>
-              <a:gd name="adj" fmla="val 17021"/>
+              <a:gd name="adj" fmla="val 16000"/>
             </a:avLst>
           </a:prstGeom>
           <a:solidFill>
@@ -16384,31 +17508,31 @@
               <a:buNone/>
             </a:pPr>
             <a:r>
-              <a:rPr lang="en-US" sz="1100" dirty="0">
+              <a:rPr lang="en-US" sz="1050" dirty="0">
                 <a:solidFill>
                   <a:schemeClr val="bg1"/>
                 </a:solidFill>
               </a:rPr>
               <a:t>Accounts and bulk</a:t>
             </a:r>
-            <a:endParaRPr lang="en-US" sz="1100" dirty="0"/>
-          </a:p>
-        </p:txBody>
-      </p:sp>
-      <p:sp>
-        <p:nvSpPr>
-          <p:cNvPr id="14" name="Text 11"/>
-          <p:cNvSpPr txBox="1"/>
-          <p:nvPr/>
-        </p:nvSpPr>
-        <p:spPr>
-          <a:xfrm>
-            <a:off x="4297680" y="3337560"/>
-            <a:ext cx="1463040" cy="429768"/>
+            <a:endParaRPr lang="en-US" sz="1050" dirty="0"/>
+          </a:p>
+        </p:txBody>
+      </p:sp>
+      <p:sp>
+        <p:nvSpPr>
+          <p:cNvPr id="11" name="Text 8"/>
+          <p:cNvSpPr txBox="1"/>
+          <p:nvPr/>
+        </p:nvSpPr>
+        <p:spPr>
+          <a:xfrm>
+            <a:off x="2377440" y="3200400"/>
+            <a:ext cx="1645920" cy="457200"/>
           </a:xfrm>
           <a:prstGeom prst="roundRect">
             <a:avLst>
-              <a:gd name="adj" fmla="val 17021"/>
+              <a:gd name="adj" fmla="val 16000"/>
             </a:avLst>
           </a:prstGeom>
           <a:solidFill>
@@ -16428,31 +17552,31 @@
               <a:buNone/>
             </a:pPr>
             <a:r>
-              <a:rPr lang="en-US" sz="1100" dirty="0">
+              <a:rPr lang="en-US" sz="1050" dirty="0">
                 <a:solidFill>
                   <a:schemeClr val="bg1"/>
                 </a:solidFill>
               </a:rPr>
               <a:t>Schedule and accrual</a:t>
             </a:r>
-            <a:endParaRPr lang="en-US" sz="1100" dirty="0"/>
-          </a:p>
-        </p:txBody>
-      </p:sp>
-      <p:sp>
-        <p:nvSpPr>
-          <p:cNvPr id="15" name="Text 12"/>
-          <p:cNvSpPr txBox="1"/>
-          <p:nvPr/>
-        </p:nvSpPr>
-        <p:spPr>
-          <a:xfrm>
-            <a:off x="2743200" y="3840480"/>
-            <a:ext cx="1463040" cy="429768"/>
+            <a:endParaRPr lang="en-US" sz="1050" dirty="0"/>
+          </a:p>
+        </p:txBody>
+      </p:sp>
+      <p:sp>
+        <p:nvSpPr>
+          <p:cNvPr id="12" name="Text 9"/>
+          <p:cNvSpPr txBox="1"/>
+          <p:nvPr/>
+        </p:nvSpPr>
+        <p:spPr>
+          <a:xfrm>
+            <a:off x="640080" y="3730752"/>
+            <a:ext cx="1645920" cy="457200"/>
           </a:xfrm>
           <a:prstGeom prst="roundRect">
             <a:avLst>
-              <a:gd name="adj" fmla="val 17021"/>
+              <a:gd name="adj" fmla="val 16000"/>
             </a:avLst>
           </a:prstGeom>
           <a:solidFill>
@@ -16472,31 +17596,31 @@
               <a:buNone/>
             </a:pPr>
             <a:r>
-              <a:rPr lang="en-US" sz="1100" dirty="0">
+              <a:rPr lang="en-US" sz="1050" dirty="0">
                 <a:solidFill>
                   <a:schemeClr val="bg1"/>
                 </a:solidFill>
               </a:rPr>
               <a:t>Payments</a:t>
             </a:r>
-            <a:endParaRPr lang="en-US" sz="1100" dirty="0"/>
-          </a:p>
-        </p:txBody>
-      </p:sp>
-      <p:sp>
-        <p:nvSpPr>
-          <p:cNvPr id="16" name="Text 13"/>
-          <p:cNvSpPr txBox="1"/>
-          <p:nvPr/>
-        </p:nvSpPr>
-        <p:spPr>
-          <a:xfrm>
-            <a:off x="4297680" y="3840480"/>
-            <a:ext cx="1463040" cy="429768"/>
+            <a:endParaRPr lang="en-US" sz="1050" dirty="0"/>
+          </a:p>
+        </p:txBody>
+      </p:sp>
+      <p:sp>
+        <p:nvSpPr>
+          <p:cNvPr id="13" name="Text 10"/>
+          <p:cNvSpPr txBox="1"/>
+          <p:nvPr/>
+        </p:nvSpPr>
+        <p:spPr>
+          <a:xfrm>
+            <a:off x="2377440" y="3730752"/>
+            <a:ext cx="1645920" cy="457200"/>
           </a:xfrm>
           <a:prstGeom prst="roundRect">
             <a:avLst>
-              <a:gd name="adj" fmla="val 17021"/>
+              <a:gd name="adj" fmla="val 16000"/>
             </a:avLst>
           </a:prstGeom>
           <a:solidFill>
@@ -16516,31 +17640,31 @@
               <a:buNone/>
             </a:pPr>
             <a:r>
-              <a:rPr lang="en-US" sz="1100" dirty="0">
+              <a:rPr lang="en-US" sz="1050" dirty="0">
                 <a:solidFill>
                   <a:schemeClr val="bg1"/>
                 </a:solidFill>
               </a:rPr>
               <a:t>Mortgage</a:t>
             </a:r>
-            <a:endParaRPr lang="en-US" sz="1100" dirty="0"/>
-          </a:p>
-        </p:txBody>
-      </p:sp>
-      <p:sp>
-        <p:nvSpPr>
-          <p:cNvPr id="17" name="Text 14"/>
-          <p:cNvSpPr txBox="1"/>
-          <p:nvPr/>
-        </p:nvSpPr>
-        <p:spPr>
-          <a:xfrm>
-            <a:off x="2743200" y="4343400"/>
-            <a:ext cx="1463040" cy="429768"/>
+            <a:endParaRPr lang="en-US" sz="1050" dirty="0"/>
+          </a:p>
+        </p:txBody>
+      </p:sp>
+      <p:sp>
+        <p:nvSpPr>
+          <p:cNvPr id="14" name="Text 11"/>
+          <p:cNvSpPr txBox="1"/>
+          <p:nvPr/>
+        </p:nvSpPr>
+        <p:spPr>
+          <a:xfrm>
+            <a:off x="640080" y="4261104"/>
+            <a:ext cx="1645920" cy="457200"/>
           </a:xfrm>
           <a:prstGeom prst="roundRect">
             <a:avLst>
-              <a:gd name="adj" fmla="val 17021"/>
+              <a:gd name="adj" fmla="val 16000"/>
             </a:avLst>
           </a:prstGeom>
           <a:solidFill>
@@ -16560,31 +17684,31 @@
               <a:buNone/>
             </a:pPr>
             <a:r>
-              <a:rPr lang="en-US" sz="1100" dirty="0">
+              <a:rPr lang="en-US" sz="1050" dirty="0">
                 <a:solidFill>
                   <a:schemeClr val="bg1"/>
                 </a:solidFill>
               </a:rPr>
               <a:t>PDF statements</a:t>
             </a:r>
-            <a:endParaRPr lang="en-US" sz="1100" dirty="0"/>
-          </a:p>
-        </p:txBody>
-      </p:sp>
-      <p:sp>
-        <p:nvSpPr>
-          <p:cNvPr id="18" name="Text 15"/>
-          <p:cNvSpPr txBox="1"/>
-          <p:nvPr/>
-        </p:nvSpPr>
-        <p:spPr>
-          <a:xfrm>
-            <a:off x="4297680" y="4343400"/>
-            <a:ext cx="1463040" cy="429768"/>
+            <a:endParaRPr lang="en-US" sz="1050" dirty="0"/>
+          </a:p>
+        </p:txBody>
+      </p:sp>
+      <p:sp>
+        <p:nvSpPr>
+          <p:cNvPr id="15" name="Text 12"/>
+          <p:cNvSpPr txBox="1"/>
+          <p:nvPr/>
+        </p:nvSpPr>
+        <p:spPr>
+          <a:xfrm>
+            <a:off x="2377440" y="4261104"/>
+            <a:ext cx="1645920" cy="457200"/>
           </a:xfrm>
           <a:prstGeom prst="roundRect">
             <a:avLst>
-              <a:gd name="adj" fmla="val 17021"/>
+              <a:gd name="adj" fmla="val 16000"/>
             </a:avLst>
           </a:prstGeom>
           <a:solidFill>
@@ -16604,31 +17728,137 @@
               <a:buNone/>
             </a:pPr>
             <a:r>
-              <a:rPr lang="en-US" sz="1100" dirty="0">
+              <a:rPr lang="en-US" sz="1050" dirty="0">
                 <a:solidFill>
                   <a:schemeClr val="bg1"/>
                 </a:solidFill>
               </a:rPr>
               <a:t>Ledger outbox</a:t>
             </a:r>
-            <a:endParaRPr lang="en-US" sz="1100" dirty="0"/>
-          </a:p>
-        </p:txBody>
-      </p:sp>
-      <p:sp>
-        <p:nvSpPr>
-          <p:cNvPr id="19" name="Text 16"/>
-          <p:cNvSpPr txBox="1"/>
-          <p:nvPr/>
-        </p:nvSpPr>
-        <p:spPr>
-          <a:xfrm>
-            <a:off x="6217920" y="2697480"/>
-            <a:ext cx="3200400" cy="2194560"/>
+            <a:endParaRPr lang="en-US" sz="1050" dirty="0"/>
+          </a:p>
+        </p:txBody>
+      </p:sp>
+      <p:sp>
+        <p:nvSpPr>
+          <p:cNvPr id="16" name="Text 13"/>
+          <p:cNvSpPr txBox="1"/>
+          <p:nvPr/>
+        </p:nvSpPr>
+        <p:spPr>
+          <a:xfrm>
+            <a:off x="4297680" y="1417320"/>
+            <a:ext cx="3566160" cy="640080"/>
           </a:xfrm>
           <a:prstGeom prst="roundRect">
             <a:avLst>
-              <a:gd name="adj" fmla="val 3333"/>
+              <a:gd name="adj" fmla="val 11429"/>
+            </a:avLst>
+          </a:prstGeom>
+          <a:solidFill>
+            <a:schemeClr val="accent4">
+              <a:alpha val="12000"/>
+            </a:schemeClr>
+          </a:solidFill>
+          <a:ln w="12700">
+            <a:solidFill>
+              <a:schemeClr val="accent1"/>
+            </a:solidFill>
+          </a:ln>
+        </p:spPr>
+        <p:txBody>
+          <a:bodyPr wrap="square" lIns="50800" tIns="50800" rIns="50800" bIns="50800" rtlCol="0" anchor="ctr"/>
+          <a:lstStyle/>
+          <a:p>
+            <a:pPr algn="ctr" indent="0" marL="0">
+              <a:buNone/>
+            </a:pPr>
+            <a:r>
+              <a:rPr lang="en-US" sz="1100" dirty="0">
+                <a:solidFill>
+                  <a:schemeClr val="tx1"/>
+                </a:solidFill>
+              </a:rPr>
+              <a:t>Operators  (HTTP Basic, BATCH_ADMIN)</a:t>
+            </a:r>
+            <a:endParaRPr lang="en-US" sz="1100" dirty="0"/>
+          </a:p>
+        </p:txBody>
+      </p:sp>
+      <p:sp>
+        <p:nvSpPr>
+          <p:cNvPr id="17" name="Shape 14"/>
+          <p:cNvSpPr/>
+          <p:nvPr/>
+        </p:nvSpPr>
+        <p:spPr>
+          <a:xfrm>
+            <a:off x="6080760" y="2057400"/>
+            <a:ext cx="0" cy="457200"/>
+          </a:xfrm>
+          <a:prstGeom prst="line">
+            <a:avLst/>
+          </a:prstGeom>
+          <a:noFill/>
+          <a:ln w="22225">
+            <a:solidFill>
+              <a:schemeClr val="tx2"/>
+            </a:solidFill>
+            <a:prstDash val="solid"/>
+            <a:tailEnd type="triangle"/>
+          </a:ln>
+        </p:spPr>
+      </p:sp>
+      <p:sp>
+        <p:nvSpPr>
+          <p:cNvPr id="18" name="Text 15"/>
+          <p:cNvSpPr txBox="1"/>
+          <p:nvPr/>
+        </p:nvSpPr>
+        <p:spPr>
+          <a:xfrm>
+            <a:off x="6172200" y="2103120"/>
+            <a:ext cx="1097280" cy="228600"/>
+          </a:xfrm>
+          <a:prstGeom prst="rect">
+            <a:avLst/>
+          </a:prstGeom>
+          <a:noFill/>
+          <a:ln/>
+        </p:spPr>
+        <p:txBody>
+          <a:bodyPr wrap="square" lIns="0" tIns="0" rIns="0" bIns="0" rtlCol="0" anchor="ctr"/>
+          <a:lstStyle/>
+          <a:p>
+            <a:pPr algn="l" indent="0" marL="0">
+              <a:buNone/>
+            </a:pPr>
+            <a:r>
+              <a:rPr lang="en-US" sz="1000" i="1" dirty="0">
+                <a:solidFill>
+                  <a:schemeClr val="accent4"/>
+                </a:solidFill>
+              </a:rPr>
+              <a:t>REST / JSON</a:t>
+            </a:r>
+            <a:endParaRPr lang="en-US" sz="1000" dirty="0"/>
+          </a:p>
+        </p:txBody>
+      </p:sp>
+      <p:sp>
+        <p:nvSpPr>
+          <p:cNvPr id="19" name="Text 16"/>
+          <p:cNvSpPr txBox="1"/>
+          <p:nvPr/>
+        </p:nvSpPr>
+        <p:spPr>
+          <a:xfrm>
+            <a:off x="4297680" y="2514600"/>
+            <a:ext cx="3566160" cy="2286000"/>
+          </a:xfrm>
+          <a:prstGeom prst="roundRect">
+            <a:avLst>
+              <a:gd name="adj" fmla="val 3200"/>
             </a:avLst>
           </a:prstGeom>
           <a:solidFill>
@@ -16661,8 +17891,8 @@
         </p:nvSpPr>
         <p:spPr>
           <a:xfrm>
-            <a:off x="6355080" y="2770632"/>
-            <a:ext cx="2926080" cy="457200"/>
+            <a:off x="4434840" y="2587752"/>
+            <a:ext cx="3291840" cy="457200"/>
           </a:xfrm>
           <a:prstGeom prst="rect">
             <a:avLst/>
@@ -16678,7 +17908,7 @@
               <a:buNone/>
             </a:pPr>
             <a:r>
-              <a:rPr lang="en-US" sz="1500" b="1" dirty="0">
+              <a:rPr lang="en-US" sz="1400" b="1" dirty="0">
                 <a:solidFill>
                   <a:schemeClr val="tx2"/>
                 </a:solidFill>
@@ -16692,12 +17922,12 @@
               <a:buNone/>
             </a:pPr>
             <a:r>
-              <a:rPr lang="en-US" sz="1100" dirty="0">
+              <a:rPr lang="en-US" sz="1050" dirty="0">
                 <a:solidFill>
                   <a:schemeClr val="tx2"/>
                 </a:solidFill>
               </a:rPr>
-              <a:t>Java 17  |  Spring Batch 5  |  Quartz</a:t>
+              <a:t>Java 17  |  Spring Batch 5  |  Quartz  |  :8081</a:t>
             </a:r>
             <a:endParaRPr lang="en-US" sz="1400" dirty="0"/>
           </a:p>
@@ -16711,12 +17941,12 @@
         </p:nvSpPr>
         <p:spPr>
           <a:xfrm>
-            <a:off x="6309360" y="3337560"/>
-            <a:ext cx="1463040" cy="429768"/>
+            <a:off x="4389120" y="3200400"/>
+            <a:ext cx="1645920" cy="457200"/>
           </a:xfrm>
           <a:prstGeom prst="roundRect">
             <a:avLst>
-              <a:gd name="adj" fmla="val 17021"/>
+              <a:gd name="adj" fmla="val 16000"/>
             </a:avLst>
           </a:prstGeom>
           <a:solidFill>
@@ -16736,14 +17966,14 @@
               <a:buNone/>
             </a:pPr>
             <a:r>
-              <a:rPr lang="en-US" sz="1100" dirty="0">
+              <a:rPr lang="en-US" sz="1050" dirty="0">
                 <a:solidFill>
                   <a:schemeClr val="bg1"/>
                 </a:solidFill>
               </a:rPr>
               <a:t>Quartz scheduler (clustered)</a:t>
             </a:r>
-            <a:endParaRPr lang="en-US" sz="1100" dirty="0"/>
+            <a:endParaRPr lang="en-US" sz="1050" dirty="0"/>
           </a:p>
         </p:txBody>
       </p:sp>
@@ -16755,12 +17985,12 @@
         </p:nvSpPr>
         <p:spPr>
           <a:xfrm>
-            <a:off x="7863840" y="3337560"/>
-            <a:ext cx="1463040" cy="429768"/>
+            <a:off x="6126480" y="3200400"/>
+            <a:ext cx="1645920" cy="457200"/>
           </a:xfrm>
           <a:prstGeom prst="roundRect">
             <a:avLst>
-              <a:gd name="adj" fmla="val 17021"/>
+              <a:gd name="adj" fmla="val 16000"/>
             </a:avLst>
           </a:prstGeom>
           <a:solidFill>
@@ -16780,14 +18010,14 @@
               <a:buNone/>
             </a:pPr>
             <a:r>
-              <a:rPr lang="en-US" sz="1100" dirty="0">
+              <a:rPr lang="en-US" sz="1050" dirty="0">
                 <a:solidFill>
                   <a:schemeClr val="bg1"/>
                 </a:solidFill>
               </a:rPr>
               <a:t>36 job slots</a:t>
             </a:r>
-            <a:endParaRPr lang="en-US" sz="1100" dirty="0"/>
+            <a:endParaRPr lang="en-US" sz="1050" dirty="0"/>
           </a:p>
         </p:txBody>
       </p:sp>
@@ -16799,12 +18029,12 @@
         </p:nvSpPr>
         <p:spPr>
           <a:xfrm>
-            <a:off x="6309360" y="3840480"/>
-            <a:ext cx="1463040" cy="429768"/>
+            <a:off x="4389120" y="3730752"/>
+            <a:ext cx="1645920" cy="457200"/>
           </a:xfrm>
           <a:prstGeom prst="roundRect">
             <a:avLst>
-              <a:gd name="adj" fmla="val 17021"/>
+              <a:gd name="adj" fmla="val 16000"/>
             </a:avLst>
           </a:prstGeom>
           <a:solidFill>
@@ -16824,14 +18054,14 @@
               <a:buNone/>
             </a:pPr>
             <a:r>
-              <a:rPr lang="en-US" sz="1100" dirty="0">
+              <a:rPr lang="en-US" sz="1050" dirty="0">
                 <a:solidFill>
                   <a:schemeClr val="bg1"/>
                 </a:solidFill>
               </a:rPr>
               <a:t>Admin REST API</a:t>
             </a:r>
-            <a:endParaRPr lang="en-US" sz="1100" dirty="0"/>
+            <a:endParaRPr lang="en-US" sz="1050" dirty="0"/>
           </a:p>
         </p:txBody>
       </p:sp>
@@ -16843,12 +18073,12 @@
         </p:nvSpPr>
         <p:spPr>
           <a:xfrm>
-            <a:off x="7863840" y="3840480"/>
-            <a:ext cx="1463040" cy="429768"/>
+            <a:off x="6126480" y="3730752"/>
+            <a:ext cx="1645920" cy="457200"/>
           </a:xfrm>
           <a:prstGeom prst="roundRect">
             <a:avLst>
-              <a:gd name="adj" fmla="val 17021"/>
+              <a:gd name="adj" fmla="val 16000"/>
             </a:avLst>
           </a:prstGeom>
           <a:solidFill>
@@ -16868,14 +18098,14 @@
               <a:buNone/>
             </a:pPr>
             <a:r>
-              <a:rPr lang="en-US" sz="1100" dirty="0">
+              <a:rPr lang="en-US" sz="1050" dirty="0">
                 <a:solidFill>
                   <a:schemeClr val="bg1"/>
                 </a:solidFill>
               </a:rPr>
               <a:t>Dead-letter and audit</a:t>
             </a:r>
-            <a:endParaRPr lang="en-US" sz="1100" dirty="0"/>
+            <a:endParaRPr lang="en-US" sz="1050" dirty="0"/>
           </a:p>
         </p:txBody>
       </p:sp>
@@ -16887,12 +18117,12 @@
         </p:nvSpPr>
         <p:spPr>
           <a:xfrm>
-            <a:off x="6309360" y="4343400"/>
-            <a:ext cx="1463040" cy="429768"/>
+            <a:off x="4389120" y="4261104"/>
+            <a:ext cx="1645920" cy="457200"/>
           </a:xfrm>
           <a:prstGeom prst="roundRect">
             <a:avLst>
-              <a:gd name="adj" fmla="val 17021"/>
+              <a:gd name="adj" fmla="val 16000"/>
             </a:avLst>
           </a:prstGeom>
           <a:solidFill>
@@ -16912,14 +18142,14 @@
               <a:buNone/>
             </a:pPr>
             <a:r>
-              <a:rPr lang="en-US" sz="1100" dirty="0">
+              <a:rPr lang="en-US" sz="1050" dirty="0">
                 <a:solidFill>
                   <a:schemeClr val="bg1"/>
                 </a:solidFill>
               </a:rPr>
               <a:t>Hot-reload job config</a:t>
             </a:r>
-            <a:endParaRPr lang="en-US" sz="1100" dirty="0"/>
+            <a:endParaRPr lang="en-US" sz="1050" dirty="0"/>
           </a:p>
         </p:txBody>
       </p:sp>
@@ -16931,12 +18161,12 @@
         </p:nvSpPr>
         <p:spPr>
           <a:xfrm>
-            <a:off x="7863840" y="4343400"/>
-            <a:ext cx="1463040" cy="429768"/>
+            <a:off x="6126480" y="4261104"/>
+            <a:ext cx="1645920" cy="457200"/>
           </a:xfrm>
           <a:prstGeom prst="roundRect">
             <a:avLst>
-              <a:gd name="adj" fmla="val 17021"/>
+              <a:gd name="adj" fmla="val 16000"/>
             </a:avLst>
           </a:prstGeom>
           <a:solidFill>
@@ -16956,14 +18186,14 @@
               <a:buNone/>
             </a:pPr>
             <a:r>
-              <a:rPr lang="en-US" sz="1100" dirty="0">
+              <a:rPr lang="en-US" sz="1050" dirty="0">
                 <a:solidFill>
                   <a:schemeClr val="bg1"/>
                 </a:solidFill>
               </a:rPr>
               <a:t>Kafka event producer</a:t>
             </a:r>
-            <a:endParaRPr lang="en-US" sz="1100" dirty="0"/>
+            <a:endParaRPr lang="en-US" sz="1050" dirty="0"/>
           </a:p>
         </p:txBody>
       </p:sp>
@@ -16975,22 +18205,23 @@
         </p:nvSpPr>
         <p:spPr>
           <a:xfrm>
-            <a:off x="548640" y="3108960"/>
-            <a:ext cx="1463040" cy="1371600"/>
+            <a:off x="8046720" y="1417320"/>
+            <a:ext cx="3566160" cy="640080"/>
           </a:xfrm>
           <a:prstGeom prst="roundRect">
             <a:avLst>
-              <a:gd name="adj" fmla="val 5333"/>
+              <a:gd name="adj" fmla="val 11429"/>
             </a:avLst>
           </a:prstGeom>
           <a:solidFill>
-            <a:schemeClr val="bg2"/>
+            <a:schemeClr val="accent2">
+              <a:alpha val="12000"/>
+            </a:schemeClr>
           </a:solidFill>
           <a:ln w="12700">
             <a:solidFill>
-              <a:schemeClr val="accent4"/>
+              <a:schemeClr val="accent1"/>
             </a:solidFill>
-            <a:prstDash val="dash"/>
           </a:ln>
         </p:spPr>
         <p:txBody>
@@ -17001,14 +18232,14 @@
               <a:buNone/>
             </a:pPr>
             <a:r>
-              <a:rPr lang="en-US" sz="1200" dirty="0">
+              <a:rPr lang="en-US" sz="1100" dirty="0">
                 <a:solidFill>
                   <a:schemeClr val="tx1"/>
                 </a:solidFill>
               </a:rPr>
-              <a:t>Core banking ledger (external)</a:t>
-            </a:r>
-            <a:endParaRPr lang="en-US" sz="1200" dirty="0"/>
+              <a:t>Operations staff  (browser, HTTP Basic)</a:t>
+            </a:r>
+            <a:endParaRPr lang="en-US" sz="1100" dirty="0"/>
           </a:p>
         </p:txBody>
       </p:sp>
@@ -17019,9 +18250,9 @@
           <p:nvPr/>
         </p:nvSpPr>
         <p:spPr>
-          <a:xfrm flipH="1">
-            <a:off x="2011680" y="3794760"/>
-            <a:ext cx="640080" cy="0"/>
+          <a:xfrm>
+            <a:off x="9829800" y="2057400"/>
+            <a:ext cx="0" cy="457200"/>
           </a:xfrm>
           <a:prstGeom prst="line">
             <a:avLst/>
@@ -17031,7 +18262,7 @@
             <a:solidFill>
               <a:schemeClr val="tx2"/>
             </a:solidFill>
-            <a:prstDash val="dash"/>
+            <a:prstDash val="solid"/>
             <a:tailEnd type="triangle"/>
           </a:ln>
         </p:spPr>
@@ -17044,8 +18275,8 @@
         </p:nvSpPr>
         <p:spPr>
           <a:xfrm>
-            <a:off x="2011680" y="3520440"/>
-            <a:ext cx="640080" cy="228600"/>
+            <a:off x="9921240" y="2103120"/>
+            <a:ext cx="1097280" cy="228600"/>
           </a:xfrm>
           <a:prstGeom prst="rect">
             <a:avLst/>
@@ -17057,18 +18288,18 @@
           <a:bodyPr wrap="square" lIns="0" tIns="0" rIns="0" bIns="0" rtlCol="0" anchor="ctr"/>
           <a:lstStyle/>
           <a:p>
-            <a:pPr algn="ctr" indent="0" marL="0">
-              <a:buNone/>
-            </a:pPr>
-            <a:r>
-              <a:rPr lang="en-US" sz="900" i="1" dirty="0">
+            <a:pPr algn="l" indent="0" marL="0">
+              <a:buNone/>
+            </a:pPr>
+            <a:r>
+              <a:rPr lang="en-US" sz="1000" i="1" dirty="0">
                 <a:solidFill>
                   <a:schemeClr val="accent4"/>
                 </a:solidFill>
               </a:rPr>
-              <a:t>outbox push</a:t>
-            </a:r>
-            <a:endParaRPr lang="en-US" sz="900" dirty="0"/>
+              <a:t>REST / JSON</a:t>
+            </a:r>
+            <a:endParaRPr lang="en-US" sz="1000" dirty="0"/>
           </a:p>
         </p:txBody>
       </p:sp>
@@ -17080,53 +18311,360 @@
         </p:nvSpPr>
         <p:spPr>
           <a:xfrm>
-            <a:off x="9966960" y="3108960"/>
-            <a:ext cx="1673352" cy="1371600"/>
+            <a:off x="8046720" y="2514600"/>
+            <a:ext cx="3566160" cy="2286000"/>
           </a:xfrm>
           <a:prstGeom prst="roundRect">
             <a:avLst>
-              <a:gd name="adj" fmla="val 5333"/>
+              <a:gd name="adj" fmla="val 3200"/>
             </a:avLst>
           </a:prstGeom>
           <a:solidFill>
-            <a:schemeClr val="bg2"/>
+            <a:schemeClr val="accent2">
+              <a:alpha val="12000"/>
+            </a:schemeClr>
+          </a:solidFill>
+          <a:ln w="19050">
+            <a:solidFill>
+              <a:schemeClr val="accent2"/>
+            </a:solidFill>
+          </a:ln>
+        </p:spPr>
+        <p:txBody>
+          <a:bodyPr wrap="square" lIns="50800" tIns="50800" rIns="50800" bIns="50800" rtlCol="0" anchor="ctr"/>
+          <a:lstStyle/>
+          <a:p>
+            <a:pPr algn="ctr" indent="0" marL="0">
+              <a:buNone/>
+            </a:pPr>
+            <a:endParaRPr lang="en-US" sz="1200" dirty="0"/>
+          </a:p>
+        </p:txBody>
+      </p:sp>
+      <p:sp>
+        <p:nvSpPr>
+          <p:cNvPr id="31" name="Text 28"/>
+          <p:cNvSpPr txBox="1"/>
+          <p:nvPr/>
+        </p:nvSpPr>
+        <p:spPr>
+          <a:xfrm>
+            <a:off x="8183880" y="2587752"/>
+            <a:ext cx="3291840" cy="457200"/>
+          </a:xfrm>
+          <a:prstGeom prst="rect">
+            <a:avLst/>
+          </a:prstGeom>
+          <a:noFill/>
+          <a:ln/>
+        </p:spPr>
+        <p:txBody>
+          <a:bodyPr wrap="square" lIns="0" tIns="0" rIns="0" bIns="0" rtlCol="0" anchor="t"/>
+          <a:lstStyle/>
+          <a:p>
+            <a:pPr indent="0" marL="0">
+              <a:buNone/>
+            </a:pPr>
+            <a:r>
+              <a:rPr lang="en-US" sz="1400" b="1" dirty="0">
+                <a:solidFill>
+                  <a:schemeClr val="tx2"/>
+                </a:solidFill>
+              </a:rPr>
+              <a:t>lending-admin-service</a:t>
+            </a:r>
+            <a:endParaRPr lang="en-US" sz="1400" dirty="0"/>
+          </a:p>
+          <a:p>
+            <a:pPr indent="0" marL="0">
+              <a:buNone/>
+            </a:pPr>
+            <a:r>
+              <a:rPr lang="en-US" sz="1050" dirty="0">
+                <a:solidFill>
+                  <a:schemeClr val="tx2"/>
+                </a:solidFill>
+              </a:rPr>
+              <a:t>Java 17  |  Spring Boot + React  |  :8082</a:t>
+            </a:r>
+            <a:endParaRPr lang="en-US" sz="1400" dirty="0"/>
+          </a:p>
+        </p:txBody>
+      </p:sp>
+      <p:sp>
+        <p:nvSpPr>
+          <p:cNvPr id="32" name="Text 29"/>
+          <p:cNvSpPr txBox="1"/>
+          <p:nvPr/>
+        </p:nvSpPr>
+        <p:spPr>
+          <a:xfrm>
+            <a:off x="8138160" y="3200400"/>
+            <a:ext cx="1645920" cy="457200"/>
+          </a:xfrm>
+          <a:prstGeom prst="roundRect">
+            <a:avLst>
+              <a:gd name="adj" fmla="val 16000"/>
+            </a:avLst>
+          </a:prstGeom>
+          <a:solidFill>
+            <a:schemeClr val="accent2"/>
           </a:solidFill>
           <a:ln w="12700">
             <a:solidFill>
-              <a:schemeClr val="accent4"/>
+              <a:schemeClr val="accent2"/>
             </a:solidFill>
-            <a:prstDash val="dash"/>
           </a:ln>
         </p:spPr>
         <p:txBody>
-          <a:bodyPr wrap="square" lIns="50800" tIns="50800" rIns="50800" bIns="50800" rtlCol="0" anchor="ctr"/>
+          <a:bodyPr wrap="square" lIns="25400" tIns="25400" rIns="25400" bIns="25400" rtlCol="0" anchor="ctr"/>
           <a:lstStyle/>
           <a:p>
             <a:pPr algn="ctr" indent="0" marL="0">
               <a:buNone/>
             </a:pPr>
             <a:r>
-              <a:rPr lang="en-US" sz="1200" dirty="0">
+              <a:rPr lang="en-US" sz="1050" dirty="0">
                 <a:solidFill>
                   <a:schemeClr val="tx1"/>
                 </a:solidFill>
               </a:rPr>
-              <a:t>Kafka (external, optional)</a:t>
-            </a:r>
-            <a:endParaRPr lang="en-US" sz="1200" dirty="0"/>
-          </a:p>
-        </p:txBody>
-      </p:sp>
-      <p:sp>
-        <p:nvSpPr>
-          <p:cNvPr id="31" name="Shape 28"/>
+              <a:t>Account inquiry</a:t>
+            </a:r>
+            <a:endParaRPr lang="en-US" sz="1050" dirty="0"/>
+          </a:p>
+        </p:txBody>
+      </p:sp>
+      <p:sp>
+        <p:nvSpPr>
+          <p:cNvPr id="33" name="Text 30"/>
+          <p:cNvSpPr txBox="1"/>
+          <p:nvPr/>
+        </p:nvSpPr>
+        <p:spPr>
+          <a:xfrm>
+            <a:off x="9875520" y="3200400"/>
+            <a:ext cx="1645920" cy="457200"/>
+          </a:xfrm>
+          <a:prstGeom prst="roundRect">
+            <a:avLst>
+              <a:gd name="adj" fmla="val 16000"/>
+            </a:avLst>
+          </a:prstGeom>
+          <a:solidFill>
+            <a:schemeClr val="accent2"/>
+          </a:solidFill>
+          <a:ln w="12700">
+            <a:solidFill>
+              <a:schemeClr val="accent2"/>
+            </a:solidFill>
+          </a:ln>
+        </p:spPr>
+        <p:txBody>
+          <a:bodyPr wrap="square" lIns="25400" tIns="25400" rIns="25400" bIns="25400" rtlCol="0" anchor="ctr"/>
+          <a:lstStyle/>
+          <a:p>
+            <a:pPr algn="ctr" indent="0" marL="0">
+              <a:buNone/>
+            </a:pPr>
+            <a:r>
+              <a:rPr lang="en-US" sz="1050" dirty="0">
+                <a:solidFill>
+                  <a:schemeClr val="tx1"/>
+                </a:solidFill>
+              </a:rPr>
+              <a:t>Amortisation and accruals</a:t>
+            </a:r>
+            <a:endParaRPr lang="en-US" sz="1050" dirty="0"/>
+          </a:p>
+        </p:txBody>
+      </p:sp>
+      <p:sp>
+        <p:nvSpPr>
+          <p:cNvPr id="34" name="Text 31"/>
+          <p:cNvSpPr txBox="1"/>
+          <p:nvPr/>
+        </p:nvSpPr>
+        <p:spPr>
+          <a:xfrm>
+            <a:off x="8138160" y="3730752"/>
+            <a:ext cx="1645920" cy="457200"/>
+          </a:xfrm>
+          <a:prstGeom prst="roundRect">
+            <a:avLst>
+              <a:gd name="adj" fmla="val 16000"/>
+            </a:avLst>
+          </a:prstGeom>
+          <a:solidFill>
+            <a:schemeClr val="accent2"/>
+          </a:solidFill>
+          <a:ln w="12700">
+            <a:solidFill>
+              <a:schemeClr val="accent2"/>
+            </a:solidFill>
+          </a:ln>
+        </p:spPr>
+        <p:txBody>
+          <a:bodyPr wrap="square" lIns="25400" tIns="25400" rIns="25400" bIns="25400" rtlCol="0" anchor="ctr"/>
+          <a:lstStyle/>
+          <a:p>
+            <a:pPr algn="ctr" indent="0" marL="0">
+              <a:buNone/>
+            </a:pPr>
+            <a:r>
+              <a:rPr lang="en-US" sz="1050" dirty="0">
+                <a:solidFill>
+                  <a:schemeClr val="tx1"/>
+                </a:solidFill>
+              </a:rPr>
+              <a:t>Upcoming and overdue</a:t>
+            </a:r>
+            <a:endParaRPr lang="en-US" sz="1050" dirty="0"/>
+          </a:p>
+        </p:txBody>
+      </p:sp>
+      <p:sp>
+        <p:nvSpPr>
+          <p:cNvPr id="35" name="Text 32"/>
+          <p:cNvSpPr txBox="1"/>
+          <p:nvPr/>
+        </p:nvSpPr>
+        <p:spPr>
+          <a:xfrm>
+            <a:off x="9875520" y="3730752"/>
+            <a:ext cx="1645920" cy="457200"/>
+          </a:xfrm>
+          <a:prstGeom prst="roundRect">
+            <a:avLst>
+              <a:gd name="adj" fmla="val 16000"/>
+            </a:avLst>
+          </a:prstGeom>
+          <a:solidFill>
+            <a:schemeClr val="accent2"/>
+          </a:solidFill>
+          <a:ln w="12700">
+            <a:solidFill>
+              <a:schemeClr val="accent2"/>
+            </a:solidFill>
+          </a:ln>
+        </p:spPr>
+        <p:txBody>
+          <a:bodyPr wrap="square" lIns="25400" tIns="25400" rIns="25400" bIns="25400" rtlCol="0" anchor="ctr"/>
+          <a:lstStyle/>
+          <a:p>
+            <a:pPr algn="ctr" indent="0" marL="0">
+              <a:buNone/>
+            </a:pPr>
+            <a:r>
+              <a:rPr lang="en-US" sz="1050" dirty="0">
+                <a:solidFill>
+                  <a:schemeClr val="tx1"/>
+                </a:solidFill>
+              </a:rPr>
+              <a:t>Dashboard</a:t>
+            </a:r>
+            <a:endParaRPr lang="en-US" sz="1050" dirty="0"/>
+          </a:p>
+        </p:txBody>
+      </p:sp>
+      <p:sp>
+        <p:nvSpPr>
+          <p:cNvPr id="36" name="Text 33"/>
+          <p:cNvSpPr txBox="1"/>
+          <p:nvPr/>
+        </p:nvSpPr>
+        <p:spPr>
+          <a:xfrm>
+            <a:off x="8138160" y="4261104"/>
+            <a:ext cx="1645920" cy="457200"/>
+          </a:xfrm>
+          <a:prstGeom prst="roundRect">
+            <a:avLst>
+              <a:gd name="adj" fmla="val 16000"/>
+            </a:avLst>
+          </a:prstGeom>
+          <a:solidFill>
+            <a:schemeClr val="accent2"/>
+          </a:solidFill>
+          <a:ln w="12700">
+            <a:solidFill>
+              <a:schemeClr val="accent2"/>
+            </a:solidFill>
+          </a:ln>
+        </p:spPr>
+        <p:txBody>
+          <a:bodyPr wrap="square" lIns="25400" tIns="25400" rIns="25400" bIns="25400" rtlCol="0" anchor="ctr"/>
+          <a:lstStyle/>
+          <a:p>
+            <a:pPr algn="ctr" indent="0" marL="0">
+              <a:buNone/>
+            </a:pPr>
+            <a:r>
+              <a:rPr lang="en-US" sz="1050" dirty="0">
+                <a:solidFill>
+                  <a:schemeClr val="tx1"/>
+                </a:solidFill>
+              </a:rPr>
+              <a:t>Ledger and batch views</a:t>
+            </a:r>
+            <a:endParaRPr lang="en-US" sz="1050" dirty="0"/>
+          </a:p>
+        </p:txBody>
+      </p:sp>
+      <p:sp>
+        <p:nvSpPr>
+          <p:cNvPr id="37" name="Text 34"/>
+          <p:cNvSpPr txBox="1"/>
+          <p:nvPr/>
+        </p:nvSpPr>
+        <p:spPr>
+          <a:xfrm>
+            <a:off x="9875520" y="4261104"/>
+            <a:ext cx="1645920" cy="457200"/>
+          </a:xfrm>
+          <a:prstGeom prst="roundRect">
+            <a:avLst>
+              <a:gd name="adj" fmla="val 16000"/>
+            </a:avLst>
+          </a:prstGeom>
+          <a:solidFill>
+            <a:schemeClr val="accent2"/>
+          </a:solidFill>
+          <a:ln w="12700">
+            <a:solidFill>
+              <a:schemeClr val="accent2"/>
+            </a:solidFill>
+          </a:ln>
+        </p:spPr>
+        <p:txBody>
+          <a:bodyPr wrap="square" lIns="25400" tIns="25400" rIns="25400" bIns="25400" rtlCol="0" anchor="ctr"/>
+          <a:lstStyle/>
+          <a:p>
+            <a:pPr algn="ctr" indent="0" marL="0">
+              <a:buNone/>
+            </a:pPr>
+            <a:r>
+              <a:rPr lang="en-US" sz="1050" dirty="0">
+                <a:solidFill>
+                  <a:schemeClr val="tx1"/>
+                </a:solidFill>
+              </a:rPr>
+              <a:t>Configuration (edit jobs)</a:t>
+            </a:r>
+            <a:endParaRPr lang="en-US" sz="1050" dirty="0"/>
+          </a:p>
+        </p:txBody>
+      </p:sp>
+      <p:sp>
+        <p:nvSpPr>
+          <p:cNvPr id="38" name="Shape 35"/>
           <p:cNvSpPr/>
           <p:nvPr/>
         </p:nvSpPr>
         <p:spPr>
-          <a:xfrm>
-            <a:off x="9418320" y="3794760"/>
-            <a:ext cx="548640" cy="0"/>
+          <a:xfrm flipH="1">
+            <a:off x="7863840" y="4114800"/>
+            <a:ext cx="182880" cy="0"/>
           </a:xfrm>
           <a:prstGeom prst="line">
             <a:avLst/>
@@ -17134,7 +18672,7 @@
           <a:noFill/>
           <a:ln w="22225">
             <a:solidFill>
-              <a:schemeClr val="tx2"/>
+              <a:schemeClr val="accent2"/>
             </a:solidFill>
             <a:prstDash val="dash"/>
             <a:tailEnd type="triangle"/>
@@ -17143,14 +18681,14 @@
       </p:sp>
       <p:sp>
         <p:nvSpPr>
-          <p:cNvPr id="32" name="Text 29"/>
-          <p:cNvSpPr txBox="1"/>
-          <p:nvPr/>
-        </p:nvSpPr>
-        <p:spPr>
-          <a:xfrm>
-            <a:off x="9418320" y="3520440"/>
-            <a:ext cx="548640" cy="228600"/>
+          <p:cNvPr id="39" name="Text 36"/>
+          <p:cNvSpPr txBox="1"/>
+          <p:nvPr/>
+        </p:nvSpPr>
+        <p:spPr>
+          <a:xfrm>
+            <a:off x="7635240" y="4828032"/>
+            <a:ext cx="1554480" cy="228600"/>
           </a:xfrm>
           <a:prstGeom prst="rect">
             <a:avLst/>
@@ -17162,7 +18700,7 @@
           <a:bodyPr wrap="square" lIns="0" tIns="0" rIns="0" bIns="0" rtlCol="0" anchor="ctr"/>
           <a:lstStyle/>
           <a:p>
-            <a:pPr algn="ctr" indent="0" marL="0">
+            <a:pPr algn="l" indent="0" marL="0">
               <a:buNone/>
             </a:pPr>
             <a:r>
@@ -17171,7 +18709,7 @@
                   <a:schemeClr val="accent4"/>
                 </a:solidFill>
               </a:rPr>
-              <a:t>events</a:t>
+              <a:t>edit jobs (PUT, reload)</a:t>
             </a:r>
             <a:endParaRPr lang="en-US" sz="900" dirty="0"/>
           </a:p>
@@ -17179,13 +18717,13 @@
       </p:sp>
       <p:sp>
         <p:nvSpPr>
-          <p:cNvPr id="33" name="Shape 30"/>
+          <p:cNvPr id="40" name="Shape 37"/>
           <p:cNvSpPr/>
           <p:nvPr/>
         </p:nvSpPr>
         <p:spPr>
           <a:xfrm>
-            <a:off x="4251960" y="4892040"/>
+            <a:off x="2331720" y="4800600"/>
             <a:ext cx="0" cy="548640"/>
           </a:xfrm>
           <a:prstGeom prst="line">
@@ -17204,14 +18742,14 @@
       </p:sp>
       <p:sp>
         <p:nvSpPr>
-          <p:cNvPr id="34" name="Text 31"/>
-          <p:cNvSpPr txBox="1"/>
-          <p:nvPr/>
-        </p:nvSpPr>
-        <p:spPr>
-          <a:xfrm>
-            <a:off x="4343400" y="5029200"/>
-            <a:ext cx="731520" cy="228600"/>
+          <p:cNvPr id="41" name="Text 38"/>
+          <p:cNvSpPr txBox="1"/>
+          <p:nvPr/>
+        </p:nvSpPr>
+        <p:spPr>
+          <a:xfrm>
+            <a:off x="2423160" y="4919472"/>
+            <a:ext cx="914400" cy="228600"/>
           </a:xfrm>
           <a:prstGeom prst="rect">
             <a:avLst/>
@@ -17232,7 +18770,7 @@
                   <a:schemeClr val="accent4"/>
                 </a:solidFill>
               </a:rPr>
-              <a:t>JDBC</a:t>
+              <a:t>read / write</a:t>
             </a:r>
             <a:endParaRPr lang="en-US" sz="1000" dirty="0"/>
           </a:p>
@@ -17240,13 +18778,13 @@
       </p:sp>
       <p:sp>
         <p:nvSpPr>
-          <p:cNvPr id="35" name="Shape 32"/>
+          <p:cNvPr id="42" name="Shape 39"/>
           <p:cNvSpPr/>
           <p:nvPr/>
         </p:nvSpPr>
         <p:spPr>
           <a:xfrm>
-            <a:off x="7818120" y="4892040"/>
+            <a:off x="6080760" y="4800600"/>
             <a:ext cx="0" cy="548640"/>
           </a:xfrm>
           <a:prstGeom prst="line">
@@ -17265,14 +18803,14 @@
       </p:sp>
       <p:sp>
         <p:nvSpPr>
-          <p:cNvPr id="36" name="Text 33"/>
-          <p:cNvSpPr txBox="1"/>
-          <p:nvPr/>
-        </p:nvSpPr>
-        <p:spPr>
-          <a:xfrm>
-            <a:off x="7909560" y="5029200"/>
-            <a:ext cx="731520" cy="228600"/>
+          <p:cNvPr id="43" name="Text 40"/>
+          <p:cNvSpPr txBox="1"/>
+          <p:nvPr/>
+        </p:nvSpPr>
+        <p:spPr>
+          <a:xfrm>
+            <a:off x="6172200" y="4919472"/>
+            <a:ext cx="914400" cy="228600"/>
           </a:xfrm>
           <a:prstGeom prst="rect">
             <a:avLst/>
@@ -17293,7 +18831,7 @@
                   <a:schemeClr val="accent4"/>
                 </a:solidFill>
               </a:rPr>
-              <a:t>JDBC</a:t>
+              <a:t>read / write</a:t>
             </a:r>
             <a:endParaRPr lang="en-US" sz="1000" dirty="0"/>
           </a:p>
@@ -17301,18 +18839,78 @@
       </p:sp>
       <p:sp>
         <p:nvSpPr>
-          <p:cNvPr id="37" name="Text 34"/>
-          <p:cNvSpPr txBox="1"/>
-          <p:nvPr/>
-        </p:nvSpPr>
-        <p:spPr>
-          <a:xfrm>
-            <a:off x="2651760" y="5440680"/>
-            <a:ext cx="6766560" cy="822960"/>
+          <p:cNvPr id="44" name="Shape 41"/>
+          <p:cNvSpPr/>
+          <p:nvPr/>
+        </p:nvSpPr>
+        <p:spPr>
+          <a:xfrm>
+            <a:off x="9829800" y="4800600"/>
+            <a:ext cx="0" cy="548640"/>
+          </a:xfrm>
+          <a:prstGeom prst="line">
+            <a:avLst/>
+          </a:prstGeom>
+          <a:noFill/>
+          <a:ln w="22225">
+            <a:solidFill>
+              <a:schemeClr val="tx2"/>
+            </a:solidFill>
+            <a:prstDash val="dash"/>
+            <a:tailEnd type="triangle"/>
+          </a:ln>
+        </p:spPr>
+      </p:sp>
+      <p:sp>
+        <p:nvSpPr>
+          <p:cNvPr id="45" name="Text 42"/>
+          <p:cNvSpPr txBox="1"/>
+          <p:nvPr/>
+        </p:nvSpPr>
+        <p:spPr>
+          <a:xfrm>
+            <a:off x="9921240" y="4919472"/>
+            <a:ext cx="914400" cy="228600"/>
+          </a:xfrm>
+          <a:prstGeom prst="rect">
+            <a:avLst/>
+          </a:prstGeom>
+          <a:noFill/>
+          <a:ln/>
+        </p:spPr>
+        <p:txBody>
+          <a:bodyPr wrap="square" lIns="0" tIns="0" rIns="0" bIns="0" rtlCol="0" anchor="ctr"/>
+          <a:lstStyle/>
+          <a:p>
+            <a:pPr algn="l" indent="0" marL="0">
+              <a:buNone/>
+            </a:pPr>
+            <a:r>
+              <a:rPr lang="en-US" sz="1000" i="1" dirty="0">
+                <a:solidFill>
+                  <a:schemeClr val="accent4"/>
+                </a:solidFill>
+              </a:rPr>
+              <a:t>SELECT only</a:t>
+            </a:r>
+            <a:endParaRPr lang="en-US" sz="1000" dirty="0"/>
+          </a:p>
+        </p:txBody>
+      </p:sp>
+      <p:sp>
+        <p:nvSpPr>
+          <p:cNvPr id="46" name="Text 43"/>
+          <p:cNvSpPr txBox="1"/>
+          <p:nvPr/>
+        </p:nvSpPr>
+        <p:spPr>
+          <a:xfrm>
+            <a:off x="548640" y="5349240"/>
+            <a:ext cx="11064240" cy="640080"/>
           </a:xfrm>
           <a:prstGeom prst="roundRect">
             <a:avLst>
-              <a:gd name="adj" fmla="val 8889"/>
+              <a:gd name="adj" fmla="val 11429"/>
             </a:avLst>
           </a:prstGeom>
           <a:solidFill>
@@ -17354,6 +18952,42 @@
               <a:t>schema public: lending tables   |   schema batch: job config, error records, Spring Batch and Quartz tables</a:t>
             </a:r>
             <a:endParaRPr lang="en-US" sz="1200" dirty="0"/>
+          </a:p>
+        </p:txBody>
+      </p:sp>
+      <p:sp>
+        <p:nvSpPr>
+          <p:cNvPr id="47" name="Text 44"/>
+          <p:cNvSpPr txBox="1"/>
+          <p:nvPr/>
+        </p:nvSpPr>
+        <p:spPr>
+          <a:xfrm>
+            <a:off x="548640" y="6053328"/>
+            <a:ext cx="11064240" cy="320040"/>
+          </a:xfrm>
+          <a:prstGeom prst="rect">
+            <a:avLst/>
+          </a:prstGeom>
+          <a:noFill/>
+          <a:ln/>
+        </p:spPr>
+        <p:txBody>
+          <a:bodyPr wrap="square" lIns="0" tIns="0" rIns="0" bIns="0" rtlCol="0" anchor="t"/>
+          <a:lstStyle/>
+          <a:p>
+            <a:pPr indent="0" marL="0">
+              <a:buNone/>
+            </a:pPr>
+            <a:r>
+              <a:rPr lang="en-US" sz="1100" i="1" dirty="0">
+                <a:solidFill>
+                  <a:schemeClr val="accent4"/>
+                </a:solidFill>
+              </a:rPr>
+              <a:t>External and not deployed in the sandbox: core banking ledger (outbox push, logging stub) and Kafka (batch events). The admin console also proxies the statement PDF from lending-service.</a:t>
+            </a:r>
+            <a:endParaRPr lang="en-US" sz="1100" dirty="0"/>
           </a:p>
         </p:txBody>
       </p:sp>
@@ -17511,12 +19145,12 @@
         </p:nvSpPr>
         <p:spPr>
           <a:xfrm>
-            <a:off x="548640" y="1508760"/>
-            <a:ext cx="5943600" cy="1143000"/>
+            <a:off x="548640" y="1371600"/>
+            <a:ext cx="5943600" cy="914400"/>
           </a:xfrm>
           <a:prstGeom prst="roundRect">
             <a:avLst>
-              <a:gd name="adj" fmla="val 6400"/>
+              <a:gd name="adj" fmla="val 8000"/>
             </a:avLst>
           </a:prstGeom>
           <a:solidFill>
@@ -17549,8 +19183,8 @@
         </p:nvSpPr>
         <p:spPr>
           <a:xfrm>
-            <a:off x="731520" y="1600200"/>
-            <a:ext cx="5577840" cy="274320"/>
+            <a:off x="731520" y="1426464"/>
+            <a:ext cx="5577840" cy="256032"/>
           </a:xfrm>
           <a:prstGeom prst="rect">
             <a:avLst/>
@@ -17566,14 +19200,14 @@
               <a:buNone/>
             </a:pPr>
             <a:r>
-              <a:rPr lang="en-US" sz="1500" b="1" dirty="0">
+              <a:rPr lang="en-US" sz="1400" b="1" dirty="0">
                 <a:solidFill>
                   <a:schemeClr val="tx2"/>
                 </a:solidFill>
               </a:rPr>
               <a:t>lending-service</a:t>
             </a:r>
-            <a:endParaRPr lang="en-US" sz="1500" dirty="0"/>
+            <a:endParaRPr lang="en-US" sz="1400" dirty="0"/>
           </a:p>
         </p:txBody>
       </p:sp>
@@ -17585,8 +19219,8 @@
         </p:nvSpPr>
         <p:spPr>
           <a:xfrm>
-            <a:off x="731520" y="1892808"/>
-            <a:ext cx="5577840" cy="274320"/>
+            <a:off x="731520" y="1700784"/>
+            <a:ext cx="5577840" cy="237744"/>
           </a:xfrm>
           <a:prstGeom prst="rect">
             <a:avLst/>
@@ -17602,7 +19236,7 @@
               <a:buNone/>
             </a:pPr>
             <a:r>
-              <a:rPr lang="en-US" sz="1300" b="1" dirty="0">
+              <a:rPr lang="en-US" sz="1200" b="1" dirty="0">
                 <a:solidFill>
                   <a:schemeClr val="accent1"/>
                 </a:solidFill>
@@ -17612,7 +19246,7 @@
               </a:rPr>
               <a:t>https://lending-service-5tqm.onrender.com</a:t>
             </a:r>
-            <a:endParaRPr lang="en-US" sz="1300" dirty="0"/>
+            <a:endParaRPr lang="en-US" sz="1200" dirty="0"/>
           </a:p>
         </p:txBody>
       </p:sp>
@@ -17624,8 +19258,8 @@
         </p:nvSpPr>
         <p:spPr>
           <a:xfrm>
-            <a:off x="731520" y="2221992"/>
-            <a:ext cx="5577840" cy="384048"/>
+            <a:off x="731520" y="1956816"/>
+            <a:ext cx="5577840" cy="292608"/>
           </a:xfrm>
           <a:prstGeom prst="rect">
             <a:avLst/>
@@ -17641,14 +19275,14 @@
               <a:buNone/>
             </a:pPr>
             <a:r>
-              <a:rPr lang="en-US" sz="1100" dirty="0">
+              <a:rPr lang="en-US" sz="1000" dirty="0">
                 <a:solidFill>
                   <a:schemeClr val="tx1"/>
                 </a:solidFill>
               </a:rPr>
-              <a:t>Swagger UI: /swagger-ui/index.html   |   OpenAPI: /v3/api-docs</a:t>
-            </a:r>
-            <a:endParaRPr lang="en-US" sz="1100" dirty="0"/>
+              <a:t>Swagger UI: /swagger-ui.html   |   OpenAPI: /v3/api-docs</a:t>
+            </a:r>
+            <a:endParaRPr lang="en-US" sz="1000" dirty="0"/>
           </a:p>
         </p:txBody>
       </p:sp>
@@ -17660,12 +19294,12 @@
         </p:nvSpPr>
         <p:spPr>
           <a:xfrm>
-            <a:off x="548640" y="2788920"/>
-            <a:ext cx="5943600" cy="1143000"/>
+            <a:off x="548640" y="2377440"/>
+            <a:ext cx="5943600" cy="914400"/>
           </a:xfrm>
           <a:prstGeom prst="roundRect">
             <a:avLst>
-              <a:gd name="adj" fmla="val 6400"/>
+              <a:gd name="adj" fmla="val 8000"/>
             </a:avLst>
           </a:prstGeom>
           <a:solidFill>
@@ -17698,8 +19332,8 @@
         </p:nvSpPr>
         <p:spPr>
           <a:xfrm>
-            <a:off x="731520" y="2880360"/>
-            <a:ext cx="5577840" cy="274320"/>
+            <a:off x="731520" y="2432304"/>
+            <a:ext cx="5577840" cy="256032"/>
           </a:xfrm>
           <a:prstGeom prst="rect">
             <a:avLst/>
@@ -17715,14 +19349,14 @@
               <a:buNone/>
             </a:pPr>
             <a:r>
-              <a:rPr lang="en-US" sz="1500" b="1" dirty="0">
+              <a:rPr lang="en-US" sz="1400" b="1" dirty="0">
                 <a:solidFill>
                   <a:schemeClr val="tx2"/>
                 </a:solidFill>
               </a:rPr>
               <a:t>lending-batch-service</a:t>
             </a:r>
-            <a:endParaRPr lang="en-US" sz="1500" dirty="0"/>
+            <a:endParaRPr lang="en-US" sz="1400" dirty="0"/>
           </a:p>
         </p:txBody>
       </p:sp>
@@ -17734,8 +19368,8 @@
         </p:nvSpPr>
         <p:spPr>
           <a:xfrm>
-            <a:off x="731520" y="3172968"/>
-            <a:ext cx="5577840" cy="274320"/>
+            <a:off x="731520" y="2706624"/>
+            <a:ext cx="5577840" cy="237744"/>
           </a:xfrm>
           <a:prstGeom prst="rect">
             <a:avLst/>
@@ -17751,7 +19385,7 @@
               <a:buNone/>
             </a:pPr>
             <a:r>
-              <a:rPr lang="en-US" sz="1300" b="1" dirty="0">
+              <a:rPr lang="en-US" sz="1200" b="1" dirty="0">
                 <a:solidFill>
                   <a:schemeClr val="accent4"/>
                 </a:solidFill>
@@ -17761,7 +19395,7 @@
               </a:rPr>
               <a:t>URL assigned by Render (see the dashboard)</a:t>
             </a:r>
-            <a:endParaRPr lang="en-US" sz="1300" dirty="0"/>
+            <a:endParaRPr lang="en-US" sz="1200" dirty="0"/>
           </a:p>
         </p:txBody>
       </p:sp>
@@ -17773,8 +19407,8 @@
         </p:nvSpPr>
         <p:spPr>
           <a:xfrm>
-            <a:off x="731520" y="3502152"/>
-            <a:ext cx="5577840" cy="384048"/>
+            <a:off x="731520" y="2962656"/>
+            <a:ext cx="5577840" cy="292608"/>
           </a:xfrm>
           <a:prstGeom prst="rect">
             <a:avLst/>
@@ -17790,14 +19424,14 @@
               <a:buNone/>
             </a:pPr>
             <a:r>
-              <a:rPr lang="en-US" sz="1100" dirty="0">
+              <a:rPr lang="en-US" sz="1000" dirty="0">
                 <a:solidFill>
                   <a:schemeClr val="tx1"/>
                 </a:solidFill>
               </a:rPr>
-              <a:t>Admin API: /api/v1/batch-admin/**  |  user batch-admin, password in BATCH_ADMIN_PASSWORD  |  /actuator/health</a:t>
-            </a:r>
-            <a:endParaRPr lang="en-US" sz="1100" dirty="0"/>
+              <a:t>Admin API /api/v1/batch-admin/**  |  user batch-admin, password BATCH_ADMIN_PASSWORD</a:t>
+            </a:r>
+            <a:endParaRPr lang="en-US" sz="1000" dirty="0"/>
           </a:p>
         </p:txBody>
       </p:sp>
@@ -17809,12 +19443,161 @@
         </p:nvSpPr>
         <p:spPr>
           <a:xfrm>
-            <a:off x="548640" y="4069080"/>
-            <a:ext cx="5943600" cy="1143000"/>
+            <a:off x="548640" y="3383280"/>
+            <a:ext cx="5943600" cy="914400"/>
           </a:xfrm>
           <a:prstGeom prst="roundRect">
             <a:avLst>
-              <a:gd name="adj" fmla="val 6400"/>
+              <a:gd name="adj" fmla="val 8000"/>
+            </a:avLst>
+          </a:prstGeom>
+          <a:solidFill>
+            <a:schemeClr val="accent2">
+              <a:alpha val="10000"/>
+            </a:schemeClr>
+          </a:solidFill>
+          <a:ln w="15875">
+            <a:solidFill>
+              <a:schemeClr val="accent2"/>
+            </a:solidFill>
+          </a:ln>
+        </p:spPr>
+        <p:txBody>
+          <a:bodyPr wrap="square" lIns="50800" tIns="50800" rIns="50800" bIns="50800" rtlCol="0" anchor="ctr"/>
+          <a:lstStyle/>
+          <a:p>
+            <a:pPr algn="ctr" indent="0" marL="0">
+              <a:buNone/>
+            </a:pPr>
+            <a:endParaRPr lang="en-US" sz="1200" dirty="0"/>
+          </a:p>
+        </p:txBody>
+      </p:sp>
+      <p:sp>
+        <p:nvSpPr>
+          <p:cNvPr id="14" name="Text 11"/>
+          <p:cNvSpPr txBox="1"/>
+          <p:nvPr/>
+        </p:nvSpPr>
+        <p:spPr>
+          <a:xfrm>
+            <a:off x="731520" y="3438144"/>
+            <a:ext cx="5577840" cy="256032"/>
+          </a:xfrm>
+          <a:prstGeom prst="rect">
+            <a:avLst/>
+          </a:prstGeom>
+          <a:noFill/>
+          <a:ln/>
+        </p:spPr>
+        <p:txBody>
+          <a:bodyPr wrap="square" lIns="0" tIns="0" rIns="0" bIns="0" rtlCol="0" anchor="t"/>
+          <a:lstStyle/>
+          <a:p>
+            <a:pPr indent="0" marL="0">
+              <a:buNone/>
+            </a:pPr>
+            <a:r>
+              <a:rPr lang="en-US" sz="1400" b="1" dirty="0">
+                <a:solidFill>
+                  <a:schemeClr val="tx2"/>
+                </a:solidFill>
+              </a:rPr>
+              <a:t>lending-admin-service  (admin portal)</a:t>
+            </a:r>
+            <a:endParaRPr lang="en-US" sz="1400" dirty="0"/>
+          </a:p>
+        </p:txBody>
+      </p:sp>
+      <p:sp>
+        <p:nvSpPr>
+          <p:cNvPr id="15" name="Text 12"/>
+          <p:cNvSpPr txBox="1"/>
+          <p:nvPr/>
+        </p:nvSpPr>
+        <p:spPr>
+          <a:xfrm>
+            <a:off x="731520" y="3712464"/>
+            <a:ext cx="5577840" cy="237744"/>
+          </a:xfrm>
+          <a:prstGeom prst="rect">
+            <a:avLst/>
+          </a:prstGeom>
+          <a:noFill/>
+          <a:ln/>
+        </p:spPr>
+        <p:txBody>
+          <a:bodyPr wrap="square" lIns="0" tIns="0" rIns="0" bIns="0" rtlCol="0" anchor="t"/>
+          <a:lstStyle/>
+          <a:p>
+            <a:pPr indent="0" marL="0">
+              <a:buNone/>
+            </a:pPr>
+            <a:r>
+              <a:rPr lang="en-US" sz="1200" b="1" dirty="0">
+                <a:solidFill>
+                  <a:schemeClr val="tx2"/>
+                </a:solidFill>
+                <a:latin typeface="Courier New" pitchFamily="34" charset="0"/>
+                <a:ea typeface="Courier New" pitchFamily="34" charset="-122"/>
+                <a:cs typeface="Courier New" pitchFamily="34" charset="-120"/>
+              </a:rPr>
+              <a:t>https://lending-admin-service-&lt;suffix&gt;.onrender.com</a:t>
+            </a:r>
+            <a:endParaRPr lang="en-US" sz="1200" dirty="0"/>
+          </a:p>
+        </p:txBody>
+      </p:sp>
+      <p:sp>
+        <p:nvSpPr>
+          <p:cNvPr id="16" name="Text 13"/>
+          <p:cNvSpPr txBox="1"/>
+          <p:nvPr/>
+        </p:nvSpPr>
+        <p:spPr>
+          <a:xfrm>
+            <a:off x="731520" y="3968496"/>
+            <a:ext cx="5577840" cy="292608"/>
+          </a:xfrm>
+          <a:prstGeom prst="rect">
+            <a:avLst/>
+          </a:prstGeom>
+          <a:noFill/>
+          <a:ln/>
+        </p:spPr>
+        <p:txBody>
+          <a:bodyPr wrap="square" lIns="0" tIns="0" rIns="0" bIns="0" rtlCol="0" anchor="t"/>
+          <a:lstStyle/>
+          <a:p>
+            <a:pPr indent="0" marL="0">
+              <a:buNone/>
+            </a:pPr>
+            <a:r>
+              <a:rPr lang="en-US" sz="1000" dirty="0">
+                <a:solidFill>
+                  <a:schemeClr val="tx1"/>
+                </a:solidFill>
+              </a:rPr>
+              <a:t>Login admin / ADMIN_PASSWORD (Render &gt; Environment)  |  Swagger: /swagger-ui.html</a:t>
+            </a:r>
+            <a:endParaRPr lang="en-US" sz="1000" dirty="0"/>
+          </a:p>
+        </p:txBody>
+      </p:sp>
+      <p:sp>
+        <p:nvSpPr>
+          <p:cNvPr id="17" name="Text 14"/>
+          <p:cNvSpPr txBox="1"/>
+          <p:nvPr/>
+        </p:nvSpPr>
+        <p:spPr>
+          <a:xfrm>
+            <a:off x="548640" y="4389120"/>
+            <a:ext cx="5943600" cy="914400"/>
+          </a:xfrm>
+          <a:prstGeom prst="roundRect">
+            <a:avLst>
+              <a:gd name="adj" fmla="val 8000"/>
             </a:avLst>
           </a:prstGeom>
           <a:solidFill>
@@ -17841,14 +19624,14 @@
       </p:sp>
       <p:sp>
         <p:nvSpPr>
-          <p:cNvPr id="14" name="Text 11"/>
-          <p:cNvSpPr txBox="1"/>
-          <p:nvPr/>
-        </p:nvSpPr>
-        <p:spPr>
-          <a:xfrm>
-            <a:off x="731520" y="4160520"/>
-            <a:ext cx="5577840" cy="274320"/>
+          <p:cNvPr id="18" name="Text 15"/>
+          <p:cNvSpPr txBox="1"/>
+          <p:nvPr/>
+        </p:nvSpPr>
+        <p:spPr>
+          <a:xfrm>
+            <a:off x="731520" y="4443984"/>
+            <a:ext cx="5577840" cy="256032"/>
           </a:xfrm>
           <a:prstGeom prst="rect">
             <a:avLst/>
@@ -17864,27 +19647,27 @@
               <a:buNone/>
             </a:pPr>
             <a:r>
-              <a:rPr lang="en-US" sz="1500" b="1" dirty="0">
+              <a:rPr lang="en-US" sz="1400" b="1" dirty="0">
                 <a:solidFill>
                   <a:schemeClr val="tx2"/>
                 </a:solidFill>
               </a:rPr>
               <a:t>lending-db  (PostgreSQL 16)</a:t>
             </a:r>
-            <a:endParaRPr lang="en-US" sz="1500" dirty="0"/>
-          </a:p>
-        </p:txBody>
-      </p:sp>
-      <p:sp>
-        <p:nvSpPr>
-          <p:cNvPr id="15" name="Text 12"/>
-          <p:cNvSpPr txBox="1"/>
-          <p:nvPr/>
-        </p:nvSpPr>
-        <p:spPr>
-          <a:xfrm>
-            <a:off x="731520" y="4453128"/>
-            <a:ext cx="5577840" cy="274320"/>
+            <a:endParaRPr lang="en-US" sz="1400" dirty="0"/>
+          </a:p>
+        </p:txBody>
+      </p:sp>
+      <p:sp>
+        <p:nvSpPr>
+          <p:cNvPr id="19" name="Text 16"/>
+          <p:cNvSpPr txBox="1"/>
+          <p:nvPr/>
+        </p:nvSpPr>
+        <p:spPr>
+          <a:xfrm>
+            <a:off x="731520" y="4718304"/>
+            <a:ext cx="5577840" cy="237744"/>
           </a:xfrm>
           <a:prstGeom prst="rect">
             <a:avLst/>
@@ -17900,7 +19683,7 @@
               <a:buNone/>
             </a:pPr>
             <a:r>
-              <a:rPr lang="en-US" sz="1300" b="1" dirty="0">
+              <a:rPr lang="en-US" sz="1200" b="1" dirty="0">
                 <a:solidFill>
                   <a:schemeClr val="tx1"/>
                 </a:solidFill>
@@ -17908,22 +19691,22 @@
                 <a:ea typeface="Courier New" pitchFamily="34" charset="-122"/>
                 <a:cs typeface="Courier New" pitchFamily="34" charset="-120"/>
               </a:rPr>
-              <a:t>Internal connection only, shared by both services</a:t>
-            </a:r>
-            <a:endParaRPr lang="en-US" sz="1300" dirty="0"/>
-          </a:p>
-        </p:txBody>
-      </p:sp>
-      <p:sp>
-        <p:nvSpPr>
-          <p:cNvPr id="16" name="Text 13"/>
-          <p:cNvSpPr txBox="1"/>
-          <p:nvPr/>
-        </p:nvSpPr>
-        <p:spPr>
-          <a:xfrm>
-            <a:off x="731520" y="4782312"/>
-            <a:ext cx="5577840" cy="384048"/>
+              <a:t>Internal connection only, shared by all three services</a:t>
+            </a:r>
+            <a:endParaRPr lang="en-US" sz="1200" dirty="0"/>
+          </a:p>
+        </p:txBody>
+      </p:sp>
+      <p:sp>
+        <p:nvSpPr>
+          <p:cNvPr id="20" name="Text 17"/>
+          <p:cNvSpPr txBox="1"/>
+          <p:nvPr/>
+        </p:nvSpPr>
+        <p:spPr>
+          <a:xfrm>
+            <a:off x="731520" y="4974336"/>
+            <a:ext cx="5577840" cy="292608"/>
           </a:xfrm>
           <a:prstGeom prst="rect">
             <a:avLst/>
@@ -17939,26 +19722,26 @@
               <a:buNone/>
             </a:pPr>
             <a:r>
-              <a:rPr lang="en-US" sz="1100" dirty="0">
+              <a:rPr lang="en-US" sz="1000" dirty="0">
                 <a:solidFill>
                   <a:schemeClr val="tx1"/>
                 </a:solidFill>
               </a:rPr>
               <a:t>Free plan: the database is deleted after 30 days</a:t>
             </a:r>
-            <a:endParaRPr lang="en-US" sz="1100" dirty="0"/>
-          </a:p>
-        </p:txBody>
-      </p:sp>
-      <p:sp>
-        <p:nvSpPr>
-          <p:cNvPr id="17" name="Text 14"/>
-          <p:cNvSpPr txBox="1"/>
-          <p:nvPr/>
-        </p:nvSpPr>
-        <p:spPr>
-          <a:xfrm>
-            <a:off x="6858000" y="1463040"/>
+            <a:endParaRPr lang="en-US" sz="1000" dirty="0"/>
+          </a:p>
+        </p:txBody>
+      </p:sp>
+      <p:sp>
+        <p:nvSpPr>
+          <p:cNvPr id="21" name="Text 18"/>
+          <p:cNvSpPr txBox="1"/>
+          <p:nvPr/>
+        </p:nvSpPr>
+        <p:spPr>
+          <a:xfrm>
+            <a:off x="6858000" y="1371600"/>
             <a:ext cx="4754880" cy="320040"/>
           </a:xfrm>
           <a:prstGeom prst="rect">
@@ -17980,7 +19763,7 @@
                   <a:schemeClr val="tx2"/>
                 </a:solidFill>
               </a:rPr>
-              <a:t>Try it in five steps</a:t>
+              <a:t>Try it in six steps</a:t>
             </a:r>
             <a:endParaRPr lang="en-US" sz="1800" dirty="0"/>
           </a:p>
@@ -17988,14 +19771,14 @@
       </p:sp>
       <p:sp>
         <p:nvSpPr>
-          <p:cNvPr id="18" name="Text 15"/>
-          <p:cNvSpPr txBox="1"/>
-          <p:nvPr/>
-        </p:nvSpPr>
-        <p:spPr>
-          <a:xfrm>
-            <a:off x="6858000" y="1965960"/>
-            <a:ext cx="457200" cy="457200"/>
+          <p:cNvPr id="22" name="Text 19"/>
+          <p:cNvSpPr txBox="1"/>
+          <p:nvPr/>
+        </p:nvSpPr>
+        <p:spPr>
+          <a:xfrm>
+            <a:off x="6858000" y="1837944"/>
+            <a:ext cx="411480" cy="411480"/>
           </a:xfrm>
           <a:prstGeom prst="ellipse">
             <a:avLst/>
@@ -18026,14 +19809,14 @@
       </p:sp>
       <p:sp>
         <p:nvSpPr>
-          <p:cNvPr id="19" name="Text 16"/>
-          <p:cNvSpPr txBox="1"/>
-          <p:nvPr/>
-        </p:nvSpPr>
-        <p:spPr>
-          <a:xfrm>
-            <a:off x="7498080" y="1874520"/>
-            <a:ext cx="4114800" cy="640080"/>
+          <p:cNvPr id="23" name="Text 20"/>
+          <p:cNvSpPr txBox="1"/>
+          <p:nvPr/>
+        </p:nvSpPr>
+        <p:spPr>
+          <a:xfrm>
+            <a:off x="7452360" y="1783080"/>
+            <a:ext cx="4160520" cy="566928"/>
           </a:xfrm>
           <a:prstGeom prst="rect">
             <a:avLst/>
@@ -18062,14 +19845,14 @@
       </p:sp>
       <p:sp>
         <p:nvSpPr>
-          <p:cNvPr id="20" name="Text 17"/>
-          <p:cNvSpPr txBox="1"/>
-          <p:nvPr/>
-        </p:nvSpPr>
-        <p:spPr>
-          <a:xfrm>
-            <a:off x="6858000" y="2697480"/>
-            <a:ext cx="457200" cy="457200"/>
+          <p:cNvPr id="24" name="Text 21"/>
+          <p:cNvSpPr txBox="1"/>
+          <p:nvPr/>
+        </p:nvSpPr>
+        <p:spPr>
+          <a:xfrm>
+            <a:off x="6858000" y="2459736"/>
+            <a:ext cx="411480" cy="411480"/>
           </a:xfrm>
           <a:prstGeom prst="ellipse">
             <a:avLst/>
@@ -18100,14 +19883,14 @@
       </p:sp>
       <p:sp>
         <p:nvSpPr>
-          <p:cNvPr id="21" name="Text 18"/>
-          <p:cNvSpPr txBox="1"/>
-          <p:nvPr/>
-        </p:nvSpPr>
-        <p:spPr>
-          <a:xfrm>
-            <a:off x="7498080" y="2606040"/>
-            <a:ext cx="4114800" cy="640080"/>
+          <p:cNvPr id="25" name="Text 22"/>
+          <p:cNvSpPr txBox="1"/>
+          <p:nvPr/>
+        </p:nvSpPr>
+        <p:spPr>
+          <a:xfrm>
+            <a:off x="7452360" y="2404872"/>
+            <a:ext cx="4160520" cy="566928"/>
           </a:xfrm>
           <a:prstGeom prst="rect">
             <a:avLst/>
@@ -18136,14 +19919,14 @@
       </p:sp>
       <p:sp>
         <p:nvSpPr>
-          <p:cNvPr id="22" name="Text 19"/>
-          <p:cNvSpPr txBox="1"/>
-          <p:nvPr/>
-        </p:nvSpPr>
-        <p:spPr>
-          <a:xfrm>
-            <a:off x="6858000" y="3429000"/>
-            <a:ext cx="457200" cy="457200"/>
+          <p:cNvPr id="26" name="Text 23"/>
+          <p:cNvSpPr txBox="1"/>
+          <p:nvPr/>
+        </p:nvSpPr>
+        <p:spPr>
+          <a:xfrm>
+            <a:off x="6858000" y="3081528"/>
+            <a:ext cx="411480" cy="411480"/>
           </a:xfrm>
           <a:prstGeom prst="ellipse">
             <a:avLst/>
@@ -18174,14 +19957,14 @@
       </p:sp>
       <p:sp>
         <p:nvSpPr>
-          <p:cNvPr id="23" name="Text 20"/>
-          <p:cNvSpPr txBox="1"/>
-          <p:nvPr/>
-        </p:nvSpPr>
-        <p:spPr>
-          <a:xfrm>
-            <a:off x="7498080" y="3337560"/>
-            <a:ext cx="4114800" cy="640080"/>
+          <p:cNvPr id="27" name="Text 24"/>
+          <p:cNvSpPr txBox="1"/>
+          <p:nvPr/>
+        </p:nvSpPr>
+        <p:spPr>
+          <a:xfrm>
+            <a:off x="7452360" y="3026664"/>
+            <a:ext cx="4160520" cy="566928"/>
           </a:xfrm>
           <a:prstGeom prst="rect">
             <a:avLst/>
@@ -18210,14 +19993,14 @@
       </p:sp>
       <p:sp>
         <p:nvSpPr>
-          <p:cNvPr id="24" name="Text 21"/>
-          <p:cNvSpPr txBox="1"/>
-          <p:nvPr/>
-        </p:nvSpPr>
-        <p:spPr>
-          <a:xfrm>
-            <a:off x="6858000" y="4160520"/>
-            <a:ext cx="457200" cy="457200"/>
+          <p:cNvPr id="28" name="Text 25"/>
+          <p:cNvSpPr txBox="1"/>
+          <p:nvPr/>
+        </p:nvSpPr>
+        <p:spPr>
+          <a:xfrm>
+            <a:off x="6858000" y="3703320"/>
+            <a:ext cx="411480" cy="411480"/>
           </a:xfrm>
           <a:prstGeom prst="ellipse">
             <a:avLst/>
@@ -18248,14 +20031,14 @@
       </p:sp>
       <p:sp>
         <p:nvSpPr>
-          <p:cNvPr id="25" name="Text 22"/>
-          <p:cNvSpPr txBox="1"/>
-          <p:nvPr/>
-        </p:nvSpPr>
-        <p:spPr>
-          <a:xfrm>
-            <a:off x="7498080" y="4069080"/>
-            <a:ext cx="4114800" cy="640080"/>
+          <p:cNvPr id="29" name="Text 26"/>
+          <p:cNvSpPr txBox="1"/>
+          <p:nvPr/>
+        </p:nvSpPr>
+        <p:spPr>
+          <a:xfrm>
+            <a:off x="7452360" y="3648456"/>
+            <a:ext cx="4160520" cy="566928"/>
           </a:xfrm>
           <a:prstGeom prst="rect">
             <a:avLst/>
@@ -18284,14 +20067,14 @@
       </p:sp>
       <p:sp>
         <p:nvSpPr>
-          <p:cNvPr id="26" name="Text 23"/>
-          <p:cNvSpPr txBox="1"/>
-          <p:nvPr/>
-        </p:nvSpPr>
-        <p:spPr>
-          <a:xfrm>
-            <a:off x="6858000" y="4892040"/>
-            <a:ext cx="457200" cy="457200"/>
+          <p:cNvPr id="30" name="Text 27"/>
+          <p:cNvSpPr txBox="1"/>
+          <p:nvPr/>
+        </p:nvSpPr>
+        <p:spPr>
+          <a:xfrm>
+            <a:off x="6858000" y="4325112"/>
+            <a:ext cx="411480" cy="411480"/>
           </a:xfrm>
           <a:prstGeom prst="ellipse">
             <a:avLst/>
@@ -18322,14 +20105,14 @@
       </p:sp>
       <p:sp>
         <p:nvSpPr>
-          <p:cNvPr id="27" name="Text 24"/>
-          <p:cNvSpPr txBox="1"/>
-          <p:nvPr/>
-        </p:nvSpPr>
-        <p:spPr>
-          <a:xfrm>
-            <a:off x="7498080" y="4800600"/>
-            <a:ext cx="4114800" cy="640080"/>
+          <p:cNvPr id="31" name="Text 28"/>
+          <p:cNvSpPr txBox="1"/>
+          <p:nvPr/>
+        </p:nvSpPr>
+        <p:spPr>
+          <a:xfrm>
+            <a:off x="7452360" y="4270248"/>
+            <a:ext cx="4160520" cy="566928"/>
           </a:xfrm>
           <a:prstGeom prst="rect">
             <a:avLst/>
@@ -18358,13 +20141,87 @@
       </p:sp>
       <p:sp>
         <p:nvSpPr>
-          <p:cNvPr id="28" name="Text 25"/>
-          <p:cNvSpPr txBox="1"/>
-          <p:nvPr/>
-        </p:nvSpPr>
-        <p:spPr>
-          <a:xfrm>
-            <a:off x="548640" y="5486400"/>
+          <p:cNvPr id="32" name="Text 29"/>
+          <p:cNvSpPr txBox="1"/>
+          <p:nvPr/>
+        </p:nvSpPr>
+        <p:spPr>
+          <a:xfrm>
+            <a:off x="6858000" y="4946904"/>
+            <a:ext cx="411480" cy="411480"/>
+          </a:xfrm>
+          <a:prstGeom prst="ellipse">
+            <a:avLst/>
+          </a:prstGeom>
+          <a:solidFill>
+            <a:schemeClr val="accent2"/>
+          </a:solidFill>
+          <a:ln/>
+        </p:spPr>
+        <p:txBody>
+          <a:bodyPr wrap="square" lIns="0" tIns="0" rIns="0" bIns="0" rtlCol="0" anchor="ctr"/>
+          <a:lstStyle/>
+          <a:p>
+            <a:pPr algn="ctr" indent="0" marL="0">
+              <a:buNone/>
+            </a:pPr>
+            <a:r>
+              <a:rPr lang="en-US" sz="1400" b="1" dirty="0">
+                <a:solidFill>
+                  <a:schemeClr val="tx1"/>
+                </a:solidFill>
+              </a:rPr>
+              <a:t>6</a:t>
+            </a:r>
+            <a:endParaRPr lang="en-US" sz="1400" dirty="0"/>
+          </a:p>
+        </p:txBody>
+      </p:sp>
+      <p:sp>
+        <p:nvSpPr>
+          <p:cNvPr id="33" name="Text 30"/>
+          <p:cNvSpPr txBox="1"/>
+          <p:nvPr/>
+        </p:nvSpPr>
+        <p:spPr>
+          <a:xfrm>
+            <a:off x="7452360" y="4892040"/>
+            <a:ext cx="4160520" cy="566928"/>
+          </a:xfrm>
+          <a:prstGeom prst="rect">
+            <a:avLst/>
+          </a:prstGeom>
+          <a:noFill/>
+          <a:ln/>
+        </p:spPr>
+        <p:txBody>
+          <a:bodyPr wrap="square" lIns="0" tIns="0" rIns="0" bIns="0" rtlCol="0" anchor="ctr"/>
+          <a:lstStyle/>
+          <a:p>
+            <a:pPr indent="0" marL="0">
+              <a:buNone/>
+            </a:pPr>
+            <a:r>
+              <a:rPr lang="en-US" sz="1300" dirty="0">
+                <a:solidFill>
+                  <a:schemeClr val="tx1"/>
+                </a:solidFill>
+              </a:rPr>
+              <a:t>Open the admin portal, sign in, and inspect the accounts and Configuration</a:t>
+            </a:r>
+            <a:endParaRPr lang="en-US" sz="1300" dirty="0"/>
+          </a:p>
+        </p:txBody>
+      </p:sp>
+      <p:sp>
+        <p:nvSpPr>
+          <p:cNvPr id="34" name="Text 31"/>
+          <p:cNvSpPr txBox="1"/>
+          <p:nvPr/>
+        </p:nvSpPr>
+        <p:spPr>
+          <a:xfrm>
+            <a:off x="548640" y="5532120"/>
             <a:ext cx="11064240" cy="777240"/>
           </a:xfrm>
           <a:prstGeom prst="roundRect">

</xml_diff>